<commit_message>
fix: independent clean app, styled slides with motion artifacts, modular JS videos, formal 1-page PDF, no em-dashes
</commit_message>
<xml_diff>
--- a/ReversoYa_Presentacion_10Minutos.pptx
+++ b/ReversoYa_Presentacion_10Minutos.pptx
@@ -511,7 +511,7 @@
           <a:lstStyle/>
           <a:p>
             <a:r>
-              <a:t>Buenas tardes. ¿A cuántos de ustedes les ha pasado que compran algo por internet o Instagram, pagan por PSE o Nequi, el producto nunca llega o llega roto, y la tienda les responde: ‘no devolvemos plata, solo damos un bono’? Para resolver ese abuso cotidiano en Colombia creamos ReversoYa. Nuestro símbolo une un escudo azul naval de certeza jurídica con una flecha circular verde esmeralda que representa el retorno del dinero a la cuenta del ciudadano. Y nuestro eslogan resume toda nuestra tesis jurídica: ‘Tu plata de vuelta por ley, sin rogarle al comercio’.</a:t>
+              <a:t>Buenas tardes. ¿A cuántos de ustedes les ha pasado que compran algo por internet o redes sociales, pagan por PSE o Nequi, el producto nunca llega o llega roto, y la tienda responde: ‘no devolvemos plata, solo damos un bono’? Para resolver ese problema cotidiano en Colombia creamos ReversoYa. Nuestro símbolo une un escudo azul naval de certeza jurídica con una flecha circular verde esmeralda que representa el retorno íntegro del dinero a la cuenta del ciudadano. Nuestro eslogan resume nuestra tesis: ‘Tu plata de vuelta por ley, sin rogarle al comercio’.</a:t>
             </a:r>
           </a:p>
         </p:txBody>
@@ -581,7 +581,7 @@
           <a:lstStyle/>
           <a:p>
             <a:r>
-              <a:t>En conclusión: con ReversoYa demostramos que cuando el artículo 78 de la Constitución y la Ley 1480 se traducen en cuatro pantallas claras, el abuso comercial deja de ser rentable. Muchas gracias.</a:t>
+              <a:t>En conclusión: con ReversoYa demostramos que cuando el artículo 78 de la Constitución y la Ley 1480 se traducen en una herramienta clara de tres minutos, el abuso comercial deja de ser rentable. Muchas gracias.</a:t>
             </a:r>
           </a:p>
         </p:txBody>
@@ -651,7 +651,7 @@
           <a:lstStyle/>
           <a:p>
             <a:r>
-              <a:t>Veamos la dimensión del problema en Colombia. Según la Cámara Colombiana de Comercio Electrónico, en el país se realizan más de 370 millones de transacciones digitales al año. Sin embargo, cuando una compra de $200.000 o $680.000 pesos falla, el consumidor choca contra dos muros: cuatro excusas ilegales del comercio y el alto costo de contratar un abogado particular.</a:t>
+              <a:t>Veamos la dimensión del problema en el país. Según la Cámara Colombiana de Comercio Electrónico, en Colombia se realizan más de 370 millones de transacciones digitales al año. Sin embargo, cuando una compra falla, el consumidor choca contra cuatro excusas improcedentes del comercio y el alto costo de contratar un abogado particular.</a:t>
             </a:r>
           </a:p>
         </p:txBody>
@@ -721,7 +721,7 @@
           <a:lstStyle/>
           <a:p>
             <a:r>
-              <a:t>Colombia tiene una legislación muy potente anclada en los artículos 78 y 229 de la Constitución, la Ley 1480 de 2011 y el Decreto 587 de 2016: si notificas dentro de los 5 días hábiles siguientes al incumplimiento, tu propio banco está obligado por ley a reversar el 100% del dinero en máximo 15 días hábiles.</a:t>
+              <a:t>Colombia cuenta con una legislación robusta anclada en los artículos 78 y 229 de la Constitución, la Ley 1480 de 2011 y el Decreto 587 de 2016: si notificas dentro de los 5 días hábiles siguientes al incumplimiento, tu propio banco está obligado a reversar el 100% del dinero en máximo 15 días hábiles.</a:t>
             </a:r>
           </a:p>
         </p:txBody>
@@ -791,7 +791,7 @@
           <a:lstStyle/>
           <a:p>
             <a:r>
-              <a:t>Nuestro público principal son los compradores digitales y viajeros en Colombia entre los 18 y 55 años que usan PSE, Nequi, Daviplata o tarjetas, además de pasarelas y comercios en nuestro canal B2B.</a:t>
+              <a:t>En el segmento B2C nos dirigimos a compradores digitales y viajeros en Colombia entre los 18 y 55 años que usan PSE, Nequi, Daviplata o tarjetas; y en el segmento B2B, a pasarelas y comercios formales.</a:t>
             </a:r>
           </a:p>
         </p:txBody>
@@ -861,7 +861,7 @@
           <a:lstStyle/>
           <a:p>
             <a:r>
-              <a:t>Inspirados en Symplifica, diseñamos en Stitch un flujo de 4 pantallas sin jerga legal. En la Pantalla 1 el usuario calcula su plazo de 5 días hábiles y en la Pantalla 2 escanea el chat de WhatsApp y sella sus pruebas con SHA-256.</a:t>
+              <a:t>En la Pantalla 1 el usuario valida cuántos de los 5 días hábiles le quedan, y en la Pantalla 2 analiza la respuesta del vendedor en WhatsApp y certifica los soportes con huella SHA-256 conforme a la Ley 527 de 1999.</a:t>
             </a:r>
           </a:p>
         </p:txBody>
@@ -931,7 +931,7 @@
           <a:lstStyle/>
           <a:p>
             <a:r>
-              <a:t>En la Pantalla 3 ReversoYa genera los 3 oficios con todos los requisitos formales del Decreto 587 para que el banco no pueda rechazarlos, y en la Pantalla 4 activa el reloj de 15 días hábiles.</a:t>
+              <a:t>En la Pantalla 3 ReversoYa genera los 3 documentos formales con todos los requisitos del Decreto 587 para que el banco no pueda rechazarlos, y en la Pantalla 4 controla los 15 días hábiles hasta el abono efectivo.</a:t>
             </a:r>
           </a:p>
         </p:txBody>
@@ -1001,7 +1001,7 @@
           <a:lstStyle/>
           <a:p>
             <a:r>
-              <a:t>En el módulo aeronáutico bajo el RAC 3 de la Aerocivil, si sobrevenden un tiquete de $540.000 pesos, ReversoYa calcula automáticamente $702.000 pesos exigibles en efectivo.</a:t>
+              <a:t>En el módulo aeronáutico bajo el RAC 3 de la Aerocivil, si sobrevenden un tiquete de $540.000 pesos, ReversoYa calcula automáticamente $702.000 pesos exigibles en efectivo (100% del pasaje más 30% de compensación).</a:t>
             </a:r>
           </a:p>
         </p:txBody>
@@ -1071,7 +1071,7 @@
           <a:lstStyle/>
           <a:p>
             <a:r>
-              <a:t>Investigamos qué existe en Colombia: ni SIC Facilita ni las apps de peticiones simples accionan la obligación del banco emisor. ReversoYa no le ruega al vendedor: activa la orden bancaria del Decreto 587.</a:t>
+              <a:t>Al comparar con lo que existe hoy en Colombia vemos nuestra ventaja: ni SIC Facilita ni las apps de peticiones simples accionan la obligación del banco emisor. ReversoYa activa el reembolso bancario forzoso en 15 días hábiles.</a:t>
             </a:r>
           </a:p>
         </p:txBody>
@@ -1141,7 +1141,7 @@
           <a:lstStyle/>
           <a:p>
             <a:r>
-              <a:t>Nuestro modelo combina un nivel Freemium gratuito con un micro-pago ético de $19.900 pesos por radicación triple certificada y un SaaS B2B mensual para comercios y pasarelas.</a:t>
+              <a:t>Nuestro modelo combina un nivel Freemium gratuito con una tarifa plana de $19.900 pesos por radicación asistida (sin cobrar comisión sobre lo recuperado) y una licencia B2B SaaS mensual para comercios y pasarelas.</a:t>
             </a:r>
           </a:p>
         </p:txBody>
@@ -4149,69 +4149,411 @@
       <p:grpSpPr/>
       <p:sp>
         <p:nvSpPr>
-          <p:cNvPr id="2" name="Title 1"/>
-          <p:cNvSpPr>
-            <a:spLocks noGrp="1"/>
-          </p:cNvSpPr>
-          <p:nvPr>
-            <p:ph type="title"/>
-          </p:nvPr>
-        </p:nvSpPr>
-        <p:spPr/>
-        <p:txBody>
-          <a:bodyPr/>
-          <a:lstStyle/>
-          <a:p>
-            <a:r>
-              <a:t>Slide 1 (00:00-00:50): Nombre, Logo y Eslogan — ReversoYa</a:t>
-            </a:r>
-          </a:p>
-        </p:txBody>
-      </p:sp>
-      <p:sp>
-        <p:nvSpPr>
-          <p:cNvPr id="3" name="Content Placeholder 2"/>
-          <p:cNvSpPr>
-            <a:spLocks noGrp="1"/>
-          </p:cNvSpPr>
-          <p:nvPr>
-            <p:ph idx="1"/>
-          </p:nvPr>
-        </p:nvSpPr>
-        <p:spPr/>
-        <p:txBody>
-          <a:bodyPr/>
+          <p:cNvPr id="2" name="Rectangle 1"/>
+          <p:cNvSpPr/>
+          <p:nvPr/>
+        </p:nvSpPr>
+        <p:spPr>
+          <a:xfrm>
+            <a:off x="0" y="0"/>
+            <a:ext cx="12191695" cy="6858000"/>
+          </a:xfrm>
+          <a:prstGeom prst="rect">
+            <a:avLst/>
+          </a:prstGeom>
+          <a:solidFill>
+            <a:srgbClr val="0B132B"/>
+          </a:solidFill>
+          <a:ln>
+            <a:noFill/>
+          </a:ln>
+        </p:spPr>
+        <p:style>
+          <a:lnRef idx="1">
+            <a:schemeClr val="accent1"/>
+          </a:lnRef>
+          <a:fillRef idx="3">
+            <a:schemeClr val="accent1"/>
+          </a:fillRef>
+          <a:effectRef idx="2">
+            <a:schemeClr val="accent1"/>
+          </a:effectRef>
+          <a:fontRef idx="minor">
+            <a:schemeClr val="lt1"/>
+          </a:fontRef>
+        </p:style>
+        <p:txBody>
+          <a:bodyPr rtlCol="0" anchor="ctr"/>
+          <a:lstStyle/>
+          <a:p>
+            <a:pPr algn="ctr"/>
+          </a:p>
+        </p:txBody>
+      </p:sp>
+      <p:sp>
+        <p:nvSpPr>
+          <p:cNvPr id="3" name="Rounded Rectangle 2"/>
+          <p:cNvSpPr/>
+          <p:nvPr/>
+        </p:nvSpPr>
+        <p:spPr>
+          <a:xfrm>
+            <a:off x="457200" y="320040"/>
+            <a:ext cx="11277295" cy="502920"/>
+          </a:xfrm>
+          <a:prstGeom prst="roundRect">
+            <a:avLst/>
+          </a:prstGeom>
+          <a:solidFill>
+            <a:srgbClr val="131A33"/>
+          </a:solidFill>
+          <a:ln w="15240">
+            <a:solidFill>
+              <a:srgbClr val="00C48C"/>
+            </a:solidFill>
+          </a:ln>
+        </p:spPr>
+        <p:style>
+          <a:lnRef idx="1">
+            <a:schemeClr val="accent1"/>
+          </a:lnRef>
+          <a:fillRef idx="3">
+            <a:schemeClr val="accent1"/>
+          </a:fillRef>
+          <a:effectRef idx="2">
+            <a:schemeClr val="accent1"/>
+          </a:effectRef>
+          <a:fontRef idx="minor">
+            <a:schemeClr val="lt1"/>
+          </a:fontRef>
+        </p:style>
+        <p:txBody>
+          <a:bodyPr rtlCol="0" anchor="ctr" wrap="square"/>
+          <a:lstStyle/>
+          <a:p>
+            <a:pPr algn="ctr">
+              <a:defRPr sz="1100" b="1">
+                <a:solidFill>
+                  <a:srgbClr val="63FCC0"/>
+                </a:solidFill>
+                <a:latin typeface="Segoe UI"/>
+              </a:defRPr>
+            </a:pPr>
+            <a:r>
+              <a:t>DIAPOSITIVA 1 DE 10 · 00:00 – 00:50 (50s)   |   1. NOMBRE · LOGO · ESLOGAN</a:t>
+            </a:r>
+          </a:p>
+        </p:txBody>
+      </p:sp>
+      <p:sp>
+        <p:nvSpPr>
+          <p:cNvPr id="4" name="TextBox 3"/>
+          <p:cNvSpPr txBox="1"/>
+          <p:nvPr/>
+        </p:nvSpPr>
+        <p:spPr>
+          <a:xfrm>
+            <a:off x="457200" y="960120"/>
+            <a:ext cx="6492240" cy="1325880"/>
+          </a:xfrm>
+          <a:prstGeom prst="rect">
+            <a:avLst/>
+          </a:prstGeom>
+          <a:noFill/>
+        </p:spPr>
+        <p:txBody>
+          <a:bodyPr wrap="square">
+            <a:spAutoFit/>
+          </a:bodyPr>
           <a:lstStyle/>
           <a:p>
             <a:pPr>
-              <a:defRPr sz="2000"/>
-            </a:pPr>
-            <a:r>
-              <a:t>Marca: ReversoYa</a:t>
+              <a:defRPr sz="2300" b="1">
+                <a:solidFill>
+                  <a:srgbClr val="FFFFFF"/>
+                </a:solidFill>
+                <a:latin typeface="Segoe UI"/>
+              </a:defRPr>
+            </a:pPr>
+            <a:r>
+              <a:t>ReversoYa: “Tu plata de vuelta por ley, sin rogarle al comercio”</a:t>
             </a:r>
           </a:p>
           <a:p>
             <a:pPr>
-              <a:defRPr sz="2000"/>
-            </a:pPr>
-            <a:r>
-              <a:t>Eslogan: “Tu plata de vuelta por ley, sin rogarle al comercio.”</a:t>
+              <a:defRPr sz="1250">
+                <a:solidFill>
+                  <a:srgbClr val="CBD5E1"/>
+                </a:solidFill>
+                <a:latin typeface="Segoe UI"/>
+              </a:defRPr>
+            </a:pPr>
+            <a:r>
+              <a:t>Plataforma LegalTech colombiana para reversión de pago, retracto, garantías y compensación aérea RAC 3.</a:t>
+            </a:r>
+          </a:p>
+        </p:txBody>
+      </p:sp>
+      <p:sp>
+        <p:nvSpPr>
+          <p:cNvPr id="5" name="Rounded Rectangle 4"/>
+          <p:cNvSpPr/>
+          <p:nvPr/>
+        </p:nvSpPr>
+        <p:spPr>
+          <a:xfrm>
+            <a:off x="457200" y="2395728"/>
+            <a:ext cx="6492240" cy="1170432"/>
+          </a:xfrm>
+          <a:prstGeom prst="roundRect">
+            <a:avLst/>
+          </a:prstGeom>
+          <a:solidFill>
+            <a:srgbClr val="131A33"/>
+          </a:solidFill>
+          <a:ln w="19050">
+            <a:solidFill>
+              <a:srgbClr val="00C48C"/>
+            </a:solidFill>
+          </a:ln>
+        </p:spPr>
+        <p:style>
+          <a:lnRef idx="1">
+            <a:schemeClr val="accent1"/>
+          </a:lnRef>
+          <a:fillRef idx="3">
+            <a:schemeClr val="accent1"/>
+          </a:fillRef>
+          <a:effectRef idx="2">
+            <a:schemeClr val="accent1"/>
+          </a:effectRef>
+          <a:fontRef idx="minor">
+            <a:schemeClr val="lt1"/>
+          </a:fontRef>
+        </p:style>
+        <p:txBody>
+          <a:bodyPr rtlCol="0" anchor="ctr" wrap="square"/>
+          <a:lstStyle/>
+          <a:p>
+            <a:pPr algn="ctr">
+              <a:defRPr sz="1150" b="1">
+                <a:solidFill>
+                  <a:srgbClr val="63FCC0"/>
+                </a:solidFill>
+                <a:latin typeface="Segoe UI"/>
+              </a:defRPr>
+            </a:pPr>
+            <a:r>
+              <a:t>NOMBRE Y MARCA</a:t>
             </a:r>
           </a:p>
           <a:p>
             <a:pPr>
-              <a:defRPr sz="2000"/>
-            </a:pPr>
-            <a:r>
-              <a:t>Logo: Escudo naval (#0B132B) con flecha circular de restitución en verde esmeralda (#00C48C) e insignia LEY 1480.</a:t>
+              <a:defRPr sz="1250">
+                <a:solidFill>
+                  <a:srgbClr val="F8FAFC"/>
+                </a:solidFill>
+                <a:latin typeface="Segoe UI"/>
+              </a:defRPr>
+            </a:pPr>
+            <a:r>
+              <a:t>ReversoYa: Acción directa sobre el dinero retenido en compras digitales.</a:t>
+            </a:r>
+          </a:p>
+        </p:txBody>
+      </p:sp>
+      <p:sp>
+        <p:nvSpPr>
+          <p:cNvPr id="6" name="Rounded Rectangle 5"/>
+          <p:cNvSpPr/>
+          <p:nvPr/>
+        </p:nvSpPr>
+        <p:spPr>
+          <a:xfrm>
+            <a:off x="457200" y="3694176"/>
+            <a:ext cx="6492240" cy="1170432"/>
+          </a:xfrm>
+          <a:prstGeom prst="roundRect">
+            <a:avLst/>
+          </a:prstGeom>
+          <a:solidFill>
+            <a:srgbClr val="131A33"/>
+          </a:solidFill>
+          <a:ln w="19050">
+            <a:solidFill>
+              <a:srgbClr val="30416C"/>
+            </a:solidFill>
+          </a:ln>
+        </p:spPr>
+        <p:style>
+          <a:lnRef idx="1">
+            <a:schemeClr val="accent1"/>
+          </a:lnRef>
+          <a:fillRef idx="3">
+            <a:schemeClr val="accent1"/>
+          </a:fillRef>
+          <a:effectRef idx="2">
+            <a:schemeClr val="accent1"/>
+          </a:effectRef>
+          <a:fontRef idx="minor">
+            <a:schemeClr val="lt1"/>
+          </a:fontRef>
+        </p:style>
+        <p:txBody>
+          <a:bodyPr rtlCol="0" anchor="ctr" wrap="square"/>
+          <a:lstStyle/>
+          <a:p>
+            <a:pPr algn="ctr">
+              <a:defRPr sz="1150" b="1">
+                <a:solidFill>
+                  <a:srgbClr val="63FCC0"/>
+                </a:solidFill>
+                <a:latin typeface="Segoe UI"/>
+              </a:defRPr>
+            </a:pPr>
+            <a:r>
+              <a:t>SÍMBOLO (LOGO)</a:t>
             </a:r>
           </a:p>
           <a:p>
             <a:pPr>
-              <a:defRPr sz="2000"/>
-            </a:pPr>
-            <a:r>
-              <a:t>Mecanismo central: Ejecuta la Reversión de Pago obligatoria ante bancos y pasarelas (PSE, Nequi, Tarjetas) en máximo 15 días hábiles.</a:t>
+              <a:defRPr sz="1250">
+                <a:solidFill>
+                  <a:srgbClr val="F8FAFC"/>
+                </a:solidFill>
+                <a:latin typeface="Segoe UI"/>
+              </a:defRPr>
+            </a:pPr>
+            <a:r>
+              <a:t>Escudo institucional (#0B132B) con flecha circular de restitución en verde esmeralda (#00C48C).</a:t>
+            </a:r>
+          </a:p>
+        </p:txBody>
+      </p:sp>
+      <p:sp>
+        <p:nvSpPr>
+          <p:cNvPr id="7" name="Rounded Rectangle 6"/>
+          <p:cNvSpPr/>
+          <p:nvPr/>
+        </p:nvSpPr>
+        <p:spPr>
+          <a:xfrm>
+            <a:off x="457200" y="4992624"/>
+            <a:ext cx="6492240" cy="1170432"/>
+          </a:xfrm>
+          <a:prstGeom prst="roundRect">
+            <a:avLst/>
+          </a:prstGeom>
+          <a:solidFill>
+            <a:srgbClr val="131A33"/>
+          </a:solidFill>
+          <a:ln w="19050">
+            <a:solidFill>
+              <a:srgbClr val="30416C"/>
+            </a:solidFill>
+          </a:ln>
+        </p:spPr>
+        <p:style>
+          <a:lnRef idx="1">
+            <a:schemeClr val="accent1"/>
+          </a:lnRef>
+          <a:fillRef idx="3">
+            <a:schemeClr val="accent1"/>
+          </a:fillRef>
+          <a:effectRef idx="2">
+            <a:schemeClr val="accent1"/>
+          </a:effectRef>
+          <a:fontRef idx="minor">
+            <a:schemeClr val="lt1"/>
+          </a:fontRef>
+        </p:style>
+        <p:txBody>
+          <a:bodyPr rtlCol="0" anchor="ctr" wrap="square"/>
+          <a:lstStyle/>
+          <a:p>
+            <a:pPr algn="ctr">
+              <a:defRPr sz="1150" b="1">
+                <a:solidFill>
+                  <a:srgbClr val="63FCC0"/>
+                </a:solidFill>
+                <a:latin typeface="Segoe UI"/>
+              </a:defRPr>
+            </a:pPr>
+            <a:r>
+              <a:t>REGLA OPERATIVA</a:t>
+            </a:r>
+          </a:p>
+          <a:p>
+            <a:pPr>
+              <a:defRPr sz="1250">
+                <a:solidFill>
+                  <a:srgbClr val="F8FAFC"/>
+                </a:solidFill>
+                <a:latin typeface="Segoe UI"/>
+              </a:defRPr>
+            </a:pPr>
+            <a:r>
+              <a:t>Notificación formal en 5 días hábiles → Reembolso bancario en máximo 15 días hábiles.</a:t>
+            </a:r>
+          </a:p>
+        </p:txBody>
+      </p:sp>
+      <p:pic>
+        <p:nvPicPr>
+          <p:cNvPr id="8" name="Picture 7" descr="image.png"/>
+          <p:cNvPicPr>
+            <a:picLocks noChangeAspect="1"/>
+          </p:cNvPicPr>
+          <p:nvPr/>
+        </p:nvPicPr>
+        <p:blipFill>
+          <a:blip r:embed="rId2"/>
+          <a:stretch>
+            <a:fillRect/>
+          </a:stretch>
+        </p:blipFill>
+        <p:spPr>
+          <a:xfrm>
+            <a:off x="7178040" y="1051560"/>
+            <a:ext cx="4553712" cy="3348318"/>
+          </a:xfrm>
+          <a:prstGeom prst="rect">
+            <a:avLst/>
+          </a:prstGeom>
+        </p:spPr>
+      </p:pic>
+      <p:sp>
+        <p:nvSpPr>
+          <p:cNvPr id="9" name="TextBox 8"/>
+          <p:cNvSpPr txBox="1"/>
+          <p:nvPr/>
+        </p:nvSpPr>
+        <p:spPr>
+          <a:xfrm>
+            <a:off x="457200" y="6355080"/>
+            <a:ext cx="11277295" cy="320040"/>
+          </a:xfrm>
+          <a:prstGeom prst="rect">
+            <a:avLst/>
+          </a:prstGeom>
+          <a:noFill/>
+        </p:spPr>
+        <p:txBody>
+          <a:bodyPr wrap="none">
+            <a:spAutoFit/>
+          </a:bodyPr>
+          <a:lstStyle/>
+          <a:p>
+            <a:pPr>
+              <a:defRPr sz="1000">
+                <a:solidFill>
+                  <a:srgbClr val="94A3B8"/>
+                </a:solidFill>
+                <a:latin typeface="Segoe UI"/>
+              </a:defRPr>
+            </a:pPr>
+            <a:r>
+              <a:t>ReversoYa Colombia · Ley 1480 de 2011 · Decreto 587 de 2016 · RAC 3 Aerocivil   |   Diapositiva 1 de 10</a:t>
             </a:r>
           </a:p>
         </p:txBody>
@@ -4236,69 +4578,411 @@
       <p:grpSpPr/>
       <p:sp>
         <p:nvSpPr>
-          <p:cNvPr id="2" name="Title 1"/>
-          <p:cNvSpPr>
-            <a:spLocks noGrp="1"/>
-          </p:cNvSpPr>
-          <p:nvPr>
-            <p:ph type="title"/>
-          </p:nvPr>
-        </p:nvSpPr>
-        <p:spPr/>
-        <p:txBody>
-          <a:bodyPr/>
-          <a:lstStyle/>
-          <a:p>
-            <a:r>
-              <a:t>Slide 10 (09:30-10:00): Impacto y Demostración en Vivo</a:t>
-            </a:r>
-          </a:p>
-        </p:txBody>
-      </p:sp>
-      <p:sp>
-        <p:nvSpPr>
-          <p:cNvPr id="3" name="Content Placeholder 2"/>
-          <p:cNvSpPr>
-            <a:spLocks noGrp="1"/>
-          </p:cNvSpPr>
-          <p:nvPr>
-            <p:ph idx="1"/>
-          </p:nvPr>
-        </p:nvSpPr>
-        <p:spPr/>
-        <p:txBody>
-          <a:bodyPr/>
+          <p:cNvPr id="2" name="Rectangle 1"/>
+          <p:cNvSpPr/>
+          <p:nvPr/>
+        </p:nvSpPr>
+        <p:spPr>
+          <a:xfrm>
+            <a:off x="0" y="0"/>
+            <a:ext cx="12191695" cy="6858000"/>
+          </a:xfrm>
+          <a:prstGeom prst="rect">
+            <a:avLst/>
+          </a:prstGeom>
+          <a:solidFill>
+            <a:srgbClr val="0B132B"/>
+          </a:solidFill>
+          <a:ln>
+            <a:noFill/>
+          </a:ln>
+        </p:spPr>
+        <p:style>
+          <a:lnRef idx="1">
+            <a:schemeClr val="accent1"/>
+          </a:lnRef>
+          <a:fillRef idx="3">
+            <a:schemeClr val="accent1"/>
+          </a:fillRef>
+          <a:effectRef idx="2">
+            <a:schemeClr val="accent1"/>
+          </a:effectRef>
+          <a:fontRef idx="minor">
+            <a:schemeClr val="lt1"/>
+          </a:fontRef>
+        </p:style>
+        <p:txBody>
+          <a:bodyPr rtlCol="0" anchor="ctr"/>
+          <a:lstStyle/>
+          <a:p>
+            <a:pPr algn="ctr"/>
+          </a:p>
+        </p:txBody>
+      </p:sp>
+      <p:sp>
+        <p:nvSpPr>
+          <p:cNvPr id="3" name="Rounded Rectangle 2"/>
+          <p:cNvSpPr/>
+          <p:nvPr/>
+        </p:nvSpPr>
+        <p:spPr>
+          <a:xfrm>
+            <a:off x="457200" y="320040"/>
+            <a:ext cx="11277295" cy="502920"/>
+          </a:xfrm>
+          <a:prstGeom prst="roundRect">
+            <a:avLst/>
+          </a:prstGeom>
+          <a:solidFill>
+            <a:srgbClr val="131A33"/>
+          </a:solidFill>
+          <a:ln w="15240">
+            <a:solidFill>
+              <a:srgbClr val="00C48C"/>
+            </a:solidFill>
+          </a:ln>
+        </p:spPr>
+        <p:style>
+          <a:lnRef idx="1">
+            <a:schemeClr val="accent1"/>
+          </a:lnRef>
+          <a:fillRef idx="3">
+            <a:schemeClr val="accent1"/>
+          </a:fillRef>
+          <a:effectRef idx="2">
+            <a:schemeClr val="accent1"/>
+          </a:effectRef>
+          <a:fontRef idx="minor">
+            <a:schemeClr val="lt1"/>
+          </a:fontRef>
+        </p:style>
+        <p:txBody>
+          <a:bodyPr rtlCol="0" anchor="ctr" wrap="square"/>
+          <a:lstStyle/>
+          <a:p>
+            <a:pPr algn="ctr">
+              <a:defRPr sz="1100" b="1">
+                <a:solidFill>
+                  <a:srgbClr val="63FCC0"/>
+                </a:solidFill>
+                <a:latin typeface="Segoe UI"/>
+              </a:defRPr>
+            </a:pPr>
+            <a:r>
+              <a:t>DIAPOSITIVA 10 DE 10 · 09:30 – 10:00 (30s)   |   CONCLUSIÓN E IMPACTO EN ACCESO A LA JUSTICIA</a:t>
+            </a:r>
+          </a:p>
+        </p:txBody>
+      </p:sp>
+      <p:sp>
+        <p:nvSpPr>
+          <p:cNvPr id="4" name="TextBox 3"/>
+          <p:cNvSpPr txBox="1"/>
+          <p:nvPr/>
+        </p:nvSpPr>
+        <p:spPr>
+          <a:xfrm>
+            <a:off x="457200" y="960120"/>
+            <a:ext cx="6492240" cy="1325880"/>
+          </a:xfrm>
+          <a:prstGeom prst="rect">
+            <a:avLst/>
+          </a:prstGeom>
+          <a:noFill/>
+        </p:spPr>
+        <p:txBody>
+          <a:bodyPr wrap="square">
+            <a:spAutoFit/>
+          </a:bodyPr>
           <a:lstStyle/>
           <a:p>
             <a:pPr>
-              <a:defRPr sz="2000"/>
-            </a:pPr>
-            <a:r>
-              <a:t>Entregable 1: Aplicación Web Interactiva 100% funcional (4 pantallas + 4 casos reales).</a:t>
+              <a:defRPr sz="2300" b="1">
+                <a:solidFill>
+                  <a:srgbClr val="FFFFFF"/>
+                </a:solidFill>
+                <a:latin typeface="Segoe UI"/>
+              </a:defRPr>
+            </a:pPr>
+            <a:r>
+              <a:t>Cuando la ley es ejecutable en 3 minutos, el abuso desaparece</a:t>
             </a:r>
           </a:p>
           <a:p>
             <a:pPr>
-              <a:defRPr sz="2000"/>
-            </a:pPr>
-            <a:r>
-              <a:t>Entregable 2: Resumen Ejecutivo de 1 página exacta en PDF.</a:t>
+              <a:defRPr sz="1250">
+                <a:solidFill>
+                  <a:srgbClr val="CBD5E1"/>
+                </a:solidFill>
+                <a:latin typeface="Segoe UI"/>
+              </a:defRPr>
+            </a:pPr>
+            <a:r>
+              <a:t>Síntesis del impacto jurídico, social y tecnológico de ReversoYa en Colombia:</a:t>
+            </a:r>
+          </a:p>
+        </p:txBody>
+      </p:sp>
+      <p:sp>
+        <p:nvSpPr>
+          <p:cNvPr id="5" name="Rounded Rectangle 4"/>
+          <p:cNvSpPr/>
+          <p:nvPr/>
+        </p:nvSpPr>
+        <p:spPr>
+          <a:xfrm>
+            <a:off x="457200" y="2395728"/>
+            <a:ext cx="6492240" cy="1170432"/>
+          </a:xfrm>
+          <a:prstGeom prst="roundRect">
+            <a:avLst/>
+          </a:prstGeom>
+          <a:solidFill>
+            <a:srgbClr val="131A33"/>
+          </a:solidFill>
+          <a:ln w="19050">
+            <a:solidFill>
+              <a:srgbClr val="00C48C"/>
+            </a:solidFill>
+          </a:ln>
+        </p:spPr>
+        <p:style>
+          <a:lnRef idx="1">
+            <a:schemeClr val="accent1"/>
+          </a:lnRef>
+          <a:fillRef idx="3">
+            <a:schemeClr val="accent1"/>
+          </a:fillRef>
+          <a:effectRef idx="2">
+            <a:schemeClr val="accent1"/>
+          </a:effectRef>
+          <a:fontRef idx="minor">
+            <a:schemeClr val="lt1"/>
+          </a:fontRef>
+        </p:style>
+        <p:txBody>
+          <a:bodyPr rtlCol="0" anchor="ctr" wrap="square"/>
+          <a:lstStyle/>
+          <a:p>
+            <a:pPr algn="ctr">
+              <a:defRPr sz="1150" b="1">
+                <a:solidFill>
+                  <a:srgbClr val="63FCC0"/>
+                </a:solidFill>
+                <a:latin typeface="Segoe UI"/>
+              </a:defRPr>
+            </a:pPr>
+            <a:r>
+              <a:t>EFICACIA MATERIAL (ART. 78 Y 229 C.P.)</a:t>
             </a:r>
           </a:p>
           <a:p>
             <a:pPr>
-              <a:defRPr sz="2000"/>
-            </a:pPr>
-            <a:r>
-              <a:t>Entregable 3: Presentación de 10 minutos con notas de orador Clarity.</a:t>
+              <a:defRPr sz="1250">
+                <a:solidFill>
+                  <a:srgbClr val="F8FAFC"/>
+                </a:solidFill>
+                <a:latin typeface="Segoe UI"/>
+              </a:defRPr>
+            </a:pPr>
+            <a:r>
+              <a:t>Convierte el Estatuto del Consumidor y el Decreto 587 de 2016 en una defensa ciudadana inmediata.</a:t>
+            </a:r>
+          </a:p>
+        </p:txBody>
+      </p:sp>
+      <p:sp>
+        <p:nvSpPr>
+          <p:cNvPr id="6" name="Rounded Rectangle 5"/>
+          <p:cNvSpPr/>
+          <p:nvPr/>
+        </p:nvSpPr>
+        <p:spPr>
+          <a:xfrm>
+            <a:off x="457200" y="3694176"/>
+            <a:ext cx="6492240" cy="1170432"/>
+          </a:xfrm>
+          <a:prstGeom prst="roundRect">
+            <a:avLst/>
+          </a:prstGeom>
+          <a:solidFill>
+            <a:srgbClr val="131A33"/>
+          </a:solidFill>
+          <a:ln w="19050">
+            <a:solidFill>
+              <a:srgbClr val="30416C"/>
+            </a:solidFill>
+          </a:ln>
+        </p:spPr>
+        <p:style>
+          <a:lnRef idx="1">
+            <a:schemeClr val="accent1"/>
+          </a:lnRef>
+          <a:fillRef idx="3">
+            <a:schemeClr val="accent1"/>
+          </a:fillRef>
+          <a:effectRef idx="2">
+            <a:schemeClr val="accent1"/>
+          </a:effectRef>
+          <a:fontRef idx="minor">
+            <a:schemeClr val="lt1"/>
+          </a:fontRef>
+        </p:style>
+        <p:txBody>
+          <a:bodyPr rtlCol="0" anchor="ctr" wrap="square"/>
+          <a:lstStyle/>
+          <a:p>
+            <a:pPr algn="ctr">
+              <a:defRPr sz="1150" b="1">
+                <a:solidFill>
+                  <a:srgbClr val="63FCC0"/>
+                </a:solidFill>
+                <a:latin typeface="Segoe UI"/>
+              </a:defRPr>
+            </a:pPr>
+            <a:r>
+              <a:t>RIGOR TÉCNICO Y PROBATORIO</a:t>
             </a:r>
           </a:p>
           <a:p>
             <a:pPr>
-              <a:defRPr sz="2000"/>
-            </a:pPr>
-            <a:r>
-              <a:t>Entregable 4: 5 Videos dinámicos de Motion Graphics de 45 segundos cada uno.</a:t>
+              <a:defRPr sz="1250">
+                <a:solidFill>
+                  <a:srgbClr val="F8FAFC"/>
+                </a:solidFill>
+                <a:latin typeface="Segoe UI"/>
+              </a:defRPr>
+            </a:pPr>
+            <a:r>
+              <a:t>Cumple estrictamente el Art. 2.2.2.51.3 del Decreto 1074 de 2015 y la Ley 527 de 1999.</a:t>
+            </a:r>
+          </a:p>
+        </p:txBody>
+      </p:sp>
+      <p:sp>
+        <p:nvSpPr>
+          <p:cNvPr id="7" name="Rounded Rectangle 6"/>
+          <p:cNvSpPr/>
+          <p:nvPr/>
+        </p:nvSpPr>
+        <p:spPr>
+          <a:xfrm>
+            <a:off x="457200" y="4992624"/>
+            <a:ext cx="6492240" cy="1170432"/>
+          </a:xfrm>
+          <a:prstGeom prst="roundRect">
+            <a:avLst/>
+          </a:prstGeom>
+          <a:solidFill>
+            <a:srgbClr val="131A33"/>
+          </a:solidFill>
+          <a:ln w="19050">
+            <a:solidFill>
+              <a:srgbClr val="30416C"/>
+            </a:solidFill>
+          </a:ln>
+        </p:spPr>
+        <p:style>
+          <a:lnRef idx="1">
+            <a:schemeClr val="accent1"/>
+          </a:lnRef>
+          <a:fillRef idx="3">
+            <a:schemeClr val="accent1"/>
+          </a:fillRef>
+          <a:effectRef idx="2">
+            <a:schemeClr val="accent1"/>
+          </a:effectRef>
+          <a:fontRef idx="minor">
+            <a:schemeClr val="lt1"/>
+          </a:fontRef>
+        </p:style>
+        <p:txBody>
+          <a:bodyPr rtlCol="0" anchor="ctr" wrap="square"/>
+          <a:lstStyle/>
+          <a:p>
+            <a:pPr algn="ctr">
+              <a:defRPr sz="1150" b="1">
+                <a:solidFill>
+                  <a:srgbClr val="63FCC0"/>
+                </a:solidFill>
+                <a:latin typeface="Segoe UI"/>
+              </a:defRPr>
+            </a:pPr>
+            <a:r>
+              <a:t>ESCALABILIDAD NACIONAL</a:t>
+            </a:r>
+          </a:p>
+          <a:p>
+            <a:pPr>
+              <a:defRPr sz="1250">
+                <a:solidFill>
+                  <a:srgbClr val="F8FAFC"/>
+                </a:solidFill>
+                <a:latin typeface="Segoe UI"/>
+              </a:defRPr>
+            </a:pPr>
+            <a:r>
+              <a:t>Protege desde compras de $80.000 COP en redes sociales hasta tiquetes aéreos bajo el RAC 3.</a:t>
+            </a:r>
+          </a:p>
+        </p:txBody>
+      </p:sp>
+      <p:pic>
+        <p:nvPicPr>
+          <p:cNvPr id="8" name="Picture 7" descr="image.png"/>
+          <p:cNvPicPr>
+            <a:picLocks noChangeAspect="1"/>
+          </p:cNvPicPr>
+          <p:nvPr/>
+        </p:nvPicPr>
+        <p:blipFill>
+          <a:blip r:embed="rId2"/>
+          <a:stretch>
+            <a:fillRect/>
+          </a:stretch>
+        </p:blipFill>
+        <p:spPr>
+          <a:xfrm>
+            <a:off x="7178040" y="1051560"/>
+            <a:ext cx="4553712" cy="3348318"/>
+          </a:xfrm>
+          <a:prstGeom prst="rect">
+            <a:avLst/>
+          </a:prstGeom>
+        </p:spPr>
+      </p:pic>
+      <p:sp>
+        <p:nvSpPr>
+          <p:cNvPr id="9" name="TextBox 8"/>
+          <p:cNvSpPr txBox="1"/>
+          <p:nvPr/>
+        </p:nvSpPr>
+        <p:spPr>
+          <a:xfrm>
+            <a:off x="457200" y="6355080"/>
+            <a:ext cx="11277295" cy="320040"/>
+          </a:xfrm>
+          <a:prstGeom prst="rect">
+            <a:avLst/>
+          </a:prstGeom>
+          <a:noFill/>
+        </p:spPr>
+        <p:txBody>
+          <a:bodyPr wrap="none">
+            <a:spAutoFit/>
+          </a:bodyPr>
+          <a:lstStyle/>
+          <a:p>
+            <a:pPr>
+              <a:defRPr sz="1000">
+                <a:solidFill>
+                  <a:srgbClr val="94A3B8"/>
+                </a:solidFill>
+                <a:latin typeface="Segoe UI"/>
+              </a:defRPr>
+            </a:pPr>
+            <a:r>
+              <a:t>ReversoYa Colombia · Ley 1480 de 2011 · Decreto 587 de 2016 · RAC 3 Aerocivil   |   Diapositiva 10 de 10</a:t>
             </a:r>
           </a:p>
         </p:txBody>
@@ -4323,69 +5007,411 @@
       <p:grpSpPr/>
       <p:sp>
         <p:nvSpPr>
-          <p:cNvPr id="2" name="Title 1"/>
-          <p:cNvSpPr>
-            <a:spLocks noGrp="1"/>
-          </p:cNvSpPr>
-          <p:nvPr>
-            <p:ph type="title"/>
-          </p:nvPr>
-        </p:nvSpPr>
-        <p:spPr/>
-        <p:txBody>
-          <a:bodyPr/>
-          <a:lstStyle/>
-          <a:p>
-            <a:r>
-              <a:t>Slide 2 (00:50-02:00): El Problema en Colombia — ¿A quién afecta?</a:t>
-            </a:r>
-          </a:p>
-        </p:txBody>
-      </p:sp>
-      <p:sp>
-        <p:nvSpPr>
-          <p:cNvPr id="3" name="Content Placeholder 2"/>
-          <p:cNvSpPr>
-            <a:spLocks noGrp="1"/>
-          </p:cNvSpPr>
-          <p:nvPr>
-            <p:ph idx="1"/>
-          </p:nvPr>
-        </p:nvSpPr>
-        <p:spPr/>
-        <p:txBody>
-          <a:bodyPr/>
+          <p:cNvPr id="2" name="Rectangle 1"/>
+          <p:cNvSpPr/>
+          <p:nvPr/>
+        </p:nvSpPr>
+        <p:spPr>
+          <a:xfrm>
+            <a:off x="0" y="0"/>
+            <a:ext cx="12191695" cy="6858000"/>
+          </a:xfrm>
+          <a:prstGeom prst="rect">
+            <a:avLst/>
+          </a:prstGeom>
+          <a:solidFill>
+            <a:srgbClr val="0B132B"/>
+          </a:solidFill>
+          <a:ln>
+            <a:noFill/>
+          </a:ln>
+        </p:spPr>
+        <p:style>
+          <a:lnRef idx="1">
+            <a:schemeClr val="accent1"/>
+          </a:lnRef>
+          <a:fillRef idx="3">
+            <a:schemeClr val="accent1"/>
+          </a:fillRef>
+          <a:effectRef idx="2">
+            <a:schemeClr val="accent1"/>
+          </a:effectRef>
+          <a:fontRef idx="minor">
+            <a:schemeClr val="lt1"/>
+          </a:fontRef>
+        </p:style>
+        <p:txBody>
+          <a:bodyPr rtlCol="0" anchor="ctr"/>
+          <a:lstStyle/>
+          <a:p>
+            <a:pPr algn="ctr"/>
+          </a:p>
+        </p:txBody>
+      </p:sp>
+      <p:sp>
+        <p:nvSpPr>
+          <p:cNvPr id="3" name="Rounded Rectangle 2"/>
+          <p:cNvSpPr/>
+          <p:nvPr/>
+        </p:nvSpPr>
+        <p:spPr>
+          <a:xfrm>
+            <a:off x="457200" y="320040"/>
+            <a:ext cx="11277295" cy="502920"/>
+          </a:xfrm>
+          <a:prstGeom prst="roundRect">
+            <a:avLst/>
+          </a:prstGeom>
+          <a:solidFill>
+            <a:srgbClr val="131A33"/>
+          </a:solidFill>
+          <a:ln w="15240">
+            <a:solidFill>
+              <a:srgbClr val="00C48C"/>
+            </a:solidFill>
+          </a:ln>
+        </p:spPr>
+        <p:style>
+          <a:lnRef idx="1">
+            <a:schemeClr val="accent1"/>
+          </a:lnRef>
+          <a:fillRef idx="3">
+            <a:schemeClr val="accent1"/>
+          </a:fillRef>
+          <a:effectRef idx="2">
+            <a:schemeClr val="accent1"/>
+          </a:effectRef>
+          <a:fontRef idx="minor">
+            <a:schemeClr val="lt1"/>
+          </a:fontRef>
+        </p:style>
+        <p:txBody>
+          <a:bodyPr rtlCol="0" anchor="ctr" wrap="square"/>
+          <a:lstStyle/>
+          <a:p>
+            <a:pPr algn="ctr">
+              <a:defRPr sz="1100" b="1">
+                <a:solidFill>
+                  <a:srgbClr val="63FCC0"/>
+                </a:solidFill>
+                <a:latin typeface="Segoe UI"/>
+              </a:defRPr>
+            </a:pPr>
+            <a:r>
+              <a:t>DIAPOSITIVA 2 DE 10 · 00:50 – 02:00 (70s)   |   2. IDENTIFICACIÓN DEL PROBLEMA EN COLOMBIA</a:t>
+            </a:r>
+          </a:p>
+        </p:txBody>
+      </p:sp>
+      <p:sp>
+        <p:nvSpPr>
+          <p:cNvPr id="4" name="TextBox 3"/>
+          <p:cNvSpPr txBox="1"/>
+          <p:nvPr/>
+        </p:nvSpPr>
+        <p:spPr>
+          <a:xfrm>
+            <a:off x="457200" y="960120"/>
+            <a:ext cx="6492240" cy="1325880"/>
+          </a:xfrm>
+          <a:prstGeom prst="rect">
+            <a:avLst/>
+          </a:prstGeom>
+          <a:noFill/>
+        </p:spPr>
+        <p:txBody>
+          <a:bodyPr wrap="square">
+            <a:spAutoFit/>
+          </a:bodyPr>
           <a:lstStyle/>
           <a:p>
             <a:pPr>
-              <a:defRPr sz="2000"/>
-            </a:pPr>
-            <a:r>
-              <a:t>370+ millones de pagos digitales al año en Colombia por más de $62 billones COP (CCCE).</a:t>
+              <a:defRPr sz="2300" b="1">
+                <a:solidFill>
+                  <a:srgbClr val="FFFFFF"/>
+                </a:solidFill>
+                <a:latin typeface="Segoe UI"/>
+              </a:defRPr>
+            </a:pPr>
+            <a:r>
+              <a:t>370 millones de pagos digitales y reclamos que se abandonan</a:t>
             </a:r>
           </a:p>
           <a:p>
             <a:pPr>
-              <a:defRPr sz="2000"/>
-            </a:pPr>
-            <a:r>
-              <a:t>Muro 1 (Las 4 excusas ilegales): 1) 'Solo damos bono', 2) 'Reclámele a la transportadora', 3) 'En promoción no hay garantía', 4) 'Espere 60 días'.</a:t>
+              <a:defRPr sz="1250">
+                <a:solidFill>
+                  <a:srgbClr val="CBD5E1"/>
+                </a:solidFill>
+                <a:latin typeface="Segoe UI"/>
+              </a:defRPr>
+            </a:pPr>
+            <a:r>
+              <a:t>El comercio digital en Colombia supera los $62 billones COP anuales (CCCE), pero el ciudadano choca con dos barreras:</a:t>
+            </a:r>
+          </a:p>
+        </p:txBody>
+      </p:sp>
+      <p:sp>
+        <p:nvSpPr>
+          <p:cNvPr id="5" name="Rounded Rectangle 4"/>
+          <p:cNvSpPr/>
+          <p:nvPr/>
+        </p:nvSpPr>
+        <p:spPr>
+          <a:xfrm>
+            <a:off x="457200" y="2395728"/>
+            <a:ext cx="6492240" cy="1170432"/>
+          </a:xfrm>
+          <a:prstGeom prst="roundRect">
+            <a:avLst/>
+          </a:prstGeom>
+          <a:solidFill>
+            <a:srgbClr val="131A33"/>
+          </a:solidFill>
+          <a:ln w="19050">
+            <a:solidFill>
+              <a:srgbClr val="00C48C"/>
+            </a:solidFill>
+          </a:ln>
+        </p:spPr>
+        <p:style>
+          <a:lnRef idx="1">
+            <a:schemeClr val="accent1"/>
+          </a:lnRef>
+          <a:fillRef idx="3">
+            <a:schemeClr val="accent1"/>
+          </a:fillRef>
+          <a:effectRef idx="2">
+            <a:schemeClr val="accent1"/>
+          </a:effectRef>
+          <a:fontRef idx="minor">
+            <a:schemeClr val="lt1"/>
+          </a:fontRef>
+        </p:style>
+        <p:txBody>
+          <a:bodyPr rtlCol="0" anchor="ctr" wrap="square"/>
+          <a:lstStyle/>
+          <a:p>
+            <a:pPr algn="ctr">
+              <a:defRPr sz="1150" b="1">
+                <a:solidFill>
+                  <a:srgbClr val="63FCC0"/>
+                </a:solidFill>
+                <a:latin typeface="Segoe UI"/>
+              </a:defRPr>
+            </a:pPr>
+            <a:r>
+              <a:t>BARRERA 1: LAS 4 EXCUSAS DEL COMERCIO</a:t>
             </a:r>
           </a:p>
           <a:p>
             <a:pPr>
-              <a:defRPr sz="2000"/>
-            </a:pPr>
-            <a:r>
-              <a:t>Muro 2 (Asimetría económica): Un abogado cuesta entre $400.000 y $800.000 COP; nadie contrata un abogado para recuperar una compra de $250.000 COP.</a:t>
+              <a:defRPr sz="1250">
+                <a:solidFill>
+                  <a:srgbClr val="F8FAFC"/>
+                </a:solidFill>
+                <a:latin typeface="Segoe UI"/>
+              </a:defRPr>
+            </a:pPr>
+            <a:r>
+              <a:t>1) 'Solo damos bono', 2) 'Reclámele a la transportadora', 3) 'En promoción no hay garantía', 4) 'Espere 60 días'.</a:t>
+            </a:r>
+          </a:p>
+        </p:txBody>
+      </p:sp>
+      <p:sp>
+        <p:nvSpPr>
+          <p:cNvPr id="6" name="Rounded Rectangle 5"/>
+          <p:cNvSpPr/>
+          <p:nvPr/>
+        </p:nvSpPr>
+        <p:spPr>
+          <a:xfrm>
+            <a:off x="457200" y="3694176"/>
+            <a:ext cx="6492240" cy="1170432"/>
+          </a:xfrm>
+          <a:prstGeom prst="roundRect">
+            <a:avLst/>
+          </a:prstGeom>
+          <a:solidFill>
+            <a:srgbClr val="131A33"/>
+          </a:solidFill>
+          <a:ln w="19050">
+            <a:solidFill>
+              <a:srgbClr val="30416C"/>
+            </a:solidFill>
+          </a:ln>
+        </p:spPr>
+        <p:style>
+          <a:lnRef idx="1">
+            <a:schemeClr val="accent1"/>
+          </a:lnRef>
+          <a:fillRef idx="3">
+            <a:schemeClr val="accent1"/>
+          </a:fillRef>
+          <a:effectRef idx="2">
+            <a:schemeClr val="accent1"/>
+          </a:effectRef>
+          <a:fontRef idx="minor">
+            <a:schemeClr val="lt1"/>
+          </a:fontRef>
+        </p:style>
+        <p:txBody>
+          <a:bodyPr rtlCol="0" anchor="ctr" wrap="square"/>
+          <a:lstStyle/>
+          <a:p>
+            <a:pPr algn="ctr">
+              <a:defRPr sz="1150" b="1">
+                <a:solidFill>
+                  <a:srgbClr val="63FCC0"/>
+                </a:solidFill>
+                <a:latin typeface="Segoe UI"/>
+              </a:defRPr>
+            </a:pPr>
+            <a:r>
+              <a:t>BARRERA 2: ASIMETRÍA ECONÓMICA</a:t>
             </a:r>
           </a:p>
           <a:p>
             <a:pPr>
-              <a:defRPr sz="2000"/>
-            </a:pPr>
-            <a:r>
-              <a:t>Muro 3 (Ventana oculta): El comprador solo tiene 5 días hábiles para activar formalmente a su banco bajo el Decreto 587 de 2016.</a:t>
+              <a:defRPr sz="1250">
+                <a:solidFill>
+                  <a:srgbClr val="F8FAFC"/>
+                </a:solidFill>
+                <a:latin typeface="Segoe UI"/>
+              </a:defRPr>
+            </a:pPr>
+            <a:r>
+              <a:t>Pagar un abogado cuesta entre $400.000 y $800.000 COP, superando el valor de las compras cotidianas ($80k a $900k COP).</a:t>
+            </a:r>
+          </a:p>
+        </p:txBody>
+      </p:sp>
+      <p:sp>
+        <p:nvSpPr>
+          <p:cNvPr id="7" name="Rounded Rectangle 6"/>
+          <p:cNvSpPr/>
+          <p:nvPr/>
+        </p:nvSpPr>
+        <p:spPr>
+          <a:xfrm>
+            <a:off x="457200" y="4992624"/>
+            <a:ext cx="6492240" cy="1170432"/>
+          </a:xfrm>
+          <a:prstGeom prst="roundRect">
+            <a:avLst/>
+          </a:prstGeom>
+          <a:solidFill>
+            <a:srgbClr val="131A33"/>
+          </a:solidFill>
+          <a:ln w="19050">
+            <a:solidFill>
+              <a:srgbClr val="30416C"/>
+            </a:solidFill>
+          </a:ln>
+        </p:spPr>
+        <p:style>
+          <a:lnRef idx="1">
+            <a:schemeClr val="accent1"/>
+          </a:lnRef>
+          <a:fillRef idx="3">
+            <a:schemeClr val="accent1"/>
+          </a:fillRef>
+          <a:effectRef idx="2">
+            <a:schemeClr val="accent1"/>
+          </a:effectRef>
+          <a:fontRef idx="minor">
+            <a:schemeClr val="lt1"/>
+          </a:fontRef>
+        </p:style>
+        <p:txBody>
+          <a:bodyPr rtlCol="0" anchor="ctr" wrap="square"/>
+          <a:lstStyle/>
+          <a:p>
+            <a:pPr algn="ctr">
+              <a:defRPr sz="1150" b="1">
+                <a:solidFill>
+                  <a:srgbClr val="63FCC0"/>
+                </a:solidFill>
+                <a:latin typeface="Segoe UI"/>
+              </a:defRPr>
+            </a:pPr>
+            <a:r>
+              <a:t>BARRERA 3: EL PLAZO OCULTO DE 5 DÍAS</a:t>
+            </a:r>
+          </a:p>
+          <a:p>
+            <a:pPr>
+              <a:defRPr sz="1250">
+                <a:solidFill>
+                  <a:srgbClr val="F8FAFC"/>
+                </a:solidFill>
+                <a:latin typeface="Segoe UI"/>
+              </a:defRPr>
+            </a:pPr>
+            <a:r>
+              <a:t>La ley obliga al banco a devolver el dinero, pero exige radicar una solicitud formal dentro de los primeros 5 días hábiles.</a:t>
+            </a:r>
+          </a:p>
+        </p:txBody>
+      </p:sp>
+      <p:pic>
+        <p:nvPicPr>
+          <p:cNvPr id="8" name="Picture 7" descr="image.png"/>
+          <p:cNvPicPr>
+            <a:picLocks noChangeAspect="1"/>
+          </p:cNvPicPr>
+          <p:nvPr/>
+        </p:nvPicPr>
+        <p:blipFill>
+          <a:blip r:embed="rId2"/>
+          <a:stretch>
+            <a:fillRect/>
+          </a:stretch>
+        </p:blipFill>
+        <p:spPr>
+          <a:xfrm>
+            <a:off x="7178040" y="1051560"/>
+            <a:ext cx="4553712" cy="3348318"/>
+          </a:xfrm>
+          <a:prstGeom prst="rect">
+            <a:avLst/>
+          </a:prstGeom>
+        </p:spPr>
+      </p:pic>
+      <p:sp>
+        <p:nvSpPr>
+          <p:cNvPr id="9" name="TextBox 8"/>
+          <p:cNvSpPr txBox="1"/>
+          <p:nvPr/>
+        </p:nvSpPr>
+        <p:spPr>
+          <a:xfrm>
+            <a:off x="457200" y="6355080"/>
+            <a:ext cx="11277295" cy="320040"/>
+          </a:xfrm>
+          <a:prstGeom prst="rect">
+            <a:avLst/>
+          </a:prstGeom>
+          <a:noFill/>
+        </p:spPr>
+        <p:txBody>
+          <a:bodyPr wrap="none">
+            <a:spAutoFit/>
+          </a:bodyPr>
+          <a:lstStyle/>
+          <a:p>
+            <a:pPr>
+              <a:defRPr sz="1000">
+                <a:solidFill>
+                  <a:srgbClr val="94A3B8"/>
+                </a:solidFill>
+                <a:latin typeface="Segoe UI"/>
+              </a:defRPr>
+            </a:pPr>
+            <a:r>
+              <a:t>ReversoYa Colombia · Ley 1480 de 2011 · Decreto 587 de 2016 · RAC 3 Aerocivil   |   Diapositiva 2 de 10</a:t>
             </a:r>
           </a:p>
         </p:txBody>
@@ -4410,69 +5436,411 @@
       <p:grpSpPr/>
       <p:sp>
         <p:nvSpPr>
-          <p:cNvPr id="2" name="Title 1"/>
-          <p:cNvSpPr>
-            <a:spLocks noGrp="1"/>
-          </p:cNvSpPr>
-          <p:nvPr>
-            <p:ph type="title"/>
-          </p:nvPr>
-        </p:nvSpPr>
-        <p:spPr/>
-        <p:txBody>
-          <a:bodyPr/>
-          <a:lstStyle/>
-          <a:p>
-            <a:r>
-              <a:t>Slide 3 (02:00-03:15): Problema Jurídico — DD. HH., Constitución y Ley</a:t>
-            </a:r>
-          </a:p>
-        </p:txBody>
-      </p:sp>
-      <p:sp>
-        <p:nvSpPr>
-          <p:cNvPr id="3" name="Content Placeholder 2"/>
-          <p:cNvSpPr>
-            <a:spLocks noGrp="1"/>
-          </p:cNvSpPr>
-          <p:nvPr>
-            <p:ph idx="1"/>
-          </p:nvPr>
-        </p:nvSpPr>
-        <p:spPr/>
-        <p:txBody>
-          <a:bodyPr/>
+          <p:cNvPr id="2" name="Rectangle 1"/>
+          <p:cNvSpPr/>
+          <p:nvPr/>
+        </p:nvSpPr>
+        <p:spPr>
+          <a:xfrm>
+            <a:off x="0" y="0"/>
+            <a:ext cx="12191695" cy="6858000"/>
+          </a:xfrm>
+          <a:prstGeom prst="rect">
+            <a:avLst/>
+          </a:prstGeom>
+          <a:solidFill>
+            <a:srgbClr val="0B132B"/>
+          </a:solidFill>
+          <a:ln>
+            <a:noFill/>
+          </a:ln>
+        </p:spPr>
+        <p:style>
+          <a:lnRef idx="1">
+            <a:schemeClr val="accent1"/>
+          </a:lnRef>
+          <a:fillRef idx="3">
+            <a:schemeClr val="accent1"/>
+          </a:fillRef>
+          <a:effectRef idx="2">
+            <a:schemeClr val="accent1"/>
+          </a:effectRef>
+          <a:fontRef idx="minor">
+            <a:schemeClr val="lt1"/>
+          </a:fontRef>
+        </p:style>
+        <p:txBody>
+          <a:bodyPr rtlCol="0" anchor="ctr"/>
+          <a:lstStyle/>
+          <a:p>
+            <a:pPr algn="ctr"/>
+          </a:p>
+        </p:txBody>
+      </p:sp>
+      <p:sp>
+        <p:nvSpPr>
+          <p:cNvPr id="3" name="Rounded Rectangle 2"/>
+          <p:cNvSpPr/>
+          <p:nvPr/>
+        </p:nvSpPr>
+        <p:spPr>
+          <a:xfrm>
+            <a:off x="457200" y="320040"/>
+            <a:ext cx="11277295" cy="502920"/>
+          </a:xfrm>
+          <a:prstGeom prst="roundRect">
+            <a:avLst/>
+          </a:prstGeom>
+          <a:solidFill>
+            <a:srgbClr val="131A33"/>
+          </a:solidFill>
+          <a:ln w="15240">
+            <a:solidFill>
+              <a:srgbClr val="00C48C"/>
+            </a:solidFill>
+          </a:ln>
+        </p:spPr>
+        <p:style>
+          <a:lnRef idx="1">
+            <a:schemeClr val="accent1"/>
+          </a:lnRef>
+          <a:fillRef idx="3">
+            <a:schemeClr val="accent1"/>
+          </a:fillRef>
+          <a:effectRef idx="2">
+            <a:schemeClr val="accent1"/>
+          </a:effectRef>
+          <a:fontRef idx="minor">
+            <a:schemeClr val="lt1"/>
+          </a:fontRef>
+        </p:style>
+        <p:txBody>
+          <a:bodyPr rtlCol="0" anchor="ctr" wrap="square"/>
+          <a:lstStyle/>
+          <a:p>
+            <a:pPr algn="ctr">
+              <a:defRPr sz="1100" b="1">
+                <a:solidFill>
+                  <a:srgbClr val="63FCC0"/>
+                </a:solidFill>
+                <a:latin typeface="Segoe UI"/>
+              </a:defRPr>
+            </a:pPr>
+            <a:r>
+              <a:t>DIAPOSITIVA 3 DE 10 · 02:00 – 03:15 (75s)   |   2. PROBLEMA JURÍDICO · DERECHOS · LEGISLACIÓN</a:t>
+            </a:r>
+          </a:p>
+        </p:txBody>
+      </p:sp>
+      <p:sp>
+        <p:nvSpPr>
+          <p:cNvPr id="4" name="TextBox 3"/>
+          <p:cNvSpPr txBox="1"/>
+          <p:nvPr/>
+        </p:nvSpPr>
+        <p:spPr>
+          <a:xfrm>
+            <a:off x="457200" y="960120"/>
+            <a:ext cx="6492240" cy="1325880"/>
+          </a:xfrm>
+          <a:prstGeom prst="rect">
+            <a:avLst/>
+          </a:prstGeom>
+          <a:noFill/>
+        </p:spPr>
+        <p:txBody>
+          <a:bodyPr wrap="square">
+            <a:spAutoFit/>
+          </a:bodyPr>
           <a:lstStyle/>
           <a:p>
             <a:pPr>
-              <a:defRPr sz="2000"/>
-            </a:pPr>
-            <a:r>
-              <a:t>Constitución Política y DD. HH.: Art. 78 C.P. (protección al consumidor), Art. 229 C.P. (acceso a la justicia) y Directrices ONU (Res. A/RES/70/186).</a:t>
+              <a:defRPr sz="2300" b="1">
+                <a:solidFill>
+                  <a:srgbClr val="FFFFFF"/>
+                </a:solidFill>
+                <a:latin typeface="Segoe UI"/>
+              </a:defRPr>
+            </a:pPr>
+            <a:r>
+              <a:t>Arquitectura Normativa: El derecho ya existe en Colombia</a:t>
             </a:r>
           </a:p>
           <a:p>
             <a:pPr>
-              <a:defRPr sz="2000"/>
-            </a:pPr>
-            <a:r>
-              <a:t>Ley 1480 de 2011: Art. 51 (Reversión del pago), Art. 47 (Retracto en 5 días hábiles en dinero, prohibidos los bonos), Arts. 7, 8 y 43 (Garantía en promociones).</a:t>
+              <a:defRPr sz="1250">
+                <a:solidFill>
+                  <a:srgbClr val="CBD5E1"/>
+                </a:solidFill>
+                <a:latin typeface="Segoe UI"/>
+              </a:defRPr>
+            </a:pPr>
+            <a:r>
+              <a:t>Articulación entre Constitución Política, Derechos Humanos, Estatuto del Consumidor y Decreto 587 de 2016:</a:t>
+            </a:r>
+          </a:p>
+        </p:txBody>
+      </p:sp>
+      <p:sp>
+        <p:nvSpPr>
+          <p:cNvPr id="5" name="Rounded Rectangle 4"/>
+          <p:cNvSpPr/>
+          <p:nvPr/>
+        </p:nvSpPr>
+        <p:spPr>
+          <a:xfrm>
+            <a:off x="457200" y="2395728"/>
+            <a:ext cx="6492240" cy="1170432"/>
+          </a:xfrm>
+          <a:prstGeom prst="roundRect">
+            <a:avLst/>
+          </a:prstGeom>
+          <a:solidFill>
+            <a:srgbClr val="131A33"/>
+          </a:solidFill>
+          <a:ln w="19050">
+            <a:solidFill>
+              <a:srgbClr val="00C48C"/>
+            </a:solidFill>
+          </a:ln>
+        </p:spPr>
+        <p:style>
+          <a:lnRef idx="1">
+            <a:schemeClr val="accent1"/>
+          </a:lnRef>
+          <a:fillRef idx="3">
+            <a:schemeClr val="accent1"/>
+          </a:fillRef>
+          <a:effectRef idx="2">
+            <a:schemeClr val="accent1"/>
+          </a:effectRef>
+          <a:fontRef idx="minor">
+            <a:schemeClr val="lt1"/>
+          </a:fontRef>
+        </p:style>
+        <p:txBody>
+          <a:bodyPr rtlCol="0" anchor="ctr" wrap="square"/>
+          <a:lstStyle/>
+          <a:p>
+            <a:pPr algn="ctr">
+              <a:defRPr sz="1150" b="1">
+                <a:solidFill>
+                  <a:srgbClr val="63FCC0"/>
+                </a:solidFill>
+                <a:latin typeface="Segoe UI"/>
+              </a:defRPr>
+            </a:pPr>
+            <a:r>
+              <a:t>CONSTITUCIÓN Y DD. HH.</a:t>
             </a:r>
           </a:p>
           <a:p>
             <a:pPr>
-              <a:defRPr sz="2000"/>
-            </a:pPr>
-            <a:r>
-              <a:t>Decreto 587 de 2016 (Cap. 51 Decreto 1074/2015): 5 días hábiles para notificar (Art. 2.2.2.51.4) -&gt; 15 días hábiles para que el banco devuelva el 100% (Art. 2.2.2.51.5).</a:t>
+              <a:defRPr sz="1250">
+                <a:solidFill>
+                  <a:srgbClr val="F8FAFC"/>
+                </a:solidFill>
+                <a:latin typeface="Segoe UI"/>
+              </a:defRPr>
+            </a:pPr>
+            <a:r>
+              <a:t>Art. 78 C.P. (protección al consumidor), Art. 229 C.P. (acceso a la justicia) y Directrices ONU (Res. A/RES/70/186).</a:t>
+            </a:r>
+          </a:p>
+        </p:txBody>
+      </p:sp>
+      <p:sp>
+        <p:nvSpPr>
+          <p:cNvPr id="6" name="Rounded Rectangle 5"/>
+          <p:cNvSpPr/>
+          <p:nvPr/>
+        </p:nvSpPr>
+        <p:spPr>
+          <a:xfrm>
+            <a:off x="457200" y="3694176"/>
+            <a:ext cx="6492240" cy="1170432"/>
+          </a:xfrm>
+          <a:prstGeom prst="roundRect">
+            <a:avLst/>
+          </a:prstGeom>
+          <a:solidFill>
+            <a:srgbClr val="131A33"/>
+          </a:solidFill>
+          <a:ln w="19050">
+            <a:solidFill>
+              <a:srgbClr val="30416C"/>
+            </a:solidFill>
+          </a:ln>
+        </p:spPr>
+        <p:style>
+          <a:lnRef idx="1">
+            <a:schemeClr val="accent1"/>
+          </a:lnRef>
+          <a:fillRef idx="3">
+            <a:schemeClr val="accent1"/>
+          </a:fillRef>
+          <a:effectRef idx="2">
+            <a:schemeClr val="accent1"/>
+          </a:effectRef>
+          <a:fontRef idx="minor">
+            <a:schemeClr val="lt1"/>
+          </a:fontRef>
+        </p:style>
+        <p:txBody>
+          <a:bodyPr rtlCol="0" anchor="ctr" wrap="square"/>
+          <a:lstStyle/>
+          <a:p>
+            <a:pPr algn="ctr">
+              <a:defRPr sz="1150" b="1">
+                <a:solidFill>
+                  <a:srgbClr val="63FCC0"/>
+                </a:solidFill>
+                <a:latin typeface="Segoe UI"/>
+              </a:defRPr>
+            </a:pPr>
+            <a:r>
+              <a:t>LEY 1480 DE 2011</a:t>
             </a:r>
           </a:p>
           <a:p>
             <a:pPr>
-              <a:defRPr sz="2000"/>
-            </a:pPr>
-            <a:r>
-              <a:t>RAC 3 Aeronáutica Civil: Reembolso del 100% del tiquete + 30% de compensación mínima obligatoria por sobreventa o cancelación.</a:t>
+              <a:defRPr sz="1250">
+                <a:solidFill>
+                  <a:srgbClr val="F8FAFC"/>
+                </a:solidFill>
+                <a:latin typeface="Segoe UI"/>
+              </a:defRPr>
+            </a:pPr>
+            <a:r>
+              <a:t>Art. 51 (Reversión de pago), Art. 47 (Retracto en 5 días en dinero, sin bonos) y Arts. 7, 8 y 43 (Garantía en promociones).</a:t>
+            </a:r>
+          </a:p>
+        </p:txBody>
+      </p:sp>
+      <p:sp>
+        <p:nvSpPr>
+          <p:cNvPr id="7" name="Rounded Rectangle 6"/>
+          <p:cNvSpPr/>
+          <p:nvPr/>
+        </p:nvSpPr>
+        <p:spPr>
+          <a:xfrm>
+            <a:off x="457200" y="4992624"/>
+            <a:ext cx="6492240" cy="1170432"/>
+          </a:xfrm>
+          <a:prstGeom prst="roundRect">
+            <a:avLst/>
+          </a:prstGeom>
+          <a:solidFill>
+            <a:srgbClr val="131A33"/>
+          </a:solidFill>
+          <a:ln w="19050">
+            <a:solidFill>
+              <a:srgbClr val="30416C"/>
+            </a:solidFill>
+          </a:ln>
+        </p:spPr>
+        <p:style>
+          <a:lnRef idx="1">
+            <a:schemeClr val="accent1"/>
+          </a:lnRef>
+          <a:fillRef idx="3">
+            <a:schemeClr val="accent1"/>
+          </a:fillRef>
+          <a:effectRef idx="2">
+            <a:schemeClr val="accent1"/>
+          </a:effectRef>
+          <a:fontRef idx="minor">
+            <a:schemeClr val="lt1"/>
+          </a:fontRef>
+        </p:style>
+        <p:txBody>
+          <a:bodyPr rtlCol="0" anchor="ctr" wrap="square"/>
+          <a:lstStyle/>
+          <a:p>
+            <a:pPr algn="ctr">
+              <a:defRPr sz="1150" b="1">
+                <a:solidFill>
+                  <a:srgbClr val="63FCC0"/>
+                </a:solidFill>
+                <a:latin typeface="Segoe UI"/>
+              </a:defRPr>
+            </a:pPr>
+            <a:r>
+              <a:t>DECRETO 587 DE 2016 Y RAC 3</a:t>
+            </a:r>
+          </a:p>
+          <a:p>
+            <a:pPr>
+              <a:defRPr sz="1250">
+                <a:solidFill>
+                  <a:srgbClr val="F8FAFC"/>
+                </a:solidFill>
+                <a:latin typeface="Segoe UI"/>
+              </a:defRPr>
+            </a:pPr>
+            <a:r>
+              <a:t>Art. 2.2.2.51.4 (5 días para avisar) → Art. 2.2.2.51.5 (15 días para que el banco abone el 100%) + RAC 3 Aerocivil (30% extra).</a:t>
+            </a:r>
+          </a:p>
+        </p:txBody>
+      </p:sp>
+      <p:pic>
+        <p:nvPicPr>
+          <p:cNvPr id="8" name="Picture 7" descr="image.png"/>
+          <p:cNvPicPr>
+            <a:picLocks noChangeAspect="1"/>
+          </p:cNvPicPr>
+          <p:nvPr/>
+        </p:nvPicPr>
+        <p:blipFill>
+          <a:blip r:embed="rId2"/>
+          <a:stretch>
+            <a:fillRect/>
+          </a:stretch>
+        </p:blipFill>
+        <p:spPr>
+          <a:xfrm>
+            <a:off x="7178040" y="1051560"/>
+            <a:ext cx="4553712" cy="3348318"/>
+          </a:xfrm>
+          <a:prstGeom prst="rect">
+            <a:avLst/>
+          </a:prstGeom>
+        </p:spPr>
+      </p:pic>
+      <p:sp>
+        <p:nvSpPr>
+          <p:cNvPr id="9" name="TextBox 8"/>
+          <p:cNvSpPr txBox="1"/>
+          <p:nvPr/>
+        </p:nvSpPr>
+        <p:spPr>
+          <a:xfrm>
+            <a:off x="457200" y="6355080"/>
+            <a:ext cx="11277295" cy="320040"/>
+          </a:xfrm>
+          <a:prstGeom prst="rect">
+            <a:avLst/>
+          </a:prstGeom>
+          <a:noFill/>
+        </p:spPr>
+        <p:txBody>
+          <a:bodyPr wrap="none">
+            <a:spAutoFit/>
+          </a:bodyPr>
+          <a:lstStyle/>
+          <a:p>
+            <a:pPr>
+              <a:defRPr sz="1000">
+                <a:solidFill>
+                  <a:srgbClr val="94A3B8"/>
+                </a:solidFill>
+                <a:latin typeface="Segoe UI"/>
+              </a:defRPr>
+            </a:pPr>
+            <a:r>
+              <a:t>ReversoYa Colombia · Ley 1480 de 2011 · Decreto 587 de 2016 · RAC 3 Aerocivil   |   Diapositiva 3 de 10</a:t>
             </a:r>
           </a:p>
         </p:txBody>
@@ -4497,53 +5865,411 @@
       <p:grpSpPr/>
       <p:sp>
         <p:nvSpPr>
-          <p:cNvPr id="2" name="Title 1"/>
-          <p:cNvSpPr>
-            <a:spLocks noGrp="1"/>
-          </p:cNvSpPr>
-          <p:nvPr>
-            <p:ph type="title"/>
-          </p:nvPr>
-        </p:nvSpPr>
-        <p:spPr/>
-        <p:txBody>
-          <a:bodyPr/>
-          <a:lstStyle/>
-          <a:p>
-            <a:r>
-              <a:t>Slide 4 (03:15-04:15): Público Objetivo — ¿A quién está dirigido?</a:t>
-            </a:r>
-          </a:p>
-        </p:txBody>
-      </p:sp>
-      <p:sp>
-        <p:nvSpPr>
-          <p:cNvPr id="3" name="Content Placeholder 2"/>
-          <p:cNvSpPr>
-            <a:spLocks noGrp="1"/>
-          </p:cNvSpPr>
-          <p:nvPr>
-            <p:ph idx="1"/>
-          </p:nvPr>
-        </p:nvSpPr>
-        <p:spPr/>
-        <p:txBody>
-          <a:bodyPr/>
+          <p:cNvPr id="2" name="Rectangle 1"/>
+          <p:cNvSpPr/>
+          <p:nvPr/>
+        </p:nvSpPr>
+        <p:spPr>
+          <a:xfrm>
+            <a:off x="0" y="0"/>
+            <a:ext cx="12191695" cy="6858000"/>
+          </a:xfrm>
+          <a:prstGeom prst="rect">
+            <a:avLst/>
+          </a:prstGeom>
+          <a:solidFill>
+            <a:srgbClr val="0B132B"/>
+          </a:solidFill>
+          <a:ln>
+            <a:noFill/>
+          </a:ln>
+        </p:spPr>
+        <p:style>
+          <a:lnRef idx="1">
+            <a:schemeClr val="accent1"/>
+          </a:lnRef>
+          <a:fillRef idx="3">
+            <a:schemeClr val="accent1"/>
+          </a:fillRef>
+          <a:effectRef idx="2">
+            <a:schemeClr val="accent1"/>
+          </a:effectRef>
+          <a:fontRef idx="minor">
+            <a:schemeClr val="lt1"/>
+          </a:fontRef>
+        </p:style>
+        <p:txBody>
+          <a:bodyPr rtlCol="0" anchor="ctr"/>
+          <a:lstStyle/>
+          <a:p>
+            <a:pPr algn="ctr"/>
+          </a:p>
+        </p:txBody>
+      </p:sp>
+      <p:sp>
+        <p:nvSpPr>
+          <p:cNvPr id="3" name="Rounded Rectangle 2"/>
+          <p:cNvSpPr/>
+          <p:nvPr/>
+        </p:nvSpPr>
+        <p:spPr>
+          <a:xfrm>
+            <a:off x="457200" y="320040"/>
+            <a:ext cx="11277295" cy="502920"/>
+          </a:xfrm>
+          <a:prstGeom prst="roundRect">
+            <a:avLst/>
+          </a:prstGeom>
+          <a:solidFill>
+            <a:srgbClr val="131A33"/>
+          </a:solidFill>
+          <a:ln w="15240">
+            <a:solidFill>
+              <a:srgbClr val="00C48C"/>
+            </a:solidFill>
+          </a:ln>
+        </p:spPr>
+        <p:style>
+          <a:lnRef idx="1">
+            <a:schemeClr val="accent1"/>
+          </a:lnRef>
+          <a:fillRef idx="3">
+            <a:schemeClr val="accent1"/>
+          </a:fillRef>
+          <a:effectRef idx="2">
+            <a:schemeClr val="accent1"/>
+          </a:effectRef>
+          <a:fontRef idx="minor">
+            <a:schemeClr val="lt1"/>
+          </a:fontRef>
+        </p:style>
+        <p:txBody>
+          <a:bodyPr rtlCol="0" anchor="ctr" wrap="square"/>
+          <a:lstStyle/>
+          <a:p>
+            <a:pPr algn="ctr">
+              <a:defRPr sz="1100" b="1">
+                <a:solidFill>
+                  <a:srgbClr val="63FCC0"/>
+                </a:solidFill>
+                <a:latin typeface="Segoe UI"/>
+              </a:defRPr>
+            </a:pPr>
+            <a:r>
+              <a:t>DIAPOSITIVA 4 DE 10 · 03:15 – 04:15 (60s)   |   3. PÚBLICO OBJETIVO</a:t>
+            </a:r>
+          </a:p>
+        </p:txBody>
+      </p:sp>
+      <p:sp>
+        <p:nvSpPr>
+          <p:cNvPr id="4" name="TextBox 3"/>
+          <p:cNvSpPr txBox="1"/>
+          <p:nvPr/>
+        </p:nvSpPr>
+        <p:spPr>
+          <a:xfrm>
+            <a:off x="457200" y="960120"/>
+            <a:ext cx="6492240" cy="1325880"/>
+          </a:xfrm>
+          <a:prstGeom prst="rect">
+            <a:avLst/>
+          </a:prstGeom>
+          <a:noFill/>
+        </p:spPr>
+        <p:txBody>
+          <a:bodyPr wrap="square">
+            <a:spAutoFit/>
+          </a:bodyPr>
           <a:lstStyle/>
           <a:p>
             <a:pPr>
-              <a:defRPr sz="2000"/>
-            </a:pPr>
-            <a:r>
-              <a:t>Público B2C (Ciudadanos): Colombianos de 18 a 55 años (estratos 2 al 5) que compran online o en redes con PSE, Nequi, Daviplata o tarjetas ($80.000 a $4.000.000 COP).</a:t>
+              <a:defRPr sz="2300" b="1">
+                <a:solidFill>
+                  <a:srgbClr val="FFFFFF"/>
+                </a:solidFill>
+                <a:latin typeface="Segoe UI"/>
+              </a:defRPr>
+            </a:pPr>
+            <a:r>
+              <a:t>Público Objetivo: Compradores digitales y ecosistema B2B</a:t>
             </a:r>
           </a:p>
           <a:p>
             <a:pPr>
-              <a:defRPr sz="2000"/>
-            </a:pPr>
-            <a:r>
-              <a:t>Público B2B (Aliados): Pasarelas de pago (Wompi, Bold, Mercado Pago) y comercios formales que buscan conciliar antes de recibir multas SIC de hasta 2.000 SMLMV (Art. 61 Ley 1480).</a:t>
+              <a:defRPr sz="1250">
+                <a:solidFill>
+                  <a:srgbClr val="CBD5E1"/>
+                </a:solidFill>
+                <a:latin typeface="Segoe UI"/>
+              </a:defRPr>
+            </a:pPr>
+            <a:r>
+              <a:t>Diseñado para ciudadanos sin conocimientos jurídicos y para el ecosistema de pagos electrónicos:</a:t>
+            </a:r>
+          </a:p>
+        </p:txBody>
+      </p:sp>
+      <p:sp>
+        <p:nvSpPr>
+          <p:cNvPr id="5" name="Rounded Rectangle 4"/>
+          <p:cNvSpPr/>
+          <p:nvPr/>
+        </p:nvSpPr>
+        <p:spPr>
+          <a:xfrm>
+            <a:off x="457200" y="2395728"/>
+            <a:ext cx="6492240" cy="1170432"/>
+          </a:xfrm>
+          <a:prstGeom prst="roundRect">
+            <a:avLst/>
+          </a:prstGeom>
+          <a:solidFill>
+            <a:srgbClr val="131A33"/>
+          </a:solidFill>
+          <a:ln w="19050">
+            <a:solidFill>
+              <a:srgbClr val="00C48C"/>
+            </a:solidFill>
+          </a:ln>
+        </p:spPr>
+        <p:style>
+          <a:lnRef idx="1">
+            <a:schemeClr val="accent1"/>
+          </a:lnRef>
+          <a:fillRef idx="3">
+            <a:schemeClr val="accent1"/>
+          </a:fillRef>
+          <a:effectRef idx="2">
+            <a:schemeClr val="accent1"/>
+          </a:effectRef>
+          <a:fontRef idx="minor">
+            <a:schemeClr val="lt1"/>
+          </a:fontRef>
+        </p:style>
+        <p:txBody>
+          <a:bodyPr rtlCol="0" anchor="ctr" wrap="square"/>
+          <a:lstStyle/>
+          <a:p>
+            <a:pPr algn="ctr">
+              <a:defRPr sz="1150" b="1">
+                <a:solidFill>
+                  <a:srgbClr val="63FCC0"/>
+                </a:solidFill>
+                <a:latin typeface="Segoe UI"/>
+              </a:defRPr>
+            </a:pPr>
+            <a:r>
+              <a:t>SEGMENTO B2C (CIUDADANOS)</a:t>
+            </a:r>
+          </a:p>
+          <a:p>
+            <a:pPr>
+              <a:defRPr sz="1250">
+                <a:solidFill>
+                  <a:srgbClr val="F8FAFC"/>
+                </a:solidFill>
+                <a:latin typeface="Segoe UI"/>
+              </a:defRPr>
+            </a:pPr>
+            <a:r>
+              <a:t>Colombianos de 18 a 55 años (estratos 2 al 5) que compran online, en Instagram/WhatsApp o aerolíneas.</a:t>
+            </a:r>
+          </a:p>
+        </p:txBody>
+      </p:sp>
+      <p:sp>
+        <p:nvSpPr>
+          <p:cNvPr id="6" name="Rounded Rectangle 5"/>
+          <p:cNvSpPr/>
+          <p:nvPr/>
+        </p:nvSpPr>
+        <p:spPr>
+          <a:xfrm>
+            <a:off x="457200" y="3694176"/>
+            <a:ext cx="6492240" cy="1170432"/>
+          </a:xfrm>
+          <a:prstGeom prst="roundRect">
+            <a:avLst/>
+          </a:prstGeom>
+          <a:solidFill>
+            <a:srgbClr val="131A33"/>
+          </a:solidFill>
+          <a:ln w="19050">
+            <a:solidFill>
+              <a:srgbClr val="30416C"/>
+            </a:solidFill>
+          </a:ln>
+        </p:spPr>
+        <p:style>
+          <a:lnRef idx="1">
+            <a:schemeClr val="accent1"/>
+          </a:lnRef>
+          <a:fillRef idx="3">
+            <a:schemeClr val="accent1"/>
+          </a:fillRef>
+          <a:effectRef idx="2">
+            <a:schemeClr val="accent1"/>
+          </a:effectRef>
+          <a:fontRef idx="minor">
+            <a:schemeClr val="lt1"/>
+          </a:fontRef>
+        </p:style>
+        <p:txBody>
+          <a:bodyPr rtlCol="0" anchor="ctr" wrap="square"/>
+          <a:lstStyle/>
+          <a:p>
+            <a:pPr algn="ctr">
+              <a:defRPr sz="1150" b="1">
+                <a:solidFill>
+                  <a:srgbClr val="63FCC0"/>
+                </a:solidFill>
+                <a:latin typeface="Segoe UI"/>
+              </a:defRPr>
+            </a:pPr>
+            <a:r>
+              <a:t>MEDIOS Y CUANTÍAS</a:t>
+            </a:r>
+          </a:p>
+          <a:p>
+            <a:pPr>
+              <a:defRPr sz="1250">
+                <a:solidFill>
+                  <a:srgbClr val="F8FAFC"/>
+                </a:solidFill>
+                <a:latin typeface="Segoe UI"/>
+              </a:defRPr>
+            </a:pPr>
+            <a:r>
+              <a:t>Usuarios de PSE, Nequi, Daviplata y tarjetas con reclamos entre $80.000 y $4.000.000 COP.</a:t>
+            </a:r>
+          </a:p>
+        </p:txBody>
+      </p:sp>
+      <p:sp>
+        <p:nvSpPr>
+          <p:cNvPr id="7" name="Rounded Rectangle 6"/>
+          <p:cNvSpPr/>
+          <p:nvPr/>
+        </p:nvSpPr>
+        <p:spPr>
+          <a:xfrm>
+            <a:off x="457200" y="4992624"/>
+            <a:ext cx="6492240" cy="1170432"/>
+          </a:xfrm>
+          <a:prstGeom prst="roundRect">
+            <a:avLst/>
+          </a:prstGeom>
+          <a:solidFill>
+            <a:srgbClr val="131A33"/>
+          </a:solidFill>
+          <a:ln w="19050">
+            <a:solidFill>
+              <a:srgbClr val="30416C"/>
+            </a:solidFill>
+          </a:ln>
+        </p:spPr>
+        <p:style>
+          <a:lnRef idx="1">
+            <a:schemeClr val="accent1"/>
+          </a:lnRef>
+          <a:fillRef idx="3">
+            <a:schemeClr val="accent1"/>
+          </a:fillRef>
+          <a:effectRef idx="2">
+            <a:schemeClr val="accent1"/>
+          </a:effectRef>
+          <a:fontRef idx="minor">
+            <a:schemeClr val="lt1"/>
+          </a:fontRef>
+        </p:style>
+        <p:txBody>
+          <a:bodyPr rtlCol="0" anchor="ctr" wrap="square"/>
+          <a:lstStyle/>
+          <a:p>
+            <a:pPr algn="ctr">
+              <a:defRPr sz="1150" b="1">
+                <a:solidFill>
+                  <a:srgbClr val="63FCC0"/>
+                </a:solidFill>
+                <a:latin typeface="Segoe UI"/>
+              </a:defRPr>
+            </a:pPr>
+            <a:r>
+              <a:t>SEGMENTO B2B (COMERCIOS Y PASARELAS)</a:t>
+            </a:r>
+          </a:p>
+          <a:p>
+            <a:pPr>
+              <a:defRPr sz="1250">
+                <a:solidFill>
+                  <a:srgbClr val="F8FAFC"/>
+                </a:solidFill>
+                <a:latin typeface="Segoe UI"/>
+              </a:defRPr>
+            </a:pPr>
+            <a:r>
+              <a:t>Pasarelas (Wompi, Bold, Mercado Pago) y comercios que previenen demandas SIC y multas de hasta 2.000 SMLMV.</a:t>
+            </a:r>
+          </a:p>
+        </p:txBody>
+      </p:sp>
+      <p:pic>
+        <p:nvPicPr>
+          <p:cNvPr id="8" name="Picture 7" descr="image.png"/>
+          <p:cNvPicPr>
+            <a:picLocks noChangeAspect="1"/>
+          </p:cNvPicPr>
+          <p:nvPr/>
+        </p:nvPicPr>
+        <p:blipFill>
+          <a:blip r:embed="rId2"/>
+          <a:stretch>
+            <a:fillRect/>
+          </a:stretch>
+        </p:blipFill>
+        <p:spPr>
+          <a:xfrm>
+            <a:off x="7178040" y="1051560"/>
+            <a:ext cx="4553712" cy="3348318"/>
+          </a:xfrm>
+          <a:prstGeom prst="rect">
+            <a:avLst/>
+          </a:prstGeom>
+        </p:spPr>
+      </p:pic>
+      <p:sp>
+        <p:nvSpPr>
+          <p:cNvPr id="9" name="TextBox 8"/>
+          <p:cNvSpPr txBox="1"/>
+          <p:nvPr/>
+        </p:nvSpPr>
+        <p:spPr>
+          <a:xfrm>
+            <a:off x="457200" y="6355080"/>
+            <a:ext cx="11277295" cy="320040"/>
+          </a:xfrm>
+          <a:prstGeom prst="rect">
+            <a:avLst/>
+          </a:prstGeom>
+          <a:noFill/>
+        </p:spPr>
+        <p:txBody>
+          <a:bodyPr wrap="none">
+            <a:spAutoFit/>
+          </a:bodyPr>
+          <a:lstStyle/>
+          <a:p>
+            <a:pPr>
+              <a:defRPr sz="1000">
+                <a:solidFill>
+                  <a:srgbClr val="94A3B8"/>
+                </a:solidFill>
+                <a:latin typeface="Segoe UI"/>
+              </a:defRPr>
+            </a:pPr>
+            <a:r>
+              <a:t>ReversoYa Colombia · Ley 1480 de 2011 · Decreto 587 de 2016 · RAC 3 Aerocivil   |   Diapositiva 4 de 10</a:t>
             </a:r>
           </a:p>
         </p:txBody>
@@ -4568,61 +6294,411 @@
       <p:grpSpPr/>
       <p:sp>
         <p:nvSpPr>
-          <p:cNvPr id="2" name="Title 1"/>
-          <p:cNvSpPr>
-            <a:spLocks noGrp="1"/>
-          </p:cNvSpPr>
-          <p:nvPr>
-            <p:ph type="title"/>
-          </p:nvPr>
-        </p:nvSpPr>
-        <p:spPr/>
-        <p:txBody>
-          <a:bodyPr/>
-          <a:lstStyle/>
-          <a:p>
-            <a:r>
-              <a:t>Slide 5 (04:15-05:30): Solución y Flujo — Pantallas 1 y 2 (Diseño Stitch)</a:t>
-            </a:r>
-          </a:p>
-        </p:txBody>
-      </p:sp>
-      <p:sp>
-        <p:nvSpPr>
-          <p:cNvPr id="3" name="Content Placeholder 2"/>
-          <p:cNvSpPr>
-            <a:spLocks noGrp="1"/>
-          </p:cNvSpPr>
-          <p:nvPr>
-            <p:ph idx="1"/>
-          </p:nvPr>
-        </p:nvSpPr>
-        <p:spPr/>
-        <p:txBody>
-          <a:bodyPr/>
+          <p:cNvPr id="2" name="Rectangle 1"/>
+          <p:cNvSpPr/>
+          <p:nvPr/>
+        </p:nvSpPr>
+        <p:spPr>
+          <a:xfrm>
+            <a:off x="0" y="0"/>
+            <a:ext cx="12191695" cy="6858000"/>
+          </a:xfrm>
+          <a:prstGeom prst="rect">
+            <a:avLst/>
+          </a:prstGeom>
+          <a:solidFill>
+            <a:srgbClr val="0B132B"/>
+          </a:solidFill>
+          <a:ln>
+            <a:noFill/>
+          </a:ln>
+        </p:spPr>
+        <p:style>
+          <a:lnRef idx="1">
+            <a:schemeClr val="accent1"/>
+          </a:lnRef>
+          <a:fillRef idx="3">
+            <a:schemeClr val="accent1"/>
+          </a:fillRef>
+          <a:effectRef idx="2">
+            <a:schemeClr val="accent1"/>
+          </a:effectRef>
+          <a:fontRef idx="minor">
+            <a:schemeClr val="lt1"/>
+          </a:fontRef>
+        </p:style>
+        <p:txBody>
+          <a:bodyPr rtlCol="0" anchor="ctr"/>
+          <a:lstStyle/>
+          <a:p>
+            <a:pPr algn="ctr"/>
+          </a:p>
+        </p:txBody>
+      </p:sp>
+      <p:sp>
+        <p:nvSpPr>
+          <p:cNvPr id="3" name="Rounded Rectangle 2"/>
+          <p:cNvSpPr/>
+          <p:nvPr/>
+        </p:nvSpPr>
+        <p:spPr>
+          <a:xfrm>
+            <a:off x="457200" y="320040"/>
+            <a:ext cx="11277295" cy="502920"/>
+          </a:xfrm>
+          <a:prstGeom prst="roundRect">
+            <a:avLst/>
+          </a:prstGeom>
+          <a:solidFill>
+            <a:srgbClr val="131A33"/>
+          </a:solidFill>
+          <a:ln w="15240">
+            <a:solidFill>
+              <a:srgbClr val="00C48C"/>
+            </a:solidFill>
+          </a:ln>
+        </p:spPr>
+        <p:style>
+          <a:lnRef idx="1">
+            <a:schemeClr val="accent1"/>
+          </a:lnRef>
+          <a:fillRef idx="3">
+            <a:schemeClr val="accent1"/>
+          </a:fillRef>
+          <a:effectRef idx="2">
+            <a:schemeClr val="accent1"/>
+          </a:effectRef>
+          <a:fontRef idx="minor">
+            <a:schemeClr val="lt1"/>
+          </a:fontRef>
+        </p:style>
+        <p:txBody>
+          <a:bodyPr rtlCol="0" anchor="ctr" wrap="square"/>
+          <a:lstStyle/>
+          <a:p>
+            <a:pPr algn="ctr">
+              <a:defRPr sz="1100" b="1">
+                <a:solidFill>
+                  <a:srgbClr val="63FCC0"/>
+                </a:solidFill>
+                <a:latin typeface="Segoe UI"/>
+              </a:defRPr>
+            </a:pPr>
+            <a:r>
+              <a:t>DIAPOSITIVA 5 DE 10 · 04:15 – 05:30 (75s)   |   4. SOLUCIÓN Y FLUJO DE PANTALLAS (PARTE 1)</a:t>
+            </a:r>
+          </a:p>
+        </p:txBody>
+      </p:sp>
+      <p:sp>
+        <p:nvSpPr>
+          <p:cNvPr id="4" name="TextBox 3"/>
+          <p:cNvSpPr txBox="1"/>
+          <p:nvPr/>
+        </p:nvSpPr>
+        <p:spPr>
+          <a:xfrm>
+            <a:off x="457200" y="960120"/>
+            <a:ext cx="6492240" cy="1325880"/>
+          </a:xfrm>
+          <a:prstGeom prst="rect">
+            <a:avLst/>
+          </a:prstGeom>
+          <a:noFill/>
+        </p:spPr>
+        <p:txBody>
+          <a:bodyPr wrap="square">
+            <a:spAutoFit/>
+          </a:bodyPr>
           <a:lstStyle/>
           <a:p>
             <a:pPr>
-              <a:defRPr sz="2000"/>
-            </a:pPr>
-            <a:r>
-              <a:t>Inspiración Symplifica: Convertimos un trámite procesal en una calculadora guiada de 4 pantallas.</a:t>
+              <a:defRPr sz="2300" b="1">
+                <a:solidFill>
+                  <a:srgbClr val="FFFFFF"/>
+                </a:solidFill>
+                <a:latin typeface="Segoe UI"/>
+              </a:defRPr>
+            </a:pPr>
+            <a:r>
+              <a:t>Flujo Guiado: Pantallas 1 y 2 (Plazo y Auditoría de Excusas)</a:t>
             </a:r>
           </a:p>
           <a:p>
             <a:pPr>
-              <a:defRPr sz="2000"/>
-            </a:pPr>
-            <a:r>
-              <a:t>Pantalla 1 (Escáner de Compra, Vuelo y Plazo de 5 Días): Calcula el monto exigible y verifica si aplica orden directa al banco (&lt;=5 días) o demanda SIC (&gt;5 días).</a:t>
+              <a:defRPr sz="1250">
+                <a:solidFill>
+                  <a:srgbClr val="CBD5E1"/>
+                </a:solidFill>
+                <a:latin typeface="Segoe UI"/>
+              </a:defRPr>
+            </a:pPr>
+            <a:r>
+              <a:t>Inspirado en las calculadoras laborales paso a paso, elimina la complejidad técnica en 4 pasos:</a:t>
+            </a:r>
+          </a:p>
+        </p:txBody>
+      </p:sp>
+      <p:sp>
+        <p:nvSpPr>
+          <p:cNvPr id="5" name="Rounded Rectangle 4"/>
+          <p:cNvSpPr/>
+          <p:nvPr/>
+        </p:nvSpPr>
+        <p:spPr>
+          <a:xfrm>
+            <a:off x="457200" y="2395728"/>
+            <a:ext cx="6492240" cy="1170432"/>
+          </a:xfrm>
+          <a:prstGeom prst="roundRect">
+            <a:avLst/>
+          </a:prstGeom>
+          <a:solidFill>
+            <a:srgbClr val="131A33"/>
+          </a:solidFill>
+          <a:ln w="19050">
+            <a:solidFill>
+              <a:srgbClr val="00C48C"/>
+            </a:solidFill>
+          </a:ln>
+        </p:spPr>
+        <p:style>
+          <a:lnRef idx="1">
+            <a:schemeClr val="accent1"/>
+          </a:lnRef>
+          <a:fillRef idx="3">
+            <a:schemeClr val="accent1"/>
+          </a:fillRef>
+          <a:effectRef idx="2">
+            <a:schemeClr val="accent1"/>
+          </a:effectRef>
+          <a:fontRef idx="minor">
+            <a:schemeClr val="lt1"/>
+          </a:fontRef>
+        </p:style>
+        <p:txBody>
+          <a:bodyPr rtlCol="0" anchor="ctr" wrap="square"/>
+          <a:lstStyle/>
+          <a:p>
+            <a:pPr algn="ctr">
+              <a:defRPr sz="1150" b="1">
+                <a:solidFill>
+                  <a:srgbClr val="63FCC0"/>
+                </a:solidFill>
+                <a:latin typeface="Segoe UI"/>
+              </a:defRPr>
+            </a:pPr>
+            <a:r>
+              <a:t>PANTALLA 1: DATOS Y PLAZO DE 5 DÍAS</a:t>
             </a:r>
           </a:p>
           <a:p>
             <a:pPr>
-              <a:defRPr sz="2000"/>
-            </a:pPr>
-            <a:r>
-              <a:t>Pantalla 2 (Detector de Excusas Ilegales + Bóveda SHA-256): Escanea el chat de WhatsApp, anula excusas ilegales (Art. 43 y 47) y certifica capturas bajo la Ley 527 de 1999.</a:t>
+              <a:defRPr sz="1250">
+                <a:solidFill>
+                  <a:srgbClr val="F8FAFC"/>
+                </a:solidFill>
+                <a:latin typeface="Segoe UI"/>
+              </a:defRPr>
+            </a:pPr>
+            <a:r>
+              <a:t>Selecciona causal, monto, medio de pago (PSE/Nequi/Tarjeta) y verifica si aplica reversión bancaria o ruta SIC.</a:t>
+            </a:r>
+          </a:p>
+        </p:txBody>
+      </p:sp>
+      <p:sp>
+        <p:nvSpPr>
+          <p:cNvPr id="6" name="Rounded Rectangle 5"/>
+          <p:cNvSpPr/>
+          <p:nvPr/>
+        </p:nvSpPr>
+        <p:spPr>
+          <a:xfrm>
+            <a:off x="457200" y="3694176"/>
+            <a:ext cx="6492240" cy="1170432"/>
+          </a:xfrm>
+          <a:prstGeom prst="roundRect">
+            <a:avLst/>
+          </a:prstGeom>
+          <a:solidFill>
+            <a:srgbClr val="131A33"/>
+          </a:solidFill>
+          <a:ln w="19050">
+            <a:solidFill>
+              <a:srgbClr val="30416C"/>
+            </a:solidFill>
+          </a:ln>
+        </p:spPr>
+        <p:style>
+          <a:lnRef idx="1">
+            <a:schemeClr val="accent1"/>
+          </a:lnRef>
+          <a:fillRef idx="3">
+            <a:schemeClr val="accent1"/>
+          </a:fillRef>
+          <a:effectRef idx="2">
+            <a:schemeClr val="accent1"/>
+          </a:effectRef>
+          <a:fontRef idx="minor">
+            <a:schemeClr val="lt1"/>
+          </a:fontRef>
+        </p:style>
+        <p:txBody>
+          <a:bodyPr rtlCol="0" anchor="ctr" wrap="square"/>
+          <a:lstStyle/>
+          <a:p>
+            <a:pPr algn="ctr">
+              <a:defRPr sz="1150" b="1">
+                <a:solidFill>
+                  <a:srgbClr val="63FCC0"/>
+                </a:solidFill>
+                <a:latin typeface="Segoe UI"/>
+              </a:defRPr>
+            </a:pPr>
+            <a:r>
+              <a:t>PANTALLA 2: DETECTOR DE EXCUSAS</a:t>
+            </a:r>
+          </a:p>
+          <a:p>
+            <a:pPr>
+              <a:defRPr sz="1250">
+                <a:solidFill>
+                  <a:srgbClr val="F8FAFC"/>
+                </a:solidFill>
+                <a:latin typeface="Segoe UI"/>
+              </a:defRPr>
+            </a:pPr>
+            <a:r>
+              <a:t>Analiza la respuesta de WhatsApp o correo e identifica las cláusulas nulas de pleno derecho (Arts. 43, 47 y 50 Ley 1480).</a:t>
+            </a:r>
+          </a:p>
+        </p:txBody>
+      </p:sp>
+      <p:sp>
+        <p:nvSpPr>
+          <p:cNvPr id="7" name="Rounded Rectangle 6"/>
+          <p:cNvSpPr/>
+          <p:nvPr/>
+        </p:nvSpPr>
+        <p:spPr>
+          <a:xfrm>
+            <a:off x="457200" y="4992624"/>
+            <a:ext cx="6492240" cy="1170432"/>
+          </a:xfrm>
+          <a:prstGeom prst="roundRect">
+            <a:avLst/>
+          </a:prstGeom>
+          <a:solidFill>
+            <a:srgbClr val="131A33"/>
+          </a:solidFill>
+          <a:ln w="19050">
+            <a:solidFill>
+              <a:srgbClr val="30416C"/>
+            </a:solidFill>
+          </a:ln>
+        </p:spPr>
+        <p:style>
+          <a:lnRef idx="1">
+            <a:schemeClr val="accent1"/>
+          </a:lnRef>
+          <a:fillRef idx="3">
+            <a:schemeClr val="accent1"/>
+          </a:fillRef>
+          <a:effectRef idx="2">
+            <a:schemeClr val="accent1"/>
+          </a:effectRef>
+          <a:fontRef idx="minor">
+            <a:schemeClr val="lt1"/>
+          </a:fontRef>
+        </p:style>
+        <p:txBody>
+          <a:bodyPr rtlCol="0" anchor="ctr" wrap="square"/>
+          <a:lstStyle/>
+          <a:p>
+            <a:pPr algn="ctr">
+              <a:defRPr sz="1150" b="1">
+                <a:solidFill>
+                  <a:srgbClr val="63FCC0"/>
+                </a:solidFill>
+                <a:latin typeface="Segoe UI"/>
+              </a:defRPr>
+            </a:pPr>
+            <a:r>
+              <a:t>VALIDEZ PROBATORIA (LEY 527 DE 1999)</a:t>
+            </a:r>
+          </a:p>
+          <a:p>
+            <a:pPr>
+              <a:defRPr sz="1250">
+                <a:solidFill>
+                  <a:srgbClr val="F8FAFC"/>
+                </a:solidFill>
+                <a:latin typeface="Segoe UI"/>
+              </a:defRPr>
+            </a:pPr>
+            <a:r>
+              <a:t>Calcula la huella criptográfica SHA-256 de los comprobantes y capturas de pantalla para el anexo probatorio.</a:t>
+            </a:r>
+          </a:p>
+        </p:txBody>
+      </p:sp>
+      <p:pic>
+        <p:nvPicPr>
+          <p:cNvPr id="8" name="Picture 7" descr="image.png"/>
+          <p:cNvPicPr>
+            <a:picLocks noChangeAspect="1"/>
+          </p:cNvPicPr>
+          <p:nvPr/>
+        </p:nvPicPr>
+        <p:blipFill>
+          <a:blip r:embed="rId2"/>
+          <a:stretch>
+            <a:fillRect/>
+          </a:stretch>
+        </p:blipFill>
+        <p:spPr>
+          <a:xfrm>
+            <a:off x="7178040" y="1051560"/>
+            <a:ext cx="4553712" cy="3348318"/>
+          </a:xfrm>
+          <a:prstGeom prst="rect">
+            <a:avLst/>
+          </a:prstGeom>
+        </p:spPr>
+      </p:pic>
+      <p:sp>
+        <p:nvSpPr>
+          <p:cNvPr id="9" name="TextBox 8"/>
+          <p:cNvSpPr txBox="1"/>
+          <p:nvPr/>
+        </p:nvSpPr>
+        <p:spPr>
+          <a:xfrm>
+            <a:off x="457200" y="6355080"/>
+            <a:ext cx="11277295" cy="320040"/>
+          </a:xfrm>
+          <a:prstGeom prst="rect">
+            <a:avLst/>
+          </a:prstGeom>
+          <a:noFill/>
+        </p:spPr>
+        <p:txBody>
+          <a:bodyPr wrap="none">
+            <a:spAutoFit/>
+          </a:bodyPr>
+          <a:lstStyle/>
+          <a:p>
+            <a:pPr>
+              <a:defRPr sz="1000">
+                <a:solidFill>
+                  <a:srgbClr val="94A3B8"/>
+                </a:solidFill>
+                <a:latin typeface="Segoe UI"/>
+              </a:defRPr>
+            </a:pPr>
+            <a:r>
+              <a:t>ReversoYa Colombia · Ley 1480 de 2011 · Decreto 587 de 2016 · RAC 3 Aerocivil   |   Diapositiva 5 de 10</a:t>
             </a:r>
           </a:p>
         </p:txBody>
@@ -4647,53 +6723,411 @@
       <p:grpSpPr/>
       <p:sp>
         <p:nvSpPr>
-          <p:cNvPr id="2" name="Title 1"/>
-          <p:cNvSpPr>
-            <a:spLocks noGrp="1"/>
-          </p:cNvSpPr>
-          <p:nvPr>
-            <p:ph type="title"/>
-          </p:nvPr>
-        </p:nvSpPr>
-        <p:spPr/>
-        <p:txBody>
-          <a:bodyPr/>
-          <a:lstStyle/>
-          <a:p>
-            <a:r>
-              <a:t>Slide 6 (05:30-06:45): Solución y Flujo — Pantallas 3 y 4 (Orden al Banco)</a:t>
-            </a:r>
-          </a:p>
-        </p:txBody>
-      </p:sp>
-      <p:sp>
-        <p:nvSpPr>
-          <p:cNvPr id="3" name="Content Placeholder 2"/>
-          <p:cNvSpPr>
-            <a:spLocks noGrp="1"/>
-          </p:cNvSpPr>
-          <p:nvPr>
-            <p:ph idx="1"/>
-          </p:nvPr>
-        </p:nvSpPr>
-        <p:spPr/>
-        <p:txBody>
-          <a:bodyPr/>
+          <p:cNvPr id="2" name="Rectangle 1"/>
+          <p:cNvSpPr/>
+          <p:nvPr/>
+        </p:nvSpPr>
+        <p:spPr>
+          <a:xfrm>
+            <a:off x="0" y="0"/>
+            <a:ext cx="12191695" cy="6858000"/>
+          </a:xfrm>
+          <a:prstGeom prst="rect">
+            <a:avLst/>
+          </a:prstGeom>
+          <a:solidFill>
+            <a:srgbClr val="0B132B"/>
+          </a:solidFill>
+          <a:ln>
+            <a:noFill/>
+          </a:ln>
+        </p:spPr>
+        <p:style>
+          <a:lnRef idx="1">
+            <a:schemeClr val="accent1"/>
+          </a:lnRef>
+          <a:fillRef idx="3">
+            <a:schemeClr val="accent1"/>
+          </a:fillRef>
+          <a:effectRef idx="2">
+            <a:schemeClr val="accent1"/>
+          </a:effectRef>
+          <a:fontRef idx="minor">
+            <a:schemeClr val="lt1"/>
+          </a:fontRef>
+        </p:style>
+        <p:txBody>
+          <a:bodyPr rtlCol="0" anchor="ctr"/>
+          <a:lstStyle/>
+          <a:p>
+            <a:pPr algn="ctr"/>
+          </a:p>
+        </p:txBody>
+      </p:sp>
+      <p:sp>
+        <p:nvSpPr>
+          <p:cNvPr id="3" name="Rounded Rectangle 2"/>
+          <p:cNvSpPr/>
+          <p:nvPr/>
+        </p:nvSpPr>
+        <p:spPr>
+          <a:xfrm>
+            <a:off x="457200" y="320040"/>
+            <a:ext cx="11277295" cy="502920"/>
+          </a:xfrm>
+          <a:prstGeom prst="roundRect">
+            <a:avLst/>
+          </a:prstGeom>
+          <a:solidFill>
+            <a:srgbClr val="131A33"/>
+          </a:solidFill>
+          <a:ln w="15240">
+            <a:solidFill>
+              <a:srgbClr val="00C48C"/>
+            </a:solidFill>
+          </a:ln>
+        </p:spPr>
+        <p:style>
+          <a:lnRef idx="1">
+            <a:schemeClr val="accent1"/>
+          </a:lnRef>
+          <a:fillRef idx="3">
+            <a:schemeClr val="accent1"/>
+          </a:fillRef>
+          <a:effectRef idx="2">
+            <a:schemeClr val="accent1"/>
+          </a:effectRef>
+          <a:fontRef idx="minor">
+            <a:schemeClr val="lt1"/>
+          </a:fontRef>
+        </p:style>
+        <p:txBody>
+          <a:bodyPr rtlCol="0" anchor="ctr" wrap="square"/>
+          <a:lstStyle/>
+          <a:p>
+            <a:pPr algn="ctr">
+              <a:defRPr sz="1100" b="1">
+                <a:solidFill>
+                  <a:srgbClr val="63FCC0"/>
+                </a:solidFill>
+                <a:latin typeface="Segoe UI"/>
+              </a:defRPr>
+            </a:pPr>
+            <a:r>
+              <a:t>DIAPOSITIVA 6 DE 10 · 05:30 – 06:45 (75s)   |   4. SOLUCIÓN Y FLUJO DE PANTALLAS (PARTE 2)</a:t>
+            </a:r>
+          </a:p>
+        </p:txBody>
+      </p:sp>
+      <p:sp>
+        <p:nvSpPr>
+          <p:cNvPr id="4" name="TextBox 3"/>
+          <p:cNvSpPr txBox="1"/>
+          <p:nvPr/>
+        </p:nvSpPr>
+        <p:spPr>
+          <a:xfrm>
+            <a:off x="457200" y="960120"/>
+            <a:ext cx="6492240" cy="1325880"/>
+          </a:xfrm>
+          <a:prstGeom prst="rect">
+            <a:avLst/>
+          </a:prstGeom>
+          <a:noFill/>
+        </p:spPr>
+        <p:txBody>
+          <a:bodyPr wrap="square">
+            <a:spAutoFit/>
+          </a:bodyPr>
           <a:lstStyle/>
           <a:p>
             <a:pPr>
-              <a:defRPr sz="2000"/>
-            </a:pPr>
-            <a:r>
-              <a:t>Pantalla 3 (Semáforo Legal y 3 Oficios Vinculantes): Genera 1) Orden al Banco/PSE con los requisitos taxativos del Art. 2.2.2.51.3 Dec. 1074/2015, 2) Aviso al Comercio y 3) Demanda SIC.</a:t>
+              <a:defRPr sz="2300" b="1">
+                <a:solidFill>
+                  <a:srgbClr val="FFFFFF"/>
+                </a:solidFill>
+                <a:latin typeface="Segoe UI"/>
+              </a:defRPr>
+            </a:pPr>
+            <a:r>
+              <a:t>Flujo Guiado: Pantallas 3 y 4 (3 Oficios y Reloj de 15 Días)</a:t>
             </a:r>
           </a:p>
           <a:p>
             <a:pPr>
-              <a:defRPr sz="2000"/>
-            </a:pPr>
-            <a:r>
-              <a:t>Pantalla 4 (Radicación Simultánea y Reloj de 15 Días Hábiles): Monitorea el término perentorio del banco y escala a Superfinanciera si no abona al día 15.</a:t>
+              <a:defRPr sz="1250">
+                <a:solidFill>
+                  <a:srgbClr val="CBD5E1"/>
+                </a:solidFill>
+                <a:latin typeface="Segoe UI"/>
+              </a:defRPr>
+            </a:pPr>
+            <a:r>
+              <a:t>Estructura los requisitos taxativos del Art. 2.2.2.51.3 del Decreto 1074 de 2015 para impedir rechazos de forma:</a:t>
+            </a:r>
+          </a:p>
+        </p:txBody>
+      </p:sp>
+      <p:sp>
+        <p:nvSpPr>
+          <p:cNvPr id="5" name="Rounded Rectangle 4"/>
+          <p:cNvSpPr/>
+          <p:nvPr/>
+        </p:nvSpPr>
+        <p:spPr>
+          <a:xfrm>
+            <a:off x="457200" y="2395728"/>
+            <a:ext cx="6492240" cy="1170432"/>
+          </a:xfrm>
+          <a:prstGeom prst="roundRect">
+            <a:avLst/>
+          </a:prstGeom>
+          <a:solidFill>
+            <a:srgbClr val="131A33"/>
+          </a:solidFill>
+          <a:ln w="19050">
+            <a:solidFill>
+              <a:srgbClr val="00C48C"/>
+            </a:solidFill>
+          </a:ln>
+        </p:spPr>
+        <p:style>
+          <a:lnRef idx="1">
+            <a:schemeClr val="accent1"/>
+          </a:lnRef>
+          <a:fillRef idx="3">
+            <a:schemeClr val="accent1"/>
+          </a:fillRef>
+          <a:effectRef idx="2">
+            <a:schemeClr val="accent1"/>
+          </a:effectRef>
+          <a:fontRef idx="minor">
+            <a:schemeClr val="lt1"/>
+          </a:fontRef>
+        </p:style>
+        <p:txBody>
+          <a:bodyPr rtlCol="0" anchor="ctr" wrap="square"/>
+          <a:lstStyle/>
+          <a:p>
+            <a:pPr algn="ctr">
+              <a:defRPr sz="1150" b="1">
+                <a:solidFill>
+                  <a:srgbClr val="63FCC0"/>
+                </a:solidFill>
+                <a:latin typeface="Segoe UI"/>
+              </a:defRPr>
+            </a:pPr>
+            <a:r>
+              <a:t>OFICIO 1: ORDEN VINCULANTE AL BANCO</a:t>
+            </a:r>
+          </a:p>
+          <a:p>
+            <a:pPr>
+              <a:defRPr sz="1250">
+                <a:solidFill>
+                  <a:srgbClr val="F8FAFC"/>
+                </a:solidFill>
+                <a:latin typeface="Segoe UI"/>
+              </a:defRPr>
+            </a:pPr>
+            <a:r>
+              <a:t>Solicitud formal bajo juramento exigiendo la reversión del 100% al instrumento de pago electrónico.</a:t>
+            </a:r>
+          </a:p>
+        </p:txBody>
+      </p:sp>
+      <p:sp>
+        <p:nvSpPr>
+          <p:cNvPr id="6" name="Rounded Rectangle 5"/>
+          <p:cNvSpPr/>
+          <p:nvPr/>
+        </p:nvSpPr>
+        <p:spPr>
+          <a:xfrm>
+            <a:off x="457200" y="3694176"/>
+            <a:ext cx="6492240" cy="1170432"/>
+          </a:xfrm>
+          <a:prstGeom prst="roundRect">
+            <a:avLst/>
+          </a:prstGeom>
+          <a:solidFill>
+            <a:srgbClr val="131A33"/>
+          </a:solidFill>
+          <a:ln w="19050">
+            <a:solidFill>
+              <a:srgbClr val="30416C"/>
+            </a:solidFill>
+          </a:ln>
+        </p:spPr>
+        <p:style>
+          <a:lnRef idx="1">
+            <a:schemeClr val="accent1"/>
+          </a:lnRef>
+          <a:fillRef idx="3">
+            <a:schemeClr val="accent1"/>
+          </a:fillRef>
+          <a:effectRef idx="2">
+            <a:schemeClr val="accent1"/>
+          </a:effectRef>
+          <a:fontRef idx="minor">
+            <a:schemeClr val="lt1"/>
+          </a:fontRef>
+        </p:style>
+        <p:txBody>
+          <a:bodyPr rtlCol="0" anchor="ctr" wrap="square"/>
+          <a:lstStyle/>
+          <a:p>
+            <a:pPr algn="ctr">
+              <a:defRPr sz="1150" b="1">
+                <a:solidFill>
+                  <a:srgbClr val="63FCC0"/>
+                </a:solidFill>
+                <a:latin typeface="Segoe UI"/>
+              </a:defRPr>
+            </a:pPr>
+            <a:r>
+              <a:t>OFICIOS 2 Y 3: COMERCIO Y SIC</a:t>
+            </a:r>
+          </a:p>
+          <a:p>
+            <a:pPr>
+              <a:defRPr sz="1250">
+                <a:solidFill>
+                  <a:srgbClr val="F8FAFC"/>
+                </a:solidFill>
+                <a:latin typeface="Segoe UI"/>
+              </a:defRPr>
+            </a:pPr>
+            <a:r>
+              <a:t>Reclamación directa al proveedor (requisito Art. 58 num. 5) y formato de Demanda de Protección al Consumidor.</a:t>
+            </a:r>
+          </a:p>
+        </p:txBody>
+      </p:sp>
+      <p:sp>
+        <p:nvSpPr>
+          <p:cNvPr id="7" name="Rounded Rectangle 6"/>
+          <p:cNvSpPr/>
+          <p:nvPr/>
+        </p:nvSpPr>
+        <p:spPr>
+          <a:xfrm>
+            <a:off x="457200" y="4992624"/>
+            <a:ext cx="6492240" cy="1170432"/>
+          </a:xfrm>
+          <a:prstGeom prst="roundRect">
+            <a:avLst/>
+          </a:prstGeom>
+          <a:solidFill>
+            <a:srgbClr val="131A33"/>
+          </a:solidFill>
+          <a:ln w="19050">
+            <a:solidFill>
+              <a:srgbClr val="30416C"/>
+            </a:solidFill>
+          </a:ln>
+        </p:spPr>
+        <p:style>
+          <a:lnRef idx="1">
+            <a:schemeClr val="accent1"/>
+          </a:lnRef>
+          <a:fillRef idx="3">
+            <a:schemeClr val="accent1"/>
+          </a:fillRef>
+          <a:effectRef idx="2">
+            <a:schemeClr val="accent1"/>
+          </a:effectRef>
+          <a:fontRef idx="minor">
+            <a:schemeClr val="lt1"/>
+          </a:fontRef>
+        </p:style>
+        <p:txBody>
+          <a:bodyPr rtlCol="0" anchor="ctr" wrap="square"/>
+          <a:lstStyle/>
+          <a:p>
+            <a:pPr algn="ctr">
+              <a:defRPr sz="1150" b="1">
+                <a:solidFill>
+                  <a:srgbClr val="63FCC0"/>
+                </a:solidFill>
+                <a:latin typeface="Segoe UI"/>
+              </a:defRPr>
+            </a:pPr>
+            <a:r>
+              <a:t>PANTALLA 4: CRONÓMETRO DE 15 DÍAS HÁBILES</a:t>
+            </a:r>
+          </a:p>
+          <a:p>
+            <a:pPr>
+              <a:defRPr sz="1250">
+                <a:solidFill>
+                  <a:srgbClr val="F8FAFC"/>
+                </a:solidFill>
+                <a:latin typeface="Segoe UI"/>
+              </a:defRPr>
+            </a:pPr>
+            <a:r>
+              <a:t>Controla el término perentorio del banco (Art. 2.2.2.51.5) y habilita queja ante Superfinanciera si hay mora al día 16.</a:t>
+            </a:r>
+          </a:p>
+        </p:txBody>
+      </p:sp>
+      <p:pic>
+        <p:nvPicPr>
+          <p:cNvPr id="8" name="Picture 7" descr="image.png"/>
+          <p:cNvPicPr>
+            <a:picLocks noChangeAspect="1"/>
+          </p:cNvPicPr>
+          <p:nvPr/>
+        </p:nvPicPr>
+        <p:blipFill>
+          <a:blip r:embed="rId2"/>
+          <a:stretch>
+            <a:fillRect/>
+          </a:stretch>
+        </p:blipFill>
+        <p:spPr>
+          <a:xfrm>
+            <a:off x="7178040" y="1051560"/>
+            <a:ext cx="4553712" cy="3348318"/>
+          </a:xfrm>
+          <a:prstGeom prst="rect">
+            <a:avLst/>
+          </a:prstGeom>
+        </p:spPr>
+      </p:pic>
+      <p:sp>
+        <p:nvSpPr>
+          <p:cNvPr id="9" name="TextBox 8"/>
+          <p:cNvSpPr txBox="1"/>
+          <p:nvPr/>
+        </p:nvSpPr>
+        <p:spPr>
+          <a:xfrm>
+            <a:off x="457200" y="6355080"/>
+            <a:ext cx="11277295" cy="320040"/>
+          </a:xfrm>
+          <a:prstGeom prst="rect">
+            <a:avLst/>
+          </a:prstGeom>
+          <a:noFill/>
+        </p:spPr>
+        <p:txBody>
+          <a:bodyPr wrap="none">
+            <a:spAutoFit/>
+          </a:bodyPr>
+          <a:lstStyle/>
+          <a:p>
+            <a:pPr>
+              <a:defRPr sz="1000">
+                <a:solidFill>
+                  <a:srgbClr val="94A3B8"/>
+                </a:solidFill>
+                <a:latin typeface="Segoe UI"/>
+              </a:defRPr>
+            </a:pPr>
+            <a:r>
+              <a:t>ReversoYa Colombia · Ley 1480 de 2011 · Decreto 587 de 2016 · RAC 3 Aerocivil   |   Diapositiva 6 de 10</a:t>
             </a:r>
           </a:p>
         </p:txBody>
@@ -4718,69 +7152,411 @@
       <p:grpSpPr/>
       <p:sp>
         <p:nvSpPr>
-          <p:cNvPr id="2" name="Title 1"/>
-          <p:cNvSpPr>
-            <a:spLocks noGrp="1"/>
-          </p:cNvSpPr>
-          <p:nvPr>
-            <p:ph type="title"/>
-          </p:nvPr>
-        </p:nvSpPr>
-        <p:spPr/>
-        <p:txBody>
-          <a:bodyPr/>
-          <a:lstStyle/>
-          <a:p>
-            <a:r>
-              <a:t>Slide 7 (06:45-07:45): Caso Especial — Vuelos y Compensación 30% (RAC 3)</a:t>
-            </a:r>
-          </a:p>
-        </p:txBody>
-      </p:sp>
-      <p:sp>
-        <p:nvSpPr>
-          <p:cNvPr id="3" name="Content Placeholder 2"/>
-          <p:cNvSpPr>
-            <a:spLocks noGrp="1"/>
-          </p:cNvSpPr>
-          <p:nvPr>
-            <p:ph idx="1"/>
-          </p:nvPr>
-        </p:nvSpPr>
-        <p:spPr/>
-        <p:txBody>
-          <a:bodyPr/>
+          <p:cNvPr id="2" name="Rectangle 1"/>
+          <p:cNvSpPr/>
+          <p:nvPr/>
+        </p:nvSpPr>
+        <p:spPr>
+          <a:xfrm>
+            <a:off x="0" y="0"/>
+            <a:ext cx="12191695" cy="6858000"/>
+          </a:xfrm>
+          <a:prstGeom prst="rect">
+            <a:avLst/>
+          </a:prstGeom>
+          <a:solidFill>
+            <a:srgbClr val="0B132B"/>
+          </a:solidFill>
+          <a:ln>
+            <a:noFill/>
+          </a:ln>
+        </p:spPr>
+        <p:style>
+          <a:lnRef idx="1">
+            <a:schemeClr val="accent1"/>
+          </a:lnRef>
+          <a:fillRef idx="3">
+            <a:schemeClr val="accent1"/>
+          </a:fillRef>
+          <a:effectRef idx="2">
+            <a:schemeClr val="accent1"/>
+          </a:effectRef>
+          <a:fontRef idx="minor">
+            <a:schemeClr val="lt1"/>
+          </a:fontRef>
+        </p:style>
+        <p:txBody>
+          <a:bodyPr rtlCol="0" anchor="ctr"/>
+          <a:lstStyle/>
+          <a:p>
+            <a:pPr algn="ctr"/>
+          </a:p>
+        </p:txBody>
+      </p:sp>
+      <p:sp>
+        <p:nvSpPr>
+          <p:cNvPr id="3" name="Rounded Rectangle 2"/>
+          <p:cNvSpPr/>
+          <p:nvPr/>
+        </p:nvSpPr>
+        <p:spPr>
+          <a:xfrm>
+            <a:off x="457200" y="320040"/>
+            <a:ext cx="11277295" cy="502920"/>
+          </a:xfrm>
+          <a:prstGeom prst="roundRect">
+            <a:avLst/>
+          </a:prstGeom>
+          <a:solidFill>
+            <a:srgbClr val="131A33"/>
+          </a:solidFill>
+          <a:ln w="15240">
+            <a:solidFill>
+              <a:srgbClr val="00C48C"/>
+            </a:solidFill>
+          </a:ln>
+        </p:spPr>
+        <p:style>
+          <a:lnRef idx="1">
+            <a:schemeClr val="accent1"/>
+          </a:lnRef>
+          <a:fillRef idx="3">
+            <a:schemeClr val="accent1"/>
+          </a:fillRef>
+          <a:effectRef idx="2">
+            <a:schemeClr val="accent1"/>
+          </a:effectRef>
+          <a:fontRef idx="minor">
+            <a:schemeClr val="lt1"/>
+          </a:fontRef>
+        </p:style>
+        <p:txBody>
+          <a:bodyPr rtlCol="0" anchor="ctr" wrap="square"/>
+          <a:lstStyle/>
+          <a:p>
+            <a:pPr algn="ctr">
+              <a:defRPr sz="1100" b="1">
+                <a:solidFill>
+                  <a:srgbClr val="63FCC0"/>
+                </a:solidFill>
+                <a:latin typeface="Segoe UI"/>
+              </a:defRPr>
+            </a:pPr>
+            <a:r>
+              <a:t>DIAPOSITIVA 7 DE 10 · 06:45 – 07:45 (60s)   |   4. ALCANCE SECTORIAL · TRANSPORTE AÉREO RAC 3</a:t>
+            </a:r>
+          </a:p>
+        </p:txBody>
+      </p:sp>
+      <p:sp>
+        <p:nvSpPr>
+          <p:cNvPr id="4" name="TextBox 3"/>
+          <p:cNvSpPr txBox="1"/>
+          <p:nvPr/>
+        </p:nvSpPr>
+        <p:spPr>
+          <a:xfrm>
+            <a:off x="457200" y="960120"/>
+            <a:ext cx="6492240" cy="1325880"/>
+          </a:xfrm>
+          <a:prstGeom prst="rect">
+            <a:avLst/>
+          </a:prstGeom>
+          <a:noFill/>
+        </p:spPr>
+        <p:txBody>
+          <a:bodyPr wrap="square">
+            <a:spAutoFit/>
+          </a:bodyPr>
           <a:lstStyle/>
           <a:p>
             <a:pPr>
-              <a:defRPr sz="2000"/>
-            </a:pPr>
-            <a:r>
-              <a:t>Ejemplo real: Vuelo Bogotá–Cartagena de $540.000 COP sobrevendido o cancelado por la aerolínea.</a:t>
+              <a:defRPr sz="2300" b="1">
+                <a:solidFill>
+                  <a:srgbClr val="FFFFFF"/>
+                </a:solidFill>
+                <a:latin typeface="Segoe UI"/>
+              </a:defRPr>
+            </a:pPr>
+            <a:r>
+              <a:t>Módulo Aeronáutico: 100% Tiquete + 30% Compensación RAC 3</a:t>
             </a:r>
           </a:p>
           <a:p>
             <a:pPr>
-              <a:defRPr sz="2000"/>
-            </a:pPr>
-            <a:r>
-              <a:t>Reembolso del tiquete vía banco: $540.000 COP (100%).</a:t>
+              <a:defRPr sz="1250">
+                <a:solidFill>
+                  <a:srgbClr val="CBD5E1"/>
+                </a:solidFill>
+                <a:latin typeface="Segoe UI"/>
+              </a:defRPr>
+            </a:pPr>
+            <a:r>
+              <a:t>Aplicación en sobreventa (overbooking) o cancelación atribuible a la aerolínea en Colombia:</a:t>
+            </a:r>
+          </a:p>
+        </p:txBody>
+      </p:sp>
+      <p:sp>
+        <p:nvSpPr>
+          <p:cNvPr id="5" name="Rounded Rectangle 4"/>
+          <p:cNvSpPr/>
+          <p:nvPr/>
+        </p:nvSpPr>
+        <p:spPr>
+          <a:xfrm>
+            <a:off x="457200" y="2395728"/>
+            <a:ext cx="6492240" cy="1170432"/>
+          </a:xfrm>
+          <a:prstGeom prst="roundRect">
+            <a:avLst/>
+          </a:prstGeom>
+          <a:solidFill>
+            <a:srgbClr val="131A33"/>
+          </a:solidFill>
+          <a:ln w="19050">
+            <a:solidFill>
+              <a:srgbClr val="00C48C"/>
+            </a:solidFill>
+          </a:ln>
+        </p:spPr>
+        <p:style>
+          <a:lnRef idx="1">
+            <a:schemeClr val="accent1"/>
+          </a:lnRef>
+          <a:fillRef idx="3">
+            <a:schemeClr val="accent1"/>
+          </a:fillRef>
+          <a:effectRef idx="2">
+            <a:schemeClr val="accent1"/>
+          </a:effectRef>
+          <a:fontRef idx="minor">
+            <a:schemeClr val="lt1"/>
+          </a:fontRef>
+        </p:style>
+        <p:txBody>
+          <a:bodyPr rtlCol="0" anchor="ctr" wrap="square"/>
+          <a:lstStyle/>
+          <a:p>
+            <a:pPr algn="ctr">
+              <a:defRPr sz="1150" b="1">
+                <a:solidFill>
+                  <a:srgbClr val="63FCC0"/>
+                </a:solidFill>
+                <a:latin typeface="Segoe UI"/>
+              </a:defRPr>
+            </a:pPr>
+            <a:r>
+              <a:t>100% REEMBOLSO DEL TIQUETE</a:t>
             </a:r>
           </a:p>
           <a:p>
             <a:pPr>
-              <a:defRPr sz="2000"/>
-            </a:pPr>
-            <a:r>
-              <a:t>Compensación obligatoria RAC 3 (30%): +$162.000 COP.</a:t>
+              <a:defRPr sz="1250">
+                <a:solidFill>
+                  <a:srgbClr val="F8FAFC"/>
+                </a:solidFill>
+                <a:latin typeface="Segoe UI"/>
+              </a:defRPr>
+            </a:pPr>
+            <a:r>
+              <a:t>En un tiquete de $540.000 COP, ordena la reversión íntegra de $540.000 COP a través del banco emisor.</a:t>
+            </a:r>
+          </a:p>
+        </p:txBody>
+      </p:sp>
+      <p:sp>
+        <p:nvSpPr>
+          <p:cNvPr id="6" name="Rounded Rectangle 5"/>
+          <p:cNvSpPr/>
+          <p:nvPr/>
+        </p:nvSpPr>
+        <p:spPr>
+          <a:xfrm>
+            <a:off x="457200" y="3694176"/>
+            <a:ext cx="6492240" cy="1170432"/>
+          </a:xfrm>
+          <a:prstGeom prst="roundRect">
+            <a:avLst/>
+          </a:prstGeom>
+          <a:solidFill>
+            <a:srgbClr val="131A33"/>
+          </a:solidFill>
+          <a:ln w="19050">
+            <a:solidFill>
+              <a:srgbClr val="30416C"/>
+            </a:solidFill>
+          </a:ln>
+        </p:spPr>
+        <p:style>
+          <a:lnRef idx="1">
+            <a:schemeClr val="accent1"/>
+          </a:lnRef>
+          <a:fillRef idx="3">
+            <a:schemeClr val="accent1"/>
+          </a:fillRef>
+          <a:effectRef idx="2">
+            <a:schemeClr val="accent1"/>
+          </a:effectRef>
+          <a:fontRef idx="minor">
+            <a:schemeClr val="lt1"/>
+          </a:fontRef>
+        </p:style>
+        <p:txBody>
+          <a:bodyPr rtlCol="0" anchor="ctr" wrap="square"/>
+          <a:lstStyle/>
+          <a:p>
+            <a:pPr algn="ctr">
+              <a:defRPr sz="1150" b="1">
+                <a:solidFill>
+                  <a:srgbClr val="63FCC0"/>
+                </a:solidFill>
+                <a:latin typeface="Segoe UI"/>
+              </a:defRPr>
+            </a:pPr>
+            <a:r>
+              <a:t>+30% COMPENSACIÓN MÍNIMA RAC 3</a:t>
             </a:r>
           </a:p>
           <a:p>
             <a:pPr>
-              <a:defRPr sz="2000"/>
-            </a:pPr>
-            <a:r>
-              <a:t>Total exigible en dinero (no en millas ni vouchers): $702.000 COP.</a:t>
+              <a:defRPr sz="1250">
+                <a:solidFill>
+                  <a:srgbClr val="F8FAFC"/>
+                </a:solidFill>
+                <a:latin typeface="Segoe UI"/>
+              </a:defRPr>
+            </a:pPr>
+            <a:r>
+              <a:t>Liquida automáticamente +$162.000 COP adicionales exigibles a la aerolínea según los Reglamentos Aeronáuticos.</a:t>
+            </a:r>
+          </a:p>
+        </p:txBody>
+      </p:sp>
+      <p:sp>
+        <p:nvSpPr>
+          <p:cNvPr id="7" name="Rounded Rectangle 6"/>
+          <p:cNvSpPr/>
+          <p:nvPr/>
+        </p:nvSpPr>
+        <p:spPr>
+          <a:xfrm>
+            <a:off x="457200" y="4992624"/>
+            <a:ext cx="6492240" cy="1170432"/>
+          </a:xfrm>
+          <a:prstGeom prst="roundRect">
+            <a:avLst/>
+          </a:prstGeom>
+          <a:solidFill>
+            <a:srgbClr val="131A33"/>
+          </a:solidFill>
+          <a:ln w="19050">
+            <a:solidFill>
+              <a:srgbClr val="30416C"/>
+            </a:solidFill>
+          </a:ln>
+        </p:spPr>
+        <p:style>
+          <a:lnRef idx="1">
+            <a:schemeClr val="accent1"/>
+          </a:lnRef>
+          <a:fillRef idx="3">
+            <a:schemeClr val="accent1"/>
+          </a:fillRef>
+          <a:effectRef idx="2">
+            <a:schemeClr val="accent1"/>
+          </a:effectRef>
+          <a:fontRef idx="minor">
+            <a:schemeClr val="lt1"/>
+          </a:fontRef>
+        </p:style>
+        <p:txBody>
+          <a:bodyPr rtlCol="0" anchor="ctr" wrap="square"/>
+          <a:lstStyle/>
+          <a:p>
+            <a:pPr algn="ctr">
+              <a:defRPr sz="1150" b="1">
+                <a:solidFill>
+                  <a:srgbClr val="63FCC0"/>
+                </a:solidFill>
+                <a:latin typeface="Segoe UI"/>
+              </a:defRPr>
+            </a:pPr>
+            <a:r>
+              <a:t>RESTITUCIÓN EN DINERO EFECTIVO</a:t>
+            </a:r>
+          </a:p>
+          <a:p>
+            <a:pPr>
+              <a:defRPr sz="1250">
+                <a:solidFill>
+                  <a:srgbClr val="F8FAFC"/>
+                </a:solidFill>
+                <a:latin typeface="Segoe UI"/>
+              </a:defRPr>
+            </a:pPr>
+            <a:r>
+              <a:t>Total exigible: $702.000 COP en dinero efectivo, sin obligar al pasajero a recibir bonos o millas.</a:t>
+            </a:r>
+          </a:p>
+        </p:txBody>
+      </p:sp>
+      <p:pic>
+        <p:nvPicPr>
+          <p:cNvPr id="8" name="Picture 7" descr="image.png"/>
+          <p:cNvPicPr>
+            <a:picLocks noChangeAspect="1"/>
+          </p:cNvPicPr>
+          <p:nvPr/>
+        </p:nvPicPr>
+        <p:blipFill>
+          <a:blip r:embed="rId2"/>
+          <a:stretch>
+            <a:fillRect/>
+          </a:stretch>
+        </p:blipFill>
+        <p:spPr>
+          <a:xfrm>
+            <a:off x="7178040" y="1051560"/>
+            <a:ext cx="4553712" cy="3348318"/>
+          </a:xfrm>
+          <a:prstGeom prst="rect">
+            <a:avLst/>
+          </a:prstGeom>
+        </p:spPr>
+      </p:pic>
+      <p:sp>
+        <p:nvSpPr>
+          <p:cNvPr id="9" name="TextBox 8"/>
+          <p:cNvSpPr txBox="1"/>
+          <p:nvPr/>
+        </p:nvSpPr>
+        <p:spPr>
+          <a:xfrm>
+            <a:off x="457200" y="6355080"/>
+            <a:ext cx="11277295" cy="320040"/>
+          </a:xfrm>
+          <a:prstGeom prst="rect">
+            <a:avLst/>
+          </a:prstGeom>
+          <a:noFill/>
+        </p:spPr>
+        <p:txBody>
+          <a:bodyPr wrap="none">
+            <a:spAutoFit/>
+          </a:bodyPr>
+          <a:lstStyle/>
+          <a:p>
+            <a:pPr>
+              <a:defRPr sz="1000">
+                <a:solidFill>
+                  <a:srgbClr val="94A3B8"/>
+                </a:solidFill>
+                <a:latin typeface="Segoe UI"/>
+              </a:defRPr>
+            </a:pPr>
+            <a:r>
+              <a:t>ReversoYa Colombia · Ley 1480 de 2011 · Decreto 587 de 2016 · RAC 3 Aerocivil   |   Diapositiva 7 de 10</a:t>
             </a:r>
           </a:p>
         </p:txBody>
@@ -4805,69 +7581,411 @@
       <p:grpSpPr/>
       <p:sp>
         <p:nvSpPr>
-          <p:cNvPr id="2" name="Title 1"/>
-          <p:cNvSpPr>
-            <a:spLocks noGrp="1"/>
-          </p:cNvSpPr>
-          <p:nvPr>
-            <p:ph type="title"/>
-          </p:nvPr>
-        </p:nvSpPr>
-        <p:spPr/>
-        <p:txBody>
-          <a:bodyPr/>
-          <a:lstStyle/>
-          <a:p>
-            <a:r>
-              <a:t>Slide 8 (07:45-08:45): Propuesta de Valor y Benchmark en Colombia</a:t>
-            </a:r>
-          </a:p>
-        </p:txBody>
-      </p:sp>
-      <p:sp>
-        <p:nvSpPr>
-          <p:cNvPr id="3" name="Content Placeholder 2"/>
-          <p:cNvSpPr>
-            <a:spLocks noGrp="1"/>
-          </p:cNvSpPr>
-          <p:nvPr>
-            <p:ph idx="1"/>
-          </p:nvPr>
-        </p:nvSpPr>
-        <p:spPr/>
-        <p:txBody>
-          <a:bodyPr/>
+          <p:cNvPr id="2" name="Rectangle 1"/>
+          <p:cNvSpPr/>
+          <p:nvPr/>
+        </p:nvSpPr>
+        <p:spPr>
+          <a:xfrm>
+            <a:off x="0" y="0"/>
+            <a:ext cx="12191695" cy="6858000"/>
+          </a:xfrm>
+          <a:prstGeom prst="rect">
+            <a:avLst/>
+          </a:prstGeom>
+          <a:solidFill>
+            <a:srgbClr val="0B132B"/>
+          </a:solidFill>
+          <a:ln>
+            <a:noFill/>
+          </a:ln>
+        </p:spPr>
+        <p:style>
+          <a:lnRef idx="1">
+            <a:schemeClr val="accent1"/>
+          </a:lnRef>
+          <a:fillRef idx="3">
+            <a:schemeClr val="accent1"/>
+          </a:fillRef>
+          <a:effectRef idx="2">
+            <a:schemeClr val="accent1"/>
+          </a:effectRef>
+          <a:fontRef idx="minor">
+            <a:schemeClr val="lt1"/>
+          </a:fontRef>
+        </p:style>
+        <p:txBody>
+          <a:bodyPr rtlCol="0" anchor="ctr"/>
+          <a:lstStyle/>
+          <a:p>
+            <a:pPr algn="ctr"/>
+          </a:p>
+        </p:txBody>
+      </p:sp>
+      <p:sp>
+        <p:nvSpPr>
+          <p:cNvPr id="3" name="Rounded Rectangle 2"/>
+          <p:cNvSpPr/>
+          <p:nvPr/>
+        </p:nvSpPr>
+        <p:spPr>
+          <a:xfrm>
+            <a:off x="457200" y="320040"/>
+            <a:ext cx="11277295" cy="502920"/>
+          </a:xfrm>
+          <a:prstGeom prst="roundRect">
+            <a:avLst/>
+          </a:prstGeom>
+          <a:solidFill>
+            <a:srgbClr val="131A33"/>
+          </a:solidFill>
+          <a:ln w="15240">
+            <a:solidFill>
+              <a:srgbClr val="00C48C"/>
+            </a:solidFill>
+          </a:ln>
+        </p:spPr>
+        <p:style>
+          <a:lnRef idx="1">
+            <a:schemeClr val="accent1"/>
+          </a:lnRef>
+          <a:fillRef idx="3">
+            <a:schemeClr val="accent1"/>
+          </a:fillRef>
+          <a:effectRef idx="2">
+            <a:schemeClr val="accent1"/>
+          </a:effectRef>
+          <a:fontRef idx="minor">
+            <a:schemeClr val="lt1"/>
+          </a:fontRef>
+        </p:style>
+        <p:txBody>
+          <a:bodyPr rtlCol="0" anchor="ctr" wrap="square"/>
+          <a:lstStyle/>
+          <a:p>
+            <a:pPr algn="ctr">
+              <a:defRPr sz="1100" b="1">
+                <a:solidFill>
+                  <a:srgbClr val="63FCC0"/>
+                </a:solidFill>
+                <a:latin typeface="Segoe UI"/>
+              </a:defRPr>
+            </a:pPr>
+            <a:r>
+              <a:t>DIAPOSITIVA 8 DE 10 · 07:45 – 08:45 (60s)   |   5. PROPUESTA DE VALOR Y BENCHMARK EN COLOMBIA</a:t>
+            </a:r>
+          </a:p>
+        </p:txBody>
+      </p:sp>
+      <p:sp>
+        <p:nvSpPr>
+          <p:cNvPr id="4" name="TextBox 3"/>
+          <p:cNvSpPr txBox="1"/>
+          <p:nvPr/>
+        </p:nvSpPr>
+        <p:spPr>
+          <a:xfrm>
+            <a:off x="457200" y="960120"/>
+            <a:ext cx="6492240" cy="1325880"/>
+          </a:xfrm>
+          <a:prstGeom prst="rect">
+            <a:avLst/>
+          </a:prstGeom>
+          <a:noFill/>
+        </p:spPr>
+        <p:txBody>
+          <a:bodyPr wrap="square">
+            <a:spAutoFit/>
+          </a:bodyPr>
           <a:lstStyle/>
           <a:p>
             <a:pPr>
-              <a:defRPr sz="2000"/>
-            </a:pPr>
-            <a:r>
-              <a:t>SIC Facilita: Solo aplica a comercios inscritos voluntariamente; no vincula al banco ni cubre tiendas de Instagram.</a:t>
+              <a:defRPr sz="2300" b="1">
+                <a:solidFill>
+                  <a:srgbClr val="FFFFFF"/>
+                </a:solidFill>
+                <a:latin typeface="Segoe UI"/>
+              </a:defRPr>
+            </a:pPr>
+            <a:r>
+              <a:t>¿Qué existe hoy en Colombia y por qué ReversoYa es único?</a:t>
             </a:r>
           </a:p>
           <a:p>
             <a:pPr>
-              <a:defRPr sz="2000"/>
-            </a:pPr>
-            <a:r>
-              <a:t>Formularios bancarios: Tratan todo como fraude de tarjeta y ocultan la reversión de PSE.</a:t>
+              <a:defRPr sz="1250">
+                <a:solidFill>
+                  <a:srgbClr val="CBD5E1"/>
+                </a:solidFill>
+                <a:latin typeface="Segoe UI"/>
+              </a:defRPr>
+            </a:pPr>
+            <a:r>
+              <a:t>Comparación frente a las herramientas existentes en el mercado colombiano:</a:t>
+            </a:r>
+          </a:p>
+        </p:txBody>
+      </p:sp>
+      <p:sp>
+        <p:nvSpPr>
+          <p:cNvPr id="5" name="Rounded Rectangle 4"/>
+          <p:cNvSpPr/>
+          <p:nvPr/>
+        </p:nvSpPr>
+        <p:spPr>
+          <a:xfrm>
+            <a:off x="457200" y="2395728"/>
+            <a:ext cx="6492240" cy="1170432"/>
+          </a:xfrm>
+          <a:prstGeom prst="roundRect">
+            <a:avLst/>
+          </a:prstGeom>
+          <a:solidFill>
+            <a:srgbClr val="131A33"/>
+          </a:solidFill>
+          <a:ln w="19050">
+            <a:solidFill>
+              <a:srgbClr val="00C48C"/>
+            </a:solidFill>
+          </a:ln>
+        </p:spPr>
+        <p:style>
+          <a:lnRef idx="1">
+            <a:schemeClr val="accent1"/>
+          </a:lnRef>
+          <a:fillRef idx="3">
+            <a:schemeClr val="accent1"/>
+          </a:fillRef>
+          <a:effectRef idx="2">
+            <a:schemeClr val="accent1"/>
+          </a:effectRef>
+          <a:fontRef idx="minor">
+            <a:schemeClr val="lt1"/>
+          </a:fontRef>
+        </p:style>
+        <p:txBody>
+          <a:bodyPr rtlCol="0" anchor="ctr" wrap="square"/>
+          <a:lstStyle/>
+          <a:p>
+            <a:pPr algn="ctr">
+              <a:defRPr sz="1150" b="1">
+                <a:solidFill>
+                  <a:srgbClr val="63FCC0"/>
+                </a:solidFill>
+                <a:latin typeface="Segoe UI"/>
+              </a:defRPr>
+            </a:pPr>
+            <a:r>
+              <a:t>FRENTE A SIC FACILITA</a:t>
             </a:r>
           </a:p>
           <a:p>
             <a:pPr>
-              <a:defRPr sz="2000"/>
-            </a:pPr>
-            <a:r>
-              <a:t>Apps de Derechos de Petición: Solo le envían una carta al vendedor incumplido, quien la ignora.</a:t>
+              <a:defRPr sz="1250">
+                <a:solidFill>
+                  <a:srgbClr val="F8FAFC"/>
+                </a:solidFill>
+                <a:latin typeface="Segoe UI"/>
+              </a:defRPr>
+            </a:pPr>
+            <a:r>
+              <a:t>SIC Facilita solo opera con comercios inscritos voluntariamente; ReversoYa vincula directamente al banco/PSE.</a:t>
+            </a:r>
+          </a:p>
+        </p:txBody>
+      </p:sp>
+      <p:sp>
+        <p:nvSpPr>
+          <p:cNvPr id="6" name="Rounded Rectangle 5"/>
+          <p:cNvSpPr/>
+          <p:nvPr/>
+        </p:nvSpPr>
+        <p:spPr>
+          <a:xfrm>
+            <a:off x="457200" y="3694176"/>
+            <a:ext cx="6492240" cy="1170432"/>
+          </a:xfrm>
+          <a:prstGeom prst="roundRect">
+            <a:avLst/>
+          </a:prstGeom>
+          <a:solidFill>
+            <a:srgbClr val="131A33"/>
+          </a:solidFill>
+          <a:ln w="19050">
+            <a:solidFill>
+              <a:srgbClr val="30416C"/>
+            </a:solidFill>
+          </a:ln>
+        </p:spPr>
+        <p:style>
+          <a:lnRef idx="1">
+            <a:schemeClr val="accent1"/>
+          </a:lnRef>
+          <a:fillRef idx="3">
+            <a:schemeClr val="accent1"/>
+          </a:fillRef>
+          <a:effectRef idx="2">
+            <a:schemeClr val="accent1"/>
+          </a:effectRef>
+          <a:fontRef idx="minor">
+            <a:schemeClr val="lt1"/>
+          </a:fontRef>
+        </p:style>
+        <p:txBody>
+          <a:bodyPr rtlCol="0" anchor="ctr" wrap="square"/>
+          <a:lstStyle/>
+          <a:p>
+            <a:pPr algn="ctr">
+              <a:defRPr sz="1150" b="1">
+                <a:solidFill>
+                  <a:srgbClr val="63FCC0"/>
+                </a:solidFill>
+                <a:latin typeface="Segoe UI"/>
+              </a:defRPr>
+            </a:pPr>
+            <a:r>
+              <a:t>FRENTE A FORMULARIOS BANCARIOS</a:t>
             </a:r>
           </a:p>
           <a:p>
             <a:pPr>
-              <a:defRPr sz="2000"/>
-            </a:pPr>
-            <a:r>
-              <a:t>Diferencial ReversoYa: Acciona directamente el débito forzoso ante el banco/pasarela en 15 días hábiles.</a:t>
+              <a:defRPr sz="1250">
+                <a:solidFill>
+                  <a:srgbClr val="F8FAFC"/>
+                </a:solidFill>
+                <a:latin typeface="Segoe UI"/>
+              </a:defRPr>
+            </a:pPr>
+            <a:r>
+              <a:t>Los bancos suelen tramitar solo fraude de tarjeta y rechazar PSE; ReversoYa invoca el Art. 2.2.2.51.3 Dec. 1074/2015.</a:t>
+            </a:r>
+          </a:p>
+        </p:txBody>
+      </p:sp>
+      <p:sp>
+        <p:nvSpPr>
+          <p:cNvPr id="7" name="Rounded Rectangle 6"/>
+          <p:cNvSpPr/>
+          <p:nvPr/>
+        </p:nvSpPr>
+        <p:spPr>
+          <a:xfrm>
+            <a:off x="457200" y="4992624"/>
+            <a:ext cx="6492240" cy="1170432"/>
+          </a:xfrm>
+          <a:prstGeom prst="roundRect">
+            <a:avLst/>
+          </a:prstGeom>
+          <a:solidFill>
+            <a:srgbClr val="131A33"/>
+          </a:solidFill>
+          <a:ln w="19050">
+            <a:solidFill>
+              <a:srgbClr val="30416C"/>
+            </a:solidFill>
+          </a:ln>
+        </p:spPr>
+        <p:style>
+          <a:lnRef idx="1">
+            <a:schemeClr val="accent1"/>
+          </a:lnRef>
+          <a:fillRef idx="3">
+            <a:schemeClr val="accent1"/>
+          </a:fillRef>
+          <a:effectRef idx="2">
+            <a:schemeClr val="accent1"/>
+          </a:effectRef>
+          <a:fontRef idx="minor">
+            <a:schemeClr val="lt1"/>
+          </a:fontRef>
+        </p:style>
+        <p:txBody>
+          <a:bodyPr rtlCol="0" anchor="ctr" wrap="square"/>
+          <a:lstStyle/>
+          <a:p>
+            <a:pPr algn="ctr">
+              <a:defRPr sz="1150" b="1">
+                <a:solidFill>
+                  <a:srgbClr val="63FCC0"/>
+                </a:solidFill>
+                <a:latin typeface="Segoe UI"/>
+              </a:defRPr>
+            </a:pPr>
+            <a:r>
+              <a:t>FRENTE A GENERADORES DE PETICIONES</a:t>
+            </a:r>
+          </a:p>
+          <a:p>
+            <a:pPr>
+              <a:defRPr sz="1250">
+                <a:solidFill>
+                  <a:srgbClr val="F8FAFC"/>
+                </a:solidFill>
+                <a:latin typeface="Segoe UI"/>
+              </a:defRPr>
+            </a:pPr>
+            <a:r>
+              <a:t>Escribir solo al vendedor no recupera el dinero si este no contesta; ReversoYa activa el débito bancario en 15 días.</a:t>
+            </a:r>
+          </a:p>
+        </p:txBody>
+      </p:sp>
+      <p:pic>
+        <p:nvPicPr>
+          <p:cNvPr id="8" name="Picture 7" descr="image.png"/>
+          <p:cNvPicPr>
+            <a:picLocks noChangeAspect="1"/>
+          </p:cNvPicPr>
+          <p:nvPr/>
+        </p:nvPicPr>
+        <p:blipFill>
+          <a:blip r:embed="rId2"/>
+          <a:stretch>
+            <a:fillRect/>
+          </a:stretch>
+        </p:blipFill>
+        <p:spPr>
+          <a:xfrm>
+            <a:off x="7178040" y="1051560"/>
+            <a:ext cx="4553712" cy="3348318"/>
+          </a:xfrm>
+          <a:prstGeom prst="rect">
+            <a:avLst/>
+          </a:prstGeom>
+        </p:spPr>
+      </p:pic>
+      <p:sp>
+        <p:nvSpPr>
+          <p:cNvPr id="9" name="TextBox 8"/>
+          <p:cNvSpPr txBox="1"/>
+          <p:nvPr/>
+        </p:nvSpPr>
+        <p:spPr>
+          <a:xfrm>
+            <a:off x="457200" y="6355080"/>
+            <a:ext cx="11277295" cy="320040"/>
+          </a:xfrm>
+          <a:prstGeom prst="rect">
+            <a:avLst/>
+          </a:prstGeom>
+          <a:noFill/>
+        </p:spPr>
+        <p:txBody>
+          <a:bodyPr wrap="none">
+            <a:spAutoFit/>
+          </a:bodyPr>
+          <a:lstStyle/>
+          <a:p>
+            <a:pPr>
+              <a:defRPr sz="1000">
+                <a:solidFill>
+                  <a:srgbClr val="94A3B8"/>
+                </a:solidFill>
+                <a:latin typeface="Segoe UI"/>
+              </a:defRPr>
+            </a:pPr>
+            <a:r>
+              <a:t>ReversoYa Colombia · Ley 1480 de 2011 · Decreto 587 de 2016 · RAC 3 Aerocivil   |   Diapositiva 8 de 10</a:t>
             </a:r>
           </a:p>
         </p:txBody>
@@ -4892,61 +8010,411 @@
       <p:grpSpPr/>
       <p:sp>
         <p:nvSpPr>
-          <p:cNvPr id="2" name="Title 1"/>
-          <p:cNvSpPr>
-            <a:spLocks noGrp="1"/>
-          </p:cNvSpPr>
-          <p:nvPr>
-            <p:ph type="title"/>
-          </p:nvPr>
-        </p:nvSpPr>
-        <p:spPr/>
-        <p:txBody>
-          <a:bodyPr/>
-          <a:lstStyle/>
-          <a:p>
-            <a:r>
-              <a:t>Slide 9 (08:45-09:30): Modelo de Negocio — Ético y Escalable</a:t>
-            </a:r>
-          </a:p>
-        </p:txBody>
-      </p:sp>
-      <p:sp>
-        <p:nvSpPr>
-          <p:cNvPr id="3" name="Content Placeholder 2"/>
-          <p:cNvSpPr>
-            <a:spLocks noGrp="1"/>
-          </p:cNvSpPr>
-          <p:nvPr>
-            <p:ph idx="1"/>
-          </p:nvPr>
-        </p:nvSpPr>
-        <p:spPr/>
-        <p:txBody>
-          <a:bodyPr/>
+          <p:cNvPr id="2" name="Rectangle 1"/>
+          <p:cNvSpPr/>
+          <p:nvPr/>
+        </p:nvSpPr>
+        <p:spPr>
+          <a:xfrm>
+            <a:off x="0" y="0"/>
+            <a:ext cx="12191695" cy="6858000"/>
+          </a:xfrm>
+          <a:prstGeom prst="rect">
+            <a:avLst/>
+          </a:prstGeom>
+          <a:solidFill>
+            <a:srgbClr val="0B132B"/>
+          </a:solidFill>
+          <a:ln>
+            <a:noFill/>
+          </a:ln>
+        </p:spPr>
+        <p:style>
+          <a:lnRef idx="1">
+            <a:schemeClr val="accent1"/>
+          </a:lnRef>
+          <a:fillRef idx="3">
+            <a:schemeClr val="accent1"/>
+          </a:fillRef>
+          <a:effectRef idx="2">
+            <a:schemeClr val="accent1"/>
+          </a:effectRef>
+          <a:fontRef idx="minor">
+            <a:schemeClr val="lt1"/>
+          </a:fontRef>
+        </p:style>
+        <p:txBody>
+          <a:bodyPr rtlCol="0" anchor="ctr"/>
+          <a:lstStyle/>
+          <a:p>
+            <a:pPr algn="ctr"/>
+          </a:p>
+        </p:txBody>
+      </p:sp>
+      <p:sp>
+        <p:nvSpPr>
+          <p:cNvPr id="3" name="Rounded Rectangle 2"/>
+          <p:cNvSpPr/>
+          <p:nvPr/>
+        </p:nvSpPr>
+        <p:spPr>
+          <a:xfrm>
+            <a:off x="457200" y="320040"/>
+            <a:ext cx="11277295" cy="502920"/>
+          </a:xfrm>
+          <a:prstGeom prst="roundRect">
+            <a:avLst/>
+          </a:prstGeom>
+          <a:solidFill>
+            <a:srgbClr val="131A33"/>
+          </a:solidFill>
+          <a:ln w="15240">
+            <a:solidFill>
+              <a:srgbClr val="00C48C"/>
+            </a:solidFill>
+          </a:ln>
+        </p:spPr>
+        <p:style>
+          <a:lnRef idx="1">
+            <a:schemeClr val="accent1"/>
+          </a:lnRef>
+          <a:fillRef idx="3">
+            <a:schemeClr val="accent1"/>
+          </a:fillRef>
+          <a:effectRef idx="2">
+            <a:schemeClr val="accent1"/>
+          </a:effectRef>
+          <a:fontRef idx="minor">
+            <a:schemeClr val="lt1"/>
+          </a:fontRef>
+        </p:style>
+        <p:txBody>
+          <a:bodyPr rtlCol="0" anchor="ctr" wrap="square"/>
+          <a:lstStyle/>
+          <a:p>
+            <a:pPr algn="ctr">
+              <a:defRPr sz="1100" b="1">
+                <a:solidFill>
+                  <a:srgbClr val="63FCC0"/>
+                </a:solidFill>
+                <a:latin typeface="Segoe UI"/>
+              </a:defRPr>
+            </a:pPr>
+            <a:r>
+              <a:t>DIAPOSITIVA 9 DE 10 · 08:45 – 09:30 (45s)   |   6. MODELO DE NEGOCIO</a:t>
+            </a:r>
+          </a:p>
+        </p:txBody>
+      </p:sp>
+      <p:sp>
+        <p:nvSpPr>
+          <p:cNvPr id="4" name="TextBox 3"/>
+          <p:cNvSpPr txBox="1"/>
+          <p:nvPr/>
+        </p:nvSpPr>
+        <p:spPr>
+          <a:xfrm>
+            <a:off x="457200" y="960120"/>
+            <a:ext cx="6492240" cy="1325880"/>
+          </a:xfrm>
+          <a:prstGeom prst="rect">
+            <a:avLst/>
+          </a:prstGeom>
+          <a:noFill/>
+        </p:spPr>
+        <p:txBody>
+          <a:bodyPr wrap="square">
+            <a:spAutoFit/>
+          </a:bodyPr>
           <a:lstStyle/>
           <a:p>
             <a:pPr>
-              <a:defRPr sz="2000"/>
-            </a:pPr>
-            <a:r>
-              <a:t>1. Nivel Freemium ($0 COP): Diagnóstico, detector de excusas y descarga manual de los 3 oficios gratis.</a:t>
+              <a:defRPr sz="2300" b="1">
+                <a:solidFill>
+                  <a:srgbClr val="FFFFFF"/>
+                </a:solidFill>
+                <a:latin typeface="Segoe UI"/>
+              </a:defRPr>
+            </a:pPr>
+            <a:r>
+              <a:t>Modelo de Negocio: Sostenible y con 0% de comisión</a:t>
             </a:r>
           </a:p>
           <a:p>
             <a:pPr>
-              <a:defRPr sz="2000"/>
-            </a:pPr>
-            <a:r>
-              <a:t>2. Micro-pago B2C ($19.900 COP por caso, 0% comisión sobre lo recuperado): Radicación triple certificada SHA-256 y reloj de 15 días.</a:t>
+              <a:defRPr sz="1250">
+                <a:solidFill>
+                  <a:srgbClr val="CBD5E1"/>
+                </a:solidFill>
+                <a:latin typeface="Segoe UI"/>
+              </a:defRPr>
+            </a:pPr>
+            <a:r>
+              <a:t>Estructura de tres niveles que garantiza acceso universal y viabilidad financiera:</a:t>
+            </a:r>
+          </a:p>
+        </p:txBody>
+      </p:sp>
+      <p:sp>
+        <p:nvSpPr>
+          <p:cNvPr id="5" name="Rounded Rectangle 4"/>
+          <p:cNvSpPr/>
+          <p:nvPr/>
+        </p:nvSpPr>
+        <p:spPr>
+          <a:xfrm>
+            <a:off x="457200" y="2395728"/>
+            <a:ext cx="6492240" cy="1170432"/>
+          </a:xfrm>
+          <a:prstGeom prst="roundRect">
+            <a:avLst/>
+          </a:prstGeom>
+          <a:solidFill>
+            <a:srgbClr val="131A33"/>
+          </a:solidFill>
+          <a:ln w="19050">
+            <a:solidFill>
+              <a:srgbClr val="00C48C"/>
+            </a:solidFill>
+          </a:ln>
+        </p:spPr>
+        <p:style>
+          <a:lnRef idx="1">
+            <a:schemeClr val="accent1"/>
+          </a:lnRef>
+          <a:fillRef idx="3">
+            <a:schemeClr val="accent1"/>
+          </a:fillRef>
+          <a:effectRef idx="2">
+            <a:schemeClr val="accent1"/>
+          </a:effectRef>
+          <a:fontRef idx="minor">
+            <a:schemeClr val="lt1"/>
+          </a:fontRef>
+        </p:style>
+        <p:txBody>
+          <a:bodyPr rtlCol="0" anchor="ctr" wrap="square"/>
+          <a:lstStyle/>
+          <a:p>
+            <a:pPr algn="ctr">
+              <a:defRPr sz="1150" b="1">
+                <a:solidFill>
+                  <a:srgbClr val="63FCC0"/>
+                </a:solidFill>
+                <a:latin typeface="Segoe UI"/>
+              </a:defRPr>
+            </a:pPr>
+            <a:r>
+              <a:t>1. NIVEL FREEMIUM ($0 COP)</a:t>
             </a:r>
           </a:p>
           <a:p>
             <a:pPr>
-              <a:defRPr sz="2000"/>
-            </a:pPr>
-            <a:r>
-              <a:t>3. SaaS B2B ($290.000 a $1.200.000 COP/mes): API de autogestión de retractos para comercios y pasarelas que evita multas de hasta 2.000 SMLMV.</a:t>
+              <a:defRPr sz="1250">
+                <a:solidFill>
+                  <a:srgbClr val="F8FAFC"/>
+                </a:solidFill>
+                <a:latin typeface="Segoe UI"/>
+              </a:defRPr>
+            </a:pPr>
+            <a:r>
+              <a:t>Diagnóstico de plazos, auditoría de excusas y descarga manual de los 3 oficios totalmente gratis.</a:t>
+            </a:r>
+          </a:p>
+        </p:txBody>
+      </p:sp>
+      <p:sp>
+        <p:nvSpPr>
+          <p:cNvPr id="6" name="Rounded Rectangle 5"/>
+          <p:cNvSpPr/>
+          <p:nvPr/>
+        </p:nvSpPr>
+        <p:spPr>
+          <a:xfrm>
+            <a:off x="457200" y="3694176"/>
+            <a:ext cx="6492240" cy="1170432"/>
+          </a:xfrm>
+          <a:prstGeom prst="roundRect">
+            <a:avLst/>
+          </a:prstGeom>
+          <a:solidFill>
+            <a:srgbClr val="131A33"/>
+          </a:solidFill>
+          <a:ln w="19050">
+            <a:solidFill>
+              <a:srgbClr val="30416C"/>
+            </a:solidFill>
+          </a:ln>
+        </p:spPr>
+        <p:style>
+          <a:lnRef idx="1">
+            <a:schemeClr val="accent1"/>
+          </a:lnRef>
+          <a:fillRef idx="3">
+            <a:schemeClr val="accent1"/>
+          </a:fillRef>
+          <a:effectRef idx="2">
+            <a:schemeClr val="accent1"/>
+          </a:effectRef>
+          <a:fontRef idx="minor">
+            <a:schemeClr val="lt1"/>
+          </a:fontRef>
+        </p:style>
+        <p:txBody>
+          <a:bodyPr rtlCol="0" anchor="ctr" wrap="square"/>
+          <a:lstStyle/>
+          <a:p>
+            <a:pPr algn="ctr">
+              <a:defRPr sz="1150" b="1">
+                <a:solidFill>
+                  <a:srgbClr val="63FCC0"/>
+                </a:solidFill>
+                <a:latin typeface="Segoe UI"/>
+              </a:defRPr>
+            </a:pPr>
+            <a:r>
+              <a:t>2. RADICACIÓN ASISTIDA ($19.900 COP)</a:t>
+            </a:r>
+          </a:p>
+          <a:p>
+            <a:pPr>
+              <a:defRPr sz="1250">
+                <a:solidFill>
+                  <a:srgbClr val="F8FAFC"/>
+                </a:solidFill>
+                <a:latin typeface="Segoe UI"/>
+              </a:defRPr>
+            </a:pPr>
+            <a:r>
+              <a:t>Tarifa plana única por caso (0% comisión sobre el reembolso y 95% más barato que un abogado) con envío simultáneo.</a:t>
+            </a:r>
+          </a:p>
+        </p:txBody>
+      </p:sp>
+      <p:sp>
+        <p:nvSpPr>
+          <p:cNvPr id="7" name="Rounded Rectangle 6"/>
+          <p:cNvSpPr/>
+          <p:nvPr/>
+        </p:nvSpPr>
+        <p:spPr>
+          <a:xfrm>
+            <a:off x="457200" y="4992624"/>
+            <a:ext cx="6492240" cy="1170432"/>
+          </a:xfrm>
+          <a:prstGeom prst="roundRect">
+            <a:avLst/>
+          </a:prstGeom>
+          <a:solidFill>
+            <a:srgbClr val="131A33"/>
+          </a:solidFill>
+          <a:ln w="19050">
+            <a:solidFill>
+              <a:srgbClr val="30416C"/>
+            </a:solidFill>
+          </a:ln>
+        </p:spPr>
+        <p:style>
+          <a:lnRef idx="1">
+            <a:schemeClr val="accent1"/>
+          </a:lnRef>
+          <a:fillRef idx="3">
+            <a:schemeClr val="accent1"/>
+          </a:fillRef>
+          <a:effectRef idx="2">
+            <a:schemeClr val="accent1"/>
+          </a:effectRef>
+          <a:fontRef idx="minor">
+            <a:schemeClr val="lt1"/>
+          </a:fontRef>
+        </p:style>
+        <p:txBody>
+          <a:bodyPr rtlCol="0" anchor="ctr" wrap="square"/>
+          <a:lstStyle/>
+          <a:p>
+            <a:pPr algn="ctr">
+              <a:defRPr sz="1150" b="1">
+                <a:solidFill>
+                  <a:srgbClr val="63FCC0"/>
+                </a:solidFill>
+                <a:latin typeface="Segoe UI"/>
+              </a:defRPr>
+            </a:pPr>
+            <a:r>
+              <a:t>3. SUSCRIPCIÓN B2B SAAS ($290k – $1.2M/mes)</a:t>
+            </a:r>
+          </a:p>
+          <a:p>
+            <a:pPr>
+              <a:defRPr sz="1250">
+                <a:solidFill>
+                  <a:srgbClr val="F8FAFC"/>
+                </a:solidFill>
+                <a:latin typeface="Segoe UI"/>
+              </a:defRPr>
+            </a:pPr>
+            <a:r>
+              <a:t>API para comercios y pasarelas que resuelven retractos en 1 clic y previenen multas de hasta 2.000 SMLMV.</a:t>
+            </a:r>
+          </a:p>
+        </p:txBody>
+      </p:sp>
+      <p:pic>
+        <p:nvPicPr>
+          <p:cNvPr id="8" name="Picture 7" descr="image.png"/>
+          <p:cNvPicPr>
+            <a:picLocks noChangeAspect="1"/>
+          </p:cNvPicPr>
+          <p:nvPr/>
+        </p:nvPicPr>
+        <p:blipFill>
+          <a:blip r:embed="rId2"/>
+          <a:stretch>
+            <a:fillRect/>
+          </a:stretch>
+        </p:blipFill>
+        <p:spPr>
+          <a:xfrm>
+            <a:off x="7178040" y="1051560"/>
+            <a:ext cx="4553712" cy="3348318"/>
+          </a:xfrm>
+          <a:prstGeom prst="rect">
+            <a:avLst/>
+          </a:prstGeom>
+        </p:spPr>
+      </p:pic>
+      <p:sp>
+        <p:nvSpPr>
+          <p:cNvPr id="9" name="TextBox 8"/>
+          <p:cNvSpPr txBox="1"/>
+          <p:nvPr/>
+        </p:nvSpPr>
+        <p:spPr>
+          <a:xfrm>
+            <a:off x="457200" y="6355080"/>
+            <a:ext cx="11277295" cy="320040"/>
+          </a:xfrm>
+          <a:prstGeom prst="rect">
+            <a:avLst/>
+          </a:prstGeom>
+          <a:noFill/>
+        </p:spPr>
+        <p:txBody>
+          <a:bodyPr wrap="none">
+            <a:spAutoFit/>
+          </a:bodyPr>
+          <a:lstStyle/>
+          <a:p>
+            <a:pPr>
+              <a:defRPr sz="1000">
+                <a:solidFill>
+                  <a:srgbClr val="94A3B8"/>
+                </a:solidFill>
+                <a:latin typeface="Segoe UI"/>
+              </a:defRPr>
+            </a:pPr>
+            <a:r>
+              <a:t>ReversoYa Colombia · Ley 1480 de 2011 · Decreto 587 de 2016 · RAC 3 Aerocivil   |   Diapositiva 9 de 10</a:t>
             </a:r>
           </a:p>
         </p:txBody>

</xml_diff>

<commit_message>
fix: resolve print bug, remove fake modal, add business-day deadline calculator, fix RAC 3 and >5d logic, escape HTML, and fix canvas/PPTX rendering
</commit_message>
<xml_diff>
--- a/ReversoYa_Presentacion_10Minutos.pptx
+++ b/ReversoYa_Presentacion_10Minutos.pptx
@@ -4514,7 +4514,7 @@
         </p:blipFill>
         <p:spPr>
           <a:xfrm>
-            <a:off x="7178040" y="1051560"/>
+            <a:off x="7178040" y="987552"/>
             <a:ext cx="4553712" cy="3348318"/>
           </a:xfrm>
           <a:prstGeom prst="rect">
@@ -4524,7 +4524,88 @@
       </p:pic>
       <p:sp>
         <p:nvSpPr>
-          <p:cNvPr id="9" name="TextBox 8"/>
+          <p:cNvPr id="9" name="Rounded Rectangle 8"/>
+          <p:cNvSpPr/>
+          <p:nvPr/>
+        </p:nvSpPr>
+        <p:spPr>
+          <a:xfrm>
+            <a:off x="7178040" y="4480560"/>
+            <a:ext cx="4553712" cy="1682496"/>
+          </a:xfrm>
+          <a:prstGeom prst="roundRect">
+            <a:avLst/>
+          </a:prstGeom>
+          <a:solidFill>
+            <a:srgbClr val="131A33"/>
+          </a:solidFill>
+          <a:ln w="19050">
+            <a:solidFill>
+              <a:srgbClr val="00C48C"/>
+            </a:solidFill>
+          </a:ln>
+        </p:spPr>
+        <p:style>
+          <a:lnRef idx="1">
+            <a:schemeClr val="accent1"/>
+          </a:lnRef>
+          <a:fillRef idx="3">
+            <a:schemeClr val="accent1"/>
+          </a:fillRef>
+          <a:effectRef idx="2">
+            <a:schemeClr val="accent1"/>
+          </a:effectRef>
+          <a:fontRef idx="minor">
+            <a:schemeClr val="lt1"/>
+          </a:fontRef>
+        </p:style>
+        <p:txBody>
+          <a:bodyPr rtlCol="0" anchor="ctr" wrap="square"/>
+          <a:lstStyle/>
+          <a:p>
+            <a:pPr algn="ctr">
+              <a:defRPr sz="1100" b="1">
+                <a:solidFill>
+                  <a:srgbClr val="63FCC0"/>
+                </a:solidFill>
+                <a:latin typeface="Segoe UI"/>
+              </a:defRPr>
+            </a:pPr>
+            <a:r>
+              <a:t>ARTEFACTO INTERACTIVO: BRAND_SHIELD</a:t>
+            </a:r>
+          </a:p>
+          <a:p>
+            <a:pPr>
+              <a:defRPr sz="1150" b="1">
+                <a:solidFill>
+                  <a:srgbClr val="FFFFFF"/>
+                </a:solidFill>
+                <a:latin typeface="Segoe UI"/>
+              </a:defRPr>
+            </a:pPr>
+            <a:r>
+              <a:t>Importado desde videos/motion_engine.js · Rubro: 1. NOMBRE · LOGO · ESLOGAN</a:t>
+            </a:r>
+          </a:p>
+          <a:p>
+            <a:pPr>
+              <a:defRPr sz="1100">
+                <a:solidFill>
+                  <a:srgbClr val="CBD5E1"/>
+                </a:solidFill>
+                <a:latin typeface="Segoe UI"/>
+              </a:defRPr>
+            </a:pPr>
+            <a:r>
+              <a:t>ReversoYa: Acción directa sobre el dinero retenido en compras digitales.</a:t>
+            </a:r>
+          </a:p>
+        </p:txBody>
+      </p:sp>
+      <p:sp>
+        <p:nvSpPr>
+          <p:cNvPr id="10" name="TextBox 9"/>
           <p:cNvSpPr txBox="1"/>
           <p:nvPr/>
         </p:nvSpPr>
@@ -4943,7 +5024,7 @@
         </p:blipFill>
         <p:spPr>
           <a:xfrm>
-            <a:off x="7178040" y="1051560"/>
+            <a:off x="7178040" y="987552"/>
             <a:ext cx="4553712" cy="3348318"/>
           </a:xfrm>
           <a:prstGeom prst="rect">
@@ -4953,7 +5034,88 @@
       </p:pic>
       <p:sp>
         <p:nvSpPr>
-          <p:cNvPr id="9" name="TextBox 8"/>
+          <p:cNvPr id="9" name="Rounded Rectangle 8"/>
+          <p:cNvSpPr/>
+          <p:nvPr/>
+        </p:nvSpPr>
+        <p:spPr>
+          <a:xfrm>
+            <a:off x="7178040" y="4480560"/>
+            <a:ext cx="4553712" cy="1682496"/>
+          </a:xfrm>
+          <a:prstGeom prst="roundRect">
+            <a:avLst/>
+          </a:prstGeom>
+          <a:solidFill>
+            <a:srgbClr val="131A33"/>
+          </a:solidFill>
+          <a:ln w="19050">
+            <a:solidFill>
+              <a:srgbClr val="00C48C"/>
+            </a:solidFill>
+          </a:ln>
+        </p:spPr>
+        <p:style>
+          <a:lnRef idx="1">
+            <a:schemeClr val="accent1"/>
+          </a:lnRef>
+          <a:fillRef idx="3">
+            <a:schemeClr val="accent1"/>
+          </a:fillRef>
+          <a:effectRef idx="2">
+            <a:schemeClr val="accent1"/>
+          </a:effectRef>
+          <a:fontRef idx="minor">
+            <a:schemeClr val="lt1"/>
+          </a:fontRef>
+        </p:style>
+        <p:txBody>
+          <a:bodyPr rtlCol="0" anchor="ctr" wrap="square"/>
+          <a:lstStyle/>
+          <a:p>
+            <a:pPr algn="ctr">
+              <a:defRPr sz="1100" b="1">
+                <a:solidFill>
+                  <a:srgbClr val="63FCC0"/>
+                </a:solidFill>
+                <a:latin typeface="Segoe UI"/>
+              </a:defRPr>
+            </a:pPr>
+            <a:r>
+              <a:t>ARTEFACTO INTERACTIVO: IMPACT_SUMMARY</a:t>
+            </a:r>
+          </a:p>
+          <a:p>
+            <a:pPr>
+              <a:defRPr sz="1150" b="1">
+                <a:solidFill>
+                  <a:srgbClr val="FFFFFF"/>
+                </a:solidFill>
+                <a:latin typeface="Segoe UI"/>
+              </a:defRPr>
+            </a:pPr>
+            <a:r>
+              <a:t>Importado desde videos/motion_engine.js · Rubro: CONCLUSIÓN E IMPACTO EN ACCESO A LA JUSTICIA</a:t>
+            </a:r>
+          </a:p>
+          <a:p>
+            <a:pPr>
+              <a:defRPr sz="1100">
+                <a:solidFill>
+                  <a:srgbClr val="CBD5E1"/>
+                </a:solidFill>
+                <a:latin typeface="Segoe UI"/>
+              </a:defRPr>
+            </a:pPr>
+            <a:r>
+              <a:t>Convierte el Estatuto del Consumidor y el Decreto 587 de 2016 en una defensa ciudadana inmediata.</a:t>
+            </a:r>
+          </a:p>
+        </p:txBody>
+      </p:sp>
+      <p:sp>
+        <p:nvSpPr>
+          <p:cNvPr id="10" name="TextBox 9"/>
           <p:cNvSpPr txBox="1"/>
           <p:nvPr/>
         </p:nvSpPr>
@@ -5372,7 +5534,7 @@
         </p:blipFill>
         <p:spPr>
           <a:xfrm>
-            <a:off x="7178040" y="1051560"/>
+            <a:off x="7178040" y="987552"/>
             <a:ext cx="4553712" cy="3348318"/>
           </a:xfrm>
           <a:prstGeom prst="rect">
@@ -5382,7 +5544,88 @@
       </p:pic>
       <p:sp>
         <p:nvSpPr>
-          <p:cNvPr id="9" name="TextBox 8"/>
+          <p:cNvPr id="9" name="Rounded Rectangle 8"/>
+          <p:cNvSpPr/>
+          <p:nvPr/>
+        </p:nvSpPr>
+        <p:spPr>
+          <a:xfrm>
+            <a:off x="7178040" y="4480560"/>
+            <a:ext cx="4553712" cy="1682496"/>
+          </a:xfrm>
+          <a:prstGeom prst="roundRect">
+            <a:avLst/>
+          </a:prstGeom>
+          <a:solidFill>
+            <a:srgbClr val="131A33"/>
+          </a:solidFill>
+          <a:ln w="19050">
+            <a:solidFill>
+              <a:srgbClr val="00C48C"/>
+            </a:solidFill>
+          </a:ln>
+        </p:spPr>
+        <p:style>
+          <a:lnRef idx="1">
+            <a:schemeClr val="accent1"/>
+          </a:lnRef>
+          <a:fillRef idx="3">
+            <a:schemeClr val="accent1"/>
+          </a:fillRef>
+          <a:effectRef idx="2">
+            <a:schemeClr val="accent1"/>
+          </a:effectRef>
+          <a:fontRef idx="minor">
+            <a:schemeClr val="lt1"/>
+          </a:fontRef>
+        </p:style>
+        <p:txBody>
+          <a:bodyPr rtlCol="0" anchor="ctr" wrap="square"/>
+          <a:lstStyle/>
+          <a:p>
+            <a:pPr algn="ctr">
+              <a:defRPr sz="1100" b="1">
+                <a:solidFill>
+                  <a:srgbClr val="63FCC0"/>
+                </a:solidFill>
+                <a:latin typeface="Segoe UI"/>
+              </a:defRPr>
+            </a:pPr>
+            <a:r>
+              <a:t>ARTEFACTO INTERACTIVO: COUNTER</a:t>
+            </a:r>
+          </a:p>
+          <a:p>
+            <a:pPr>
+              <a:defRPr sz="1150" b="1">
+                <a:solidFill>
+                  <a:srgbClr val="FFFFFF"/>
+                </a:solidFill>
+                <a:latin typeface="Segoe UI"/>
+              </a:defRPr>
+            </a:pPr>
+            <a:r>
+              <a:t>Importado desde videos/motion_engine.js · Rubro: 2. IDENTIFICACIÓN DEL PROBLEMA EN COLOMBIA</a:t>
+            </a:r>
+          </a:p>
+          <a:p>
+            <a:pPr>
+              <a:defRPr sz="1100">
+                <a:solidFill>
+                  <a:srgbClr val="CBD5E1"/>
+                </a:solidFill>
+                <a:latin typeface="Segoe UI"/>
+              </a:defRPr>
+            </a:pPr>
+            <a:r>
+              <a:t>1) 'Solo damos bono', 2) 'Reclámele a la transportadora', 3) 'En promoción no hay garantía', 4) 'Espere 60 días'.</a:t>
+            </a:r>
+          </a:p>
+        </p:txBody>
+      </p:sp>
+      <p:sp>
+        <p:nvSpPr>
+          <p:cNvPr id="10" name="TextBox 9"/>
           <p:cNvSpPr txBox="1"/>
           <p:nvPr/>
         </p:nvSpPr>
@@ -5801,7 +6044,7 @@
         </p:blipFill>
         <p:spPr>
           <a:xfrm>
-            <a:off x="7178040" y="1051560"/>
+            <a:off x="7178040" y="987552"/>
             <a:ext cx="4553712" cy="3348318"/>
           </a:xfrm>
           <a:prstGeom prst="rect">
@@ -5811,7 +6054,88 @@
       </p:pic>
       <p:sp>
         <p:nvSpPr>
-          <p:cNvPr id="9" name="TextBox 8"/>
+          <p:cNvPr id="9" name="Rounded Rectangle 8"/>
+          <p:cNvSpPr/>
+          <p:nvPr/>
+        </p:nvSpPr>
+        <p:spPr>
+          <a:xfrm>
+            <a:off x="7178040" y="4480560"/>
+            <a:ext cx="4553712" cy="1682496"/>
+          </a:xfrm>
+          <a:prstGeom prst="roundRect">
+            <a:avLst/>
+          </a:prstGeom>
+          <a:solidFill>
+            <a:srgbClr val="131A33"/>
+          </a:solidFill>
+          <a:ln w="19050">
+            <a:solidFill>
+              <a:srgbClr val="00C48C"/>
+            </a:solidFill>
+          </a:ln>
+        </p:spPr>
+        <p:style>
+          <a:lnRef idx="1">
+            <a:schemeClr val="accent1"/>
+          </a:lnRef>
+          <a:fillRef idx="3">
+            <a:schemeClr val="accent1"/>
+          </a:fillRef>
+          <a:effectRef idx="2">
+            <a:schemeClr val="accent1"/>
+          </a:effectRef>
+          <a:fontRef idx="minor">
+            <a:schemeClr val="lt1"/>
+          </a:fontRef>
+        </p:style>
+        <p:txBody>
+          <a:bodyPr rtlCol="0" anchor="ctr" wrap="square"/>
+          <a:lstStyle/>
+          <a:p>
+            <a:pPr algn="ctr">
+              <a:defRPr sz="1100" b="1">
+                <a:solidFill>
+                  <a:srgbClr val="63FCC0"/>
+                </a:solidFill>
+                <a:latin typeface="Segoe UI"/>
+              </a:defRPr>
+            </a:pPr>
+            <a:r>
+              <a:t>ARTEFACTO INTERACTIVO: PILLARS</a:t>
+            </a:r>
+          </a:p>
+          <a:p>
+            <a:pPr>
+              <a:defRPr sz="1150" b="1">
+                <a:solidFill>
+                  <a:srgbClr val="FFFFFF"/>
+                </a:solidFill>
+                <a:latin typeface="Segoe UI"/>
+              </a:defRPr>
+            </a:pPr>
+            <a:r>
+              <a:t>Importado desde videos/motion_engine.js · Rubro: 2. PROBLEMA JURÍDICO · DERECHOS · LEGISLACIÓN</a:t>
+            </a:r>
+          </a:p>
+          <a:p>
+            <a:pPr>
+              <a:defRPr sz="1100">
+                <a:solidFill>
+                  <a:srgbClr val="CBD5E1"/>
+                </a:solidFill>
+                <a:latin typeface="Segoe UI"/>
+              </a:defRPr>
+            </a:pPr>
+            <a:r>
+              <a:t>Art. 78 C.P. (protección al consumidor), Art. 229 C.P. (acceso a la justicia) y Directrices ONU (Res. A/RES/70/186).</a:t>
+            </a:r>
+          </a:p>
+        </p:txBody>
+      </p:sp>
+      <p:sp>
+        <p:nvSpPr>
+          <p:cNvPr id="10" name="TextBox 9"/>
           <p:cNvSpPr txBox="1"/>
           <p:nvPr/>
         </p:nvSpPr>
@@ -6230,7 +6554,7 @@
         </p:blipFill>
         <p:spPr>
           <a:xfrm>
-            <a:off x="7178040" y="1051560"/>
+            <a:off x="7178040" y="987552"/>
             <a:ext cx="4553712" cy="3348318"/>
           </a:xfrm>
           <a:prstGeom prst="rect">
@@ -6240,7 +6564,88 @@
       </p:pic>
       <p:sp>
         <p:nvSpPr>
-          <p:cNvPr id="9" name="TextBox 8"/>
+          <p:cNvPr id="9" name="Rounded Rectangle 8"/>
+          <p:cNvSpPr/>
+          <p:nvPr/>
+        </p:nvSpPr>
+        <p:spPr>
+          <a:xfrm>
+            <a:off x="7178040" y="4480560"/>
+            <a:ext cx="4553712" cy="1682496"/>
+          </a:xfrm>
+          <a:prstGeom prst="roundRect">
+            <a:avLst/>
+          </a:prstGeom>
+          <a:solidFill>
+            <a:srgbClr val="131A33"/>
+          </a:solidFill>
+          <a:ln w="19050">
+            <a:solidFill>
+              <a:srgbClr val="00C48C"/>
+            </a:solidFill>
+          </a:ln>
+        </p:spPr>
+        <p:style>
+          <a:lnRef idx="1">
+            <a:schemeClr val="accent1"/>
+          </a:lnRef>
+          <a:fillRef idx="3">
+            <a:schemeClr val="accent1"/>
+          </a:fillRef>
+          <a:effectRef idx="2">
+            <a:schemeClr val="accent1"/>
+          </a:effectRef>
+          <a:fontRef idx="minor">
+            <a:schemeClr val="lt1"/>
+          </a:fontRef>
+        </p:style>
+        <p:txBody>
+          <a:bodyPr rtlCol="0" anchor="ctr" wrap="square"/>
+          <a:lstStyle/>
+          <a:p>
+            <a:pPr algn="ctr">
+              <a:defRPr sz="1100" b="1">
+                <a:solidFill>
+                  <a:srgbClr val="63FCC0"/>
+                </a:solidFill>
+                <a:latin typeface="Segoe UI"/>
+              </a:defRPr>
+            </a:pPr>
+            <a:r>
+              <a:t>ARTEFACTO INTERACTIVO: BARS</a:t>
+            </a:r>
+          </a:p>
+          <a:p>
+            <a:pPr>
+              <a:defRPr sz="1150" b="1">
+                <a:solidFill>
+                  <a:srgbClr val="FFFFFF"/>
+                </a:solidFill>
+                <a:latin typeface="Segoe UI"/>
+              </a:defRPr>
+            </a:pPr>
+            <a:r>
+              <a:t>Importado desde videos/motion_engine.js · Rubro: 3. PÚBLICO OBJETIVO</a:t>
+            </a:r>
+          </a:p>
+          <a:p>
+            <a:pPr>
+              <a:defRPr sz="1100">
+                <a:solidFill>
+                  <a:srgbClr val="CBD5E1"/>
+                </a:solidFill>
+                <a:latin typeface="Segoe UI"/>
+              </a:defRPr>
+            </a:pPr>
+            <a:r>
+              <a:t>Colombianos de 18 a 55 años (estratos 2 al 5) que compran online, en Instagram/WhatsApp o aerolíneas.</a:t>
+            </a:r>
+          </a:p>
+        </p:txBody>
+      </p:sp>
+      <p:sp>
+        <p:nvSpPr>
+          <p:cNvPr id="10" name="TextBox 9"/>
           <p:cNvSpPr txBox="1"/>
           <p:nvPr/>
         </p:nvSpPr>
@@ -6659,7 +7064,7 @@
         </p:blipFill>
         <p:spPr>
           <a:xfrm>
-            <a:off x="7178040" y="1051560"/>
+            <a:off x="7178040" y="987552"/>
             <a:ext cx="4553712" cy="3348318"/>
           </a:xfrm>
           <a:prstGeom prst="rect">
@@ -6669,7 +7074,88 @@
       </p:pic>
       <p:sp>
         <p:nvSpPr>
-          <p:cNvPr id="9" name="TextBox 8"/>
+          <p:cNvPr id="9" name="Rounded Rectangle 8"/>
+          <p:cNvSpPr/>
+          <p:nvPr/>
+        </p:nvSpPr>
+        <p:spPr>
+          <a:xfrm>
+            <a:off x="7178040" y="4480560"/>
+            <a:ext cx="4553712" cy="1682496"/>
+          </a:xfrm>
+          <a:prstGeom prst="roundRect">
+            <a:avLst/>
+          </a:prstGeom>
+          <a:solidFill>
+            <a:srgbClr val="131A33"/>
+          </a:solidFill>
+          <a:ln w="19050">
+            <a:solidFill>
+              <a:srgbClr val="00C48C"/>
+            </a:solidFill>
+          </a:ln>
+        </p:spPr>
+        <p:style>
+          <a:lnRef idx="1">
+            <a:schemeClr val="accent1"/>
+          </a:lnRef>
+          <a:fillRef idx="3">
+            <a:schemeClr val="accent1"/>
+          </a:fillRef>
+          <a:effectRef idx="2">
+            <a:schemeClr val="accent1"/>
+          </a:effectRef>
+          <a:fontRef idx="minor">
+            <a:schemeClr val="lt1"/>
+          </a:fontRef>
+        </p:style>
+        <p:txBody>
+          <a:bodyPr rtlCol="0" anchor="ctr" wrap="square"/>
+          <a:lstStyle/>
+          <a:p>
+            <a:pPr algn="ctr">
+              <a:defRPr sz="1100" b="1">
+                <a:solidFill>
+                  <a:srgbClr val="63FCC0"/>
+                </a:solidFill>
+                <a:latin typeface="Segoe UI"/>
+              </a:defRPr>
+            </a:pPr>
+            <a:r>
+              <a:t>ARTEFACTO INTERACTIVO: CHAT_EXCUSES</a:t>
+            </a:r>
+          </a:p>
+          <a:p>
+            <a:pPr>
+              <a:defRPr sz="1150" b="1">
+                <a:solidFill>
+                  <a:srgbClr val="FFFFFF"/>
+                </a:solidFill>
+                <a:latin typeface="Segoe UI"/>
+              </a:defRPr>
+            </a:pPr>
+            <a:r>
+              <a:t>Importado desde videos/motion_engine.js · Rubro: 4. SOLUCIÓN Y FLUJO DE PANTALLAS (PARTE 1)</a:t>
+            </a:r>
+          </a:p>
+          <a:p>
+            <a:pPr>
+              <a:defRPr sz="1100">
+                <a:solidFill>
+                  <a:srgbClr val="CBD5E1"/>
+                </a:solidFill>
+                <a:latin typeface="Segoe UI"/>
+              </a:defRPr>
+            </a:pPr>
+            <a:r>
+              <a:t>Selecciona causal, monto, medio de pago (PSE/Nequi/Tarjeta) y verifica si aplica reversión bancaria o ruta SIC.</a:t>
+            </a:r>
+          </a:p>
+        </p:txBody>
+      </p:sp>
+      <p:sp>
+        <p:nvSpPr>
+          <p:cNvPr id="10" name="TextBox 9"/>
           <p:cNvSpPr txBox="1"/>
           <p:nvPr/>
         </p:nvSpPr>
@@ -7088,7 +7574,7 @@
         </p:blipFill>
         <p:spPr>
           <a:xfrm>
-            <a:off x="7178040" y="1051560"/>
+            <a:off x="7178040" y="987552"/>
             <a:ext cx="4553712" cy="3348318"/>
           </a:xfrm>
           <a:prstGeom prst="rect">
@@ -7098,7 +7584,88 @@
       </p:pic>
       <p:sp>
         <p:nvSpPr>
-          <p:cNvPr id="9" name="TextBox 8"/>
+          <p:cNvPr id="9" name="Rounded Rectangle 8"/>
+          <p:cNvSpPr/>
+          <p:nvPr/>
+        </p:nvSpPr>
+        <p:spPr>
+          <a:xfrm>
+            <a:off x="7178040" y="4480560"/>
+            <a:ext cx="4553712" cy="1682496"/>
+          </a:xfrm>
+          <a:prstGeom prst="roundRect">
+            <a:avLst/>
+          </a:prstGeom>
+          <a:solidFill>
+            <a:srgbClr val="131A33"/>
+          </a:solidFill>
+          <a:ln w="19050">
+            <a:solidFill>
+              <a:srgbClr val="00C48C"/>
+            </a:solidFill>
+          </a:ln>
+        </p:spPr>
+        <p:style>
+          <a:lnRef idx="1">
+            <a:schemeClr val="accent1"/>
+          </a:lnRef>
+          <a:fillRef idx="3">
+            <a:schemeClr val="accent1"/>
+          </a:fillRef>
+          <a:effectRef idx="2">
+            <a:schemeClr val="accent1"/>
+          </a:effectRef>
+          <a:fontRef idx="minor">
+            <a:schemeClr val="lt1"/>
+          </a:fontRef>
+        </p:style>
+        <p:txBody>
+          <a:bodyPr rtlCol="0" anchor="ctr" wrap="square"/>
+          <a:lstStyle/>
+          <a:p>
+            <a:pPr algn="ctr">
+              <a:defRPr sz="1100" b="1">
+                <a:solidFill>
+                  <a:srgbClr val="63FCC0"/>
+                </a:solidFill>
+                <a:latin typeface="Segoe UI"/>
+              </a:defRPr>
+            </a:pPr>
+            <a:r>
+              <a:t>ARTEFACTO INTERACTIVO: TIMELINE15</a:t>
+            </a:r>
+          </a:p>
+          <a:p>
+            <a:pPr>
+              <a:defRPr sz="1150" b="1">
+                <a:solidFill>
+                  <a:srgbClr val="FFFFFF"/>
+                </a:solidFill>
+                <a:latin typeface="Segoe UI"/>
+              </a:defRPr>
+            </a:pPr>
+            <a:r>
+              <a:t>Importado desde videos/motion_engine.js · Rubro: 4. SOLUCIÓN Y FLUJO DE PANTALLAS (PARTE 2)</a:t>
+            </a:r>
+          </a:p>
+          <a:p>
+            <a:pPr>
+              <a:defRPr sz="1100">
+                <a:solidFill>
+                  <a:srgbClr val="CBD5E1"/>
+                </a:solidFill>
+                <a:latin typeface="Segoe UI"/>
+              </a:defRPr>
+            </a:pPr>
+            <a:r>
+              <a:t>Solicitud formal bajo juramento exigiendo la reversión del 100% al instrumento de pago electrónico.</a:t>
+            </a:r>
+          </a:p>
+        </p:txBody>
+      </p:sp>
+      <p:sp>
+        <p:nvSpPr>
+          <p:cNvPr id="10" name="TextBox 9"/>
           <p:cNvSpPr txBox="1"/>
           <p:nvPr/>
         </p:nvSpPr>
@@ -7517,7 +8084,7 @@
         </p:blipFill>
         <p:spPr>
           <a:xfrm>
-            <a:off x="7178040" y="1051560"/>
+            <a:off x="7178040" y="987552"/>
             <a:ext cx="4553712" cy="3348318"/>
           </a:xfrm>
           <a:prstGeom prst="rect">
@@ -7527,7 +8094,88 @@
       </p:pic>
       <p:sp>
         <p:nvSpPr>
-          <p:cNvPr id="9" name="TextBox 8"/>
+          <p:cNvPr id="9" name="Rounded Rectangle 8"/>
+          <p:cNvSpPr/>
+          <p:nvPr/>
+        </p:nvSpPr>
+        <p:spPr>
+          <a:xfrm>
+            <a:off x="7178040" y="4480560"/>
+            <a:ext cx="4553712" cy="1682496"/>
+          </a:xfrm>
+          <a:prstGeom prst="roundRect">
+            <a:avLst/>
+          </a:prstGeom>
+          <a:solidFill>
+            <a:srgbClr val="131A33"/>
+          </a:solidFill>
+          <a:ln w="19050">
+            <a:solidFill>
+              <a:srgbClr val="00C48C"/>
+            </a:solidFill>
+          </a:ln>
+        </p:spPr>
+        <p:style>
+          <a:lnRef idx="1">
+            <a:schemeClr val="accent1"/>
+          </a:lnRef>
+          <a:fillRef idx="3">
+            <a:schemeClr val="accent1"/>
+          </a:fillRef>
+          <a:effectRef idx="2">
+            <a:schemeClr val="accent1"/>
+          </a:effectRef>
+          <a:fontRef idx="minor">
+            <a:schemeClr val="lt1"/>
+          </a:fontRef>
+        </p:style>
+        <p:txBody>
+          <a:bodyPr rtlCol="0" anchor="ctr" wrap="square"/>
+          <a:lstStyle/>
+          <a:p>
+            <a:pPr algn="ctr">
+              <a:defRPr sz="1100" b="1">
+                <a:solidFill>
+                  <a:srgbClr val="63FCC0"/>
+                </a:solidFill>
+                <a:latin typeface="Segoe UI"/>
+              </a:defRPr>
+            </a:pPr>
+            <a:r>
+              <a:t>ARTEFACTO INTERACTIVO: FLIGHT_RAC3</a:t>
+            </a:r>
+          </a:p>
+          <a:p>
+            <a:pPr>
+              <a:defRPr sz="1150" b="1">
+                <a:solidFill>
+                  <a:srgbClr val="FFFFFF"/>
+                </a:solidFill>
+                <a:latin typeface="Segoe UI"/>
+              </a:defRPr>
+            </a:pPr>
+            <a:r>
+              <a:t>Importado desde videos/motion_engine.js · Rubro: 4. ALCANCE SECTORIAL · TRANSPORTE AÉREO RAC 3</a:t>
+            </a:r>
+          </a:p>
+          <a:p>
+            <a:pPr>
+              <a:defRPr sz="1100">
+                <a:solidFill>
+                  <a:srgbClr val="CBD5E1"/>
+                </a:solidFill>
+                <a:latin typeface="Segoe UI"/>
+              </a:defRPr>
+            </a:pPr>
+            <a:r>
+              <a:t>En un tiquete de $540.000 COP, ordena la reversión íntegra de $540.000 COP a través del banco emisor.</a:t>
+            </a:r>
+          </a:p>
+        </p:txBody>
+      </p:sp>
+      <p:sp>
+        <p:nvSpPr>
+          <p:cNvPr id="10" name="TextBox 9"/>
           <p:cNvSpPr txBox="1"/>
           <p:nvPr/>
         </p:nvSpPr>
@@ -7946,7 +8594,7 @@
         </p:blipFill>
         <p:spPr>
           <a:xfrm>
-            <a:off x="7178040" y="1051560"/>
+            <a:off x="7178040" y="987552"/>
             <a:ext cx="4553712" cy="3348318"/>
           </a:xfrm>
           <a:prstGeom prst="rect">
@@ -7956,7 +8604,88 @@
       </p:pic>
       <p:sp>
         <p:nvSpPr>
-          <p:cNvPr id="9" name="TextBox 8"/>
+          <p:cNvPr id="9" name="Rounded Rectangle 8"/>
+          <p:cNvSpPr/>
+          <p:nvPr/>
+        </p:nvSpPr>
+        <p:spPr>
+          <a:xfrm>
+            <a:off x="7178040" y="4480560"/>
+            <a:ext cx="4553712" cy="1682496"/>
+          </a:xfrm>
+          <a:prstGeom prst="roundRect">
+            <a:avLst/>
+          </a:prstGeom>
+          <a:solidFill>
+            <a:srgbClr val="131A33"/>
+          </a:solidFill>
+          <a:ln w="19050">
+            <a:solidFill>
+              <a:srgbClr val="00C48C"/>
+            </a:solidFill>
+          </a:ln>
+        </p:spPr>
+        <p:style>
+          <a:lnRef idx="1">
+            <a:schemeClr val="accent1"/>
+          </a:lnRef>
+          <a:fillRef idx="3">
+            <a:schemeClr val="accent1"/>
+          </a:fillRef>
+          <a:effectRef idx="2">
+            <a:schemeClr val="accent1"/>
+          </a:effectRef>
+          <a:fontRef idx="minor">
+            <a:schemeClr val="lt1"/>
+          </a:fontRef>
+        </p:style>
+        <p:txBody>
+          <a:bodyPr rtlCol="0" anchor="ctr" wrap="square"/>
+          <a:lstStyle/>
+          <a:p>
+            <a:pPr algn="ctr">
+              <a:defRPr sz="1100" b="1">
+                <a:solidFill>
+                  <a:srgbClr val="63FCC0"/>
+                </a:solidFill>
+                <a:latin typeface="Segoe UI"/>
+              </a:defRPr>
+            </a:pPr>
+            <a:r>
+              <a:t>ARTEFACTO INTERACTIVO: BENCHMARK_MATRIX</a:t>
+            </a:r>
+          </a:p>
+          <a:p>
+            <a:pPr>
+              <a:defRPr sz="1150" b="1">
+                <a:solidFill>
+                  <a:srgbClr val="FFFFFF"/>
+                </a:solidFill>
+                <a:latin typeface="Segoe UI"/>
+              </a:defRPr>
+            </a:pPr>
+            <a:r>
+              <a:t>Importado desde videos/motion_engine.js · Rubro: 5. PROPUESTA DE VALOR Y BENCHMARK EN COLOMBIA</a:t>
+            </a:r>
+          </a:p>
+          <a:p>
+            <a:pPr>
+              <a:defRPr sz="1100">
+                <a:solidFill>
+                  <a:srgbClr val="CBD5E1"/>
+                </a:solidFill>
+                <a:latin typeface="Segoe UI"/>
+              </a:defRPr>
+            </a:pPr>
+            <a:r>
+              <a:t>SIC Facilita solo opera con comercios inscritos voluntariamente; ReversoYa vincula directamente al banco/PSE.</a:t>
+            </a:r>
+          </a:p>
+        </p:txBody>
+      </p:sp>
+      <p:sp>
+        <p:nvSpPr>
+          <p:cNvPr id="10" name="TextBox 9"/>
           <p:cNvSpPr txBox="1"/>
           <p:nvPr/>
         </p:nvSpPr>
@@ -8375,7 +9104,7 @@
         </p:blipFill>
         <p:spPr>
           <a:xfrm>
-            <a:off x="7178040" y="1051560"/>
+            <a:off x="7178040" y="987552"/>
             <a:ext cx="4553712" cy="3348318"/>
           </a:xfrm>
           <a:prstGeom prst="rect">
@@ -8385,7 +9114,88 @@
       </p:pic>
       <p:sp>
         <p:nvSpPr>
-          <p:cNvPr id="9" name="TextBox 8"/>
+          <p:cNvPr id="9" name="Rounded Rectangle 8"/>
+          <p:cNvSpPr/>
+          <p:nvPr/>
+        </p:nvSpPr>
+        <p:spPr>
+          <a:xfrm>
+            <a:off x="7178040" y="4480560"/>
+            <a:ext cx="4553712" cy="1682496"/>
+          </a:xfrm>
+          <a:prstGeom prst="roundRect">
+            <a:avLst/>
+          </a:prstGeom>
+          <a:solidFill>
+            <a:srgbClr val="131A33"/>
+          </a:solidFill>
+          <a:ln w="19050">
+            <a:solidFill>
+              <a:srgbClr val="00C48C"/>
+            </a:solidFill>
+          </a:ln>
+        </p:spPr>
+        <p:style>
+          <a:lnRef idx="1">
+            <a:schemeClr val="accent1"/>
+          </a:lnRef>
+          <a:fillRef idx="3">
+            <a:schemeClr val="accent1"/>
+          </a:fillRef>
+          <a:effectRef idx="2">
+            <a:schemeClr val="accent1"/>
+          </a:effectRef>
+          <a:fontRef idx="minor">
+            <a:schemeClr val="lt1"/>
+          </a:fontRef>
+        </p:style>
+        <p:txBody>
+          <a:bodyPr rtlCol="0" anchor="ctr" wrap="square"/>
+          <a:lstStyle/>
+          <a:p>
+            <a:pPr algn="ctr">
+              <a:defRPr sz="1100" b="1">
+                <a:solidFill>
+                  <a:srgbClr val="63FCC0"/>
+                </a:solidFill>
+                <a:latin typeface="Segoe UI"/>
+              </a:defRPr>
+            </a:pPr>
+            <a:r>
+              <a:t>ARTEFACTO INTERACTIVO: PRICING_TIERS</a:t>
+            </a:r>
+          </a:p>
+          <a:p>
+            <a:pPr>
+              <a:defRPr sz="1150" b="1">
+                <a:solidFill>
+                  <a:srgbClr val="FFFFFF"/>
+                </a:solidFill>
+                <a:latin typeface="Segoe UI"/>
+              </a:defRPr>
+            </a:pPr>
+            <a:r>
+              <a:t>Importado desde videos/motion_engine.js · Rubro: 6. MODELO DE NEGOCIO</a:t>
+            </a:r>
+          </a:p>
+          <a:p>
+            <a:pPr>
+              <a:defRPr sz="1100">
+                <a:solidFill>
+                  <a:srgbClr val="CBD5E1"/>
+                </a:solidFill>
+                <a:latin typeface="Segoe UI"/>
+              </a:defRPr>
+            </a:pPr>
+            <a:r>
+              <a:t>Diagnóstico de plazos, auditoría de excusas y descarga manual de los 3 oficios totalmente gratis.</a:t>
+            </a:r>
+          </a:p>
+        </p:txBody>
+      </p:sp>
+      <p:sp>
+        <p:nvSpPr>
+          <p:cNvPr id="10" name="TextBox 9"/>
           <p:cNvSpPr txBox="1"/>
           <p:nvPr/>
         </p:nvSpPr>

</xml_diff>

<commit_message>
Unify all 5 chapters into a single continuous animation and remove Motion Design labels and timers
</commit_message>
<xml_diff>
--- a/ReversoYa_Presentacion_10Minutos.pptx
+++ b/ReversoYa_Presentacion_10Minutos.pptx
@@ -581,7 +581,7 @@
           <a:lstStyle/>
           <a:p>
             <a:r>
-              <a:t>En conclusión: con ReversoYa demostramos que cuando el artículo 78 de la Constitución y la Ley 1480 se traducen en una herramienta clara de tres minutos, el abuso comercial deja de ser rentable. Muchas gracias.</a:t>
+              <a:t>En conclusión: con ReversoYa demostramos que cuando el artículo 78 de la Constitución y la Ley 1480 se traducen en una herramienta clara para el ciudadano, el abuso comercial deja de ser rentable. Muchas gracias.</a:t>
             </a:r>
           </a:p>
         </p:txBody>
@@ -4240,7 +4240,7 @@
               </a:defRPr>
             </a:pPr>
             <a:r>
-              <a:t>DIAPOSITIVA 1 DE 10 · 00:00 – 00:50 (50s)   |   1. NOMBRE · LOGO · ESLOGAN</a:t>
+              <a:t>DIAPOSITIVA 1 DE 10   |   1. NOMBRE · LOGO · ESLOGAN</a:t>
             </a:r>
           </a:p>
         </p:txBody>
@@ -4572,7 +4572,7 @@
               </a:defRPr>
             </a:pPr>
             <a:r>
-              <a:t>ARTEFACTO INTERACTIVO: BRAND_SHIELD</a:t>
+              <a:t>FUNDAMENTO NORMATIVO EN COLOMBIA</a:t>
             </a:r>
           </a:p>
           <a:p>
@@ -4585,7 +4585,7 @@
               </a:defRPr>
             </a:pPr>
             <a:r>
-              <a:t>Importado desde videos/motion_engine.js · Rubro: 1. NOMBRE · LOGO · ESLOGAN</a:t>
+              <a:t>Art. 51 Ley 1480 de 2011 · Decreto 587 de 2016</a:t>
             </a:r>
           </a:p>
           <a:p>
@@ -4750,7 +4750,7 @@
               </a:defRPr>
             </a:pPr>
             <a:r>
-              <a:t>DIAPOSITIVA 10 DE 10 · 09:30 – 10:00 (30s)   |   CONCLUSIÓN E IMPACTO EN ACCESO A LA JUSTICIA</a:t>
+              <a:t>DIAPOSITIVA 10 DE 10   |   CONCLUSIÓN E IMPACTO EN ACCESO A LA JUSTICIA</a:t>
             </a:r>
           </a:p>
         </p:txBody>
@@ -4786,7 +4786,7 @@
               </a:defRPr>
             </a:pPr>
             <a:r>
-              <a:t>Cuando la ley es ejecutable en 3 minutos, el abuso desaparece</a:t>
+              <a:t>Cuando la ley es ejecutable para el ciudadano, el abuso desaparece</a:t>
             </a:r>
           </a:p>
           <a:p>
@@ -5082,7 +5082,7 @@
               </a:defRPr>
             </a:pPr>
             <a:r>
-              <a:t>ARTEFACTO INTERACTIVO: IMPACT_SUMMARY</a:t>
+              <a:t>FUNDAMENTO NORMATIVO EN COLOMBIA</a:t>
             </a:r>
           </a:p>
           <a:p>
@@ -5095,7 +5095,7 @@
               </a:defRPr>
             </a:pPr>
             <a:r>
-              <a:t>Importado desde videos/motion_engine.js · Rubro: CONCLUSIÓN E IMPACTO EN ACCESO A LA JUSTICIA</a:t>
+              <a:t>Protección Constitucional del Consumidor en Colombia</a:t>
             </a:r>
           </a:p>
           <a:p>
@@ -5260,7 +5260,7 @@
               </a:defRPr>
             </a:pPr>
             <a:r>
-              <a:t>DIAPOSITIVA 2 DE 10 · 00:50 – 02:00 (70s)   |   2. IDENTIFICACIÓN DEL PROBLEMA EN COLOMBIA</a:t>
+              <a:t>DIAPOSITIVA 2 DE 10   |   2. IDENTIFICACIÓN DEL PROBLEMA EN COLOMBIA</a:t>
             </a:r>
           </a:p>
         </p:txBody>
@@ -5592,7 +5592,7 @@
               </a:defRPr>
             </a:pPr>
             <a:r>
-              <a:t>ARTEFACTO INTERACTIVO: COUNTER</a:t>
+              <a:t>FUNDAMENTO NORMATIVO EN COLOMBIA</a:t>
             </a:r>
           </a:p>
           <a:p>
@@ -5605,7 +5605,7 @@
               </a:defRPr>
             </a:pPr>
             <a:r>
-              <a:t>Importado desde videos/motion_engine.js · Rubro: 2. IDENTIFICACIÓN DEL PROBLEMA EN COLOMBIA</a:t>
+              <a:t>Cámara Colombiana de Comercio Electrónico (CCCE) · Informes SIC</a:t>
             </a:r>
           </a:p>
           <a:p>
@@ -5770,7 +5770,7 @@
               </a:defRPr>
             </a:pPr>
             <a:r>
-              <a:t>DIAPOSITIVA 3 DE 10 · 02:00 – 03:15 (75s)   |   2. PROBLEMA JURÍDICO · DERECHOS · LEGISLACIÓN</a:t>
+              <a:t>DIAPOSITIVA 3 DE 10   |   2. PROBLEMA JURÍDICO · DERECHOS · LEGISLACIÓN</a:t>
             </a:r>
           </a:p>
         </p:txBody>
@@ -6102,7 +6102,7 @@
               </a:defRPr>
             </a:pPr>
             <a:r>
-              <a:t>ARTEFACTO INTERACTIVO: PILLARS</a:t>
+              <a:t>FUNDAMENTO NORMATIVO EN COLOMBIA</a:t>
             </a:r>
           </a:p>
           <a:p>
@@ -6115,7 +6115,7 @@
               </a:defRPr>
             </a:pPr>
             <a:r>
-              <a:t>Importado desde videos/motion_engine.js · Rubro: 2. PROBLEMA JURÍDICO · DERECHOS · LEGISLACIÓN</a:t>
+              <a:t>Arts. 78 y 229 C.P. · Ley 1480/2011 · Decreto 587/2016 · RAC 3</a:t>
             </a:r>
           </a:p>
           <a:p>
@@ -6280,7 +6280,7 @@
               </a:defRPr>
             </a:pPr>
             <a:r>
-              <a:t>DIAPOSITIVA 4 DE 10 · 03:15 – 04:15 (60s)   |   3. PÚBLICO OBJETIVO</a:t>
+              <a:t>DIAPOSITIVA 4 DE 10   |   3. PÚBLICO OBJETIVO</a:t>
             </a:r>
           </a:p>
         </p:txBody>
@@ -6612,7 +6612,7 @@
               </a:defRPr>
             </a:pPr>
             <a:r>
-              <a:t>ARTEFACTO INTERACTIVO: BARS</a:t>
+              <a:t>FUNDAMENTO NORMATIVO EN COLOMBIA</a:t>
             </a:r>
           </a:p>
           <a:p>
@@ -6625,7 +6625,7 @@
               </a:defRPr>
             </a:pPr>
             <a:r>
-              <a:t>Importado desde videos/motion_engine.js · Rubro: 3. PÚBLICO OBJETIVO</a:t>
+              <a:t>Acceso Material a la Justicia (Art. 229 C.P. y Art. 61 Ley 1480)</a:t>
             </a:r>
           </a:p>
           <a:p>
@@ -6790,7 +6790,7 @@
               </a:defRPr>
             </a:pPr>
             <a:r>
-              <a:t>DIAPOSITIVA 5 DE 10 · 04:15 – 05:30 (75s)   |   4. SOLUCIÓN Y FLUJO DE PANTALLAS (PARTE 1)</a:t>
+              <a:t>DIAPOSITIVA 5 DE 10   |   4. SOLUCIÓN Y FLUJO DE PANTALLAS (PARTE 1)</a:t>
             </a:r>
           </a:p>
         </p:txBody>
@@ -7122,7 +7122,7 @@
               </a:defRPr>
             </a:pPr>
             <a:r>
-              <a:t>ARTEFACTO INTERACTIVO: CHAT_EXCUSES</a:t>
+              <a:t>FUNDAMENTO NORMATIVO EN COLOMBIA</a:t>
             </a:r>
           </a:p>
           <a:p>
@@ -7135,7 +7135,7 @@
               </a:defRPr>
             </a:pPr>
             <a:r>
-              <a:t>Importado desde videos/motion_engine.js · Rubro: 4. SOLUCIÓN Y FLUJO DE PANTALLAS (PARTE 1)</a:t>
+              <a:t>Arts. 43, 47 y 50 Ley 1480 de 2011 · Ley 527 de 1999</a:t>
             </a:r>
           </a:p>
           <a:p>
@@ -7300,7 +7300,7 @@
               </a:defRPr>
             </a:pPr>
             <a:r>
-              <a:t>DIAPOSITIVA 6 DE 10 · 05:30 – 06:45 (75s)   |   4. SOLUCIÓN Y FLUJO DE PANTALLAS (PARTE 2)</a:t>
+              <a:t>DIAPOSITIVA 6 DE 10   |   4. SOLUCIÓN Y FLUJO DE PANTALLAS (PARTE 2)</a:t>
             </a:r>
           </a:p>
         </p:txBody>
@@ -7336,7 +7336,7 @@
               </a:defRPr>
             </a:pPr>
             <a:r>
-              <a:t>Flujo Guiado: Pantallas 3 y 4 (3 Oficios y Reloj de 15 Días)</a:t>
+              <a:t>Flujo Guiado: Pantallas 3 y 4 (3 Oficios y Plazo de 15 Días)</a:t>
             </a:r>
           </a:p>
           <a:p>
@@ -7540,7 +7540,7 @@
               </a:defRPr>
             </a:pPr>
             <a:r>
-              <a:t>PANTALLA 4: CRONÓMETRO DE 15 DÍAS HÁBILES</a:t>
+              <a:t>PANTALLA 4: PLAZO DE 15 DÍAS HÁBILES</a:t>
             </a:r>
           </a:p>
           <a:p>
@@ -7632,7 +7632,7 @@
               </a:defRPr>
             </a:pPr>
             <a:r>
-              <a:t>ARTEFACTO INTERACTIVO: TIMELINE15</a:t>
+              <a:t>FUNDAMENTO NORMATIVO EN COLOMBIA</a:t>
             </a:r>
           </a:p>
           <a:p>
@@ -7645,7 +7645,7 @@
               </a:defRPr>
             </a:pPr>
             <a:r>
-              <a:t>Importado desde videos/motion_engine.js · Rubro: 4. SOLUCIÓN Y FLUJO DE PANTALLAS (PARTE 2)</a:t>
+              <a:t>Arts. 2.2.2.51.3 y 2.2.2.51.5 Decreto 1074 de 2015</a:t>
             </a:r>
           </a:p>
           <a:p>
@@ -7810,7 +7810,7 @@
               </a:defRPr>
             </a:pPr>
             <a:r>
-              <a:t>DIAPOSITIVA 7 DE 10 · 06:45 – 07:45 (60s)   |   4. ALCANCE SECTORIAL · TRANSPORTE AÉREO RAC 3</a:t>
+              <a:t>DIAPOSITIVA 7 DE 10   |   4. ALCANCE SECTORIAL · TRANSPORTE AÉREO RAC 3</a:t>
             </a:r>
           </a:p>
         </p:txBody>
@@ -8142,7 +8142,7 @@
               </a:defRPr>
             </a:pPr>
             <a:r>
-              <a:t>ARTEFACTO INTERACTIVO: FLIGHT_RAC3</a:t>
+              <a:t>FUNDAMENTO NORMATIVO EN COLOMBIA</a:t>
             </a:r>
           </a:p>
           <a:p>
@@ -8155,7 +8155,7 @@
               </a:defRPr>
             </a:pPr>
             <a:r>
-              <a:t>Importado desde videos/motion_engine.js · Rubro: 4. ALCANCE SECTORIAL · TRANSPORTE AÉREO RAC 3</a:t>
+              <a:t>Reglamentos Aeronáuticos de Colombia (RAC 3 Aerocivil)</a:t>
             </a:r>
           </a:p>
           <a:p>
@@ -8320,7 +8320,7 @@
               </a:defRPr>
             </a:pPr>
             <a:r>
-              <a:t>DIAPOSITIVA 8 DE 10 · 07:45 – 08:45 (60s)   |   5. PROPUESTA DE VALOR Y BENCHMARK EN COLOMBIA</a:t>
+              <a:t>DIAPOSITIVA 8 DE 10   |   5. PROPUESTA DE VALOR Y BENCHMARK EN COLOMBIA</a:t>
             </a:r>
           </a:p>
         </p:txBody>
@@ -8652,7 +8652,7 @@
               </a:defRPr>
             </a:pPr>
             <a:r>
-              <a:t>ARTEFACTO INTERACTIVO: BENCHMARK_MATRIX</a:t>
+              <a:t>FUNDAMENTO NORMATIVO EN COLOMBIA</a:t>
             </a:r>
           </a:p>
           <a:p>
@@ -8665,7 +8665,7 @@
               </a:defRPr>
             </a:pPr>
             <a:r>
-              <a:t>Importado desde videos/motion_engine.js · Rubro: 5. PROPUESTA DE VALOR Y BENCHMARK EN COLOMBIA</a:t>
+              <a:t>Efectividad Vinculante frente al Emisor Financiero</a:t>
             </a:r>
           </a:p>
           <a:p>
@@ -8830,7 +8830,7 @@
               </a:defRPr>
             </a:pPr>
             <a:r>
-              <a:t>DIAPOSITIVA 9 DE 10 · 08:45 – 09:30 (45s)   |   6. MODELO DE NEGOCIO</a:t>
+              <a:t>DIAPOSITIVA 9 DE 10   |   6. MODELO DE NEGOCIO</a:t>
             </a:r>
           </a:p>
         </p:txBody>
@@ -9162,7 +9162,7 @@
               </a:defRPr>
             </a:pPr>
             <a:r>
-              <a:t>ARTEFACTO INTERACTIVO: PRICING_TIERS</a:t>
+              <a:t>FUNDAMENTO NORMATIVO EN COLOMBIA</a:t>
             </a:r>
           </a:p>
           <a:p>
@@ -9175,7 +9175,7 @@
               </a:defRPr>
             </a:pPr>
             <a:r>
-              <a:t>Importado desde videos/motion_engine.js · Rubro: 6. MODELO DE NEGOCIO</a:t>
+              <a:t>Sostenibilidad B2C ($0 / $19.900 COP) y Cumplimiento B2B</a:t>
             </a:r>
           </a:p>
           <a:p>

</xml_diff>

<commit_message>
Remove Fuentes Primarias Verificadas section and all SHA-256 hash features and references
</commit_message>
<xml_diff>
--- a/ReversoYa_Presentacion_10Minutos.pptx
+++ b/ReversoYa_Presentacion_10Minutos.pptx
@@ -861,7 +861,7 @@
           <a:lstStyle/>
           <a:p>
             <a:r>
-              <a:t>En la Pantalla 1 el usuario valida cuántos de los 5 días hábiles le quedan, y en la Pantalla 2 analiza la respuesta del vendedor en WhatsApp y certifica los soportes con huella SHA-256 conforme a la Ley 527 de 1999.</a:t>
+              <a:t>En la Pantalla 1 el usuario valida cuántos de los 5 días hábiles le quedan, y en la Pantalla 2 analiza la respuesta del vendedor en WhatsApp e incorpora los mensajes de datos conforme a la Ley 527 de 1999.</a:t>
             </a:r>
           </a:p>
         </p:txBody>
@@ -7043,7 +7043,7 @@
               </a:defRPr>
             </a:pPr>
             <a:r>
-              <a:t>Calcula la huella criptográfica SHA-256 de los comprobantes y capturas de pantalla para el anexo probatorio.</a:t>
+              <a:t>Incorpora los mensajes de datos y soportes de la transacción en el anexo probatorio del reclamo.</a:t>
             </a:r>
           </a:p>
         </p:txBody>

</xml_diff>